<commit_message>
Add attack-flow diagram slide (FW-relay intrusion → lateral movement, EDR blind spots)
- スライド10を追加: SoftEther/VPN Azureのリレー経由でF/Wを外向き接続で貫通する侵入フローを図示
- ①〜⑤の攻撃ステップと各段階のEDR可視/不可視(盲点)を1枚に可視化
- 以降のスライドを繰り下げ(全14スライド)、memory/context.md を更新

Co-Authored-By: Claude Opus 4.8 <noreply@anthropic.com>
Claude-Session: https://claude.ai/code/session_01EA4xD6dzVHyb75mdD2BWfh
</commit_message>
<xml_diff>
--- a/成果物/SentinelOne導入後も脆弱性検査が必要な理由.pptx
+++ b/成果物/SentinelOne導入後も脆弱性検査が必要な理由.pptx
@@ -18,9 +18,10 @@
     <p:sldId id="266" r:id="rId12"/>
     <p:sldId id="267" r:id="rId13"/>
     <p:sldId id="268" r:id="rId14"/>
+    <p:sldId id="269" r:id="rId15"/>
   </p:sldIdLst>
   <p:notesMasterIdLst>
-    <p:notesMasterId r:id="rId15"/>
+    <p:notesMasterId r:id="rId16"/>
   </p:notesMasterIdLst>
   <p:sldSz cx="12192000" cy="6858000"/>
   <p:notesSz cx="6858000" cy="12192000"/>
@@ -1154,6 +1155,94 @@
             <a:fld id="{F7021451-1387-4CA6-816F-3879F97B5CBC}" type="slidenum">
               <a:rPr lang="en-US"/>
               <a:t>13</a:t>
+            </a:fld>
+            <a:endParaRPr lang="en-US"/>
+          </a:p>
+        </p:txBody>
+      </p:sp>
+    </p:spTree>
+    <p:extLst>
+      <p:ext uri="{BB962C8B-B14F-4D97-AF65-F5344CB8AC3E}">
+        <p14:creationId xmlns:p14="http://schemas.microsoft.com/office/powerpoint/2010/main" val="1024086991"/>
+      </p:ext>
+    </p:extLst>
+  </p:cSld>
+  <p:clrMapOvr>
+    <a:masterClrMapping/>
+  </p:clrMapOvr>
+</p:notes>
+</file>
+
+<file path=ppt/notesSlides/notesSlide14.xml><?xml version="1.0" encoding="utf-8"?>
+<p:notes xmlns:a="http://schemas.openxmlformats.org/drawingml/2006/main" xmlns:r="http://schemas.openxmlformats.org/officeDocument/2006/relationships" xmlns:p="http://schemas.openxmlformats.org/presentationml/2006/main">
+  <p:cSld>
+    <p:spTree>
+      <p:nvGrpSpPr>
+        <p:cNvPr id="1" name=""/>
+        <p:cNvGrpSpPr/>
+        <p:nvPr/>
+      </p:nvGrpSpPr>
+      <p:grpSpPr>
+        <a:xfrm>
+          <a:off x="0" y="0"/>
+          <a:ext cx="0" cy="0"/>
+          <a:chOff x="0" y="0"/>
+          <a:chExt cx="0" cy="0"/>
+        </a:xfrm>
+      </p:grpSpPr>
+      <p:sp>
+        <p:nvSpPr>
+          <p:cNvPr id="2" name="Slide Image Placeholder 1"/>
+          <p:cNvSpPr>
+            <a:spLocks noGrp="1" noRot="1" noChangeAspect="1"/>
+          </p:cNvSpPr>
+          <p:nvPr>
+            <p:ph type="sldImg"/>
+          </p:nvPr>
+        </p:nvSpPr>
+        <p:spPr/>
+      </p:sp>
+      <p:sp>
+        <p:nvSpPr>
+          <p:cNvPr id="3" name="Notes Placeholder 2"/>
+          <p:cNvSpPr>
+            <a:spLocks noGrp="1"/>
+          </p:cNvSpPr>
+          <p:nvPr>
+            <p:ph type="body" idx="1"/>
+          </p:nvPr>
+        </p:nvSpPr>
+        <p:spPr/>
+        <p:txBody>
+          <a:bodyPr/>
+          <a:lstStyle/>
+          <a:p>
+            <a:r>
+              <a:rPr lang="en-US" dirty="0"/>
+              <a:t/>
+            </a:r>
+            <a:endParaRPr lang="en-US" dirty="0"/>
+          </a:p>
+        </p:txBody>
+      </p:sp>
+      <p:sp>
+        <p:nvSpPr>
+          <p:cNvPr id="4" name="Slide Number Placeholder 3"/>
+          <p:cNvSpPr>
+            <a:spLocks noGrp="1"/>
+          </p:cNvSpPr>
+          <p:nvPr>
+            <p:ph type="sldNum" sz="quarter" idx="10"/>
+          </p:nvPr>
+        </p:nvSpPr>
+        <p:spPr/>
+        <p:txBody>
+          <a:bodyPr/>
+          <a:lstStyle/>
+          <a:p>
+            <a:fld id="{F7021451-1387-4CA6-816F-3879F97B5CBC}" type="slidenum">
+              <a:rPr lang="en-US"/>
+              <a:t>14</a:t>
             </a:fld>
             <a:endParaRPr lang="en-US"/>
           </a:p>
@@ -2518,7 +2607,7 @@
                 <a:ea typeface="Calibri" pitchFamily="34" charset="-122"/>
                 <a:cs typeface="Calibri" pitchFamily="34" charset="-120"/>
               </a:rPr>
-              <a:t>あるべき考え方</a:t>
+              <a:t>事例に学ぶ攻撃フロー（VPNエッジ編）</a:t>
             </a:r>
             <a:endParaRPr lang="en-US" sz="1200" dirty="0"/>
           </a:p>
@@ -2557,7 +2646,7 @@
                 <a:ea typeface="Cambria" pitchFamily="34" charset="-122"/>
                 <a:cs typeface="Cambria" pitchFamily="34" charset="-120"/>
               </a:rPr>
-              <a:t>脆弱性検査とEDRは「補完関係」― 多層で守る</a:t>
+              <a:t>EDRの盲点：F/W越しの侵入 → ラテラルムーブメント</a:t>
             </a:r>
             <a:endParaRPr lang="en-US" sz="3200" dirty="0"/>
           </a:p>
@@ -2565,14 +2654,340 @@
       </p:sp>
       <p:sp>
         <p:nvSpPr>
-          <p:cNvPr id="4" name="Shape 2"/>
-          <p:cNvSpPr/>
-          <p:nvPr/>
-        </p:nvSpPr>
-        <p:spPr>
-          <a:xfrm>
-            <a:off x="566928" y="2011680"/>
-            <a:ext cx="7498080" cy="1097280"/>
+          <p:cNvPr id="4" name="Text 2"/>
+          <p:cNvSpPr/>
+          <p:nvPr/>
+        </p:nvSpPr>
+        <p:spPr>
+          <a:xfrm>
+            <a:off x="384048" y="1572768"/>
+            <a:ext cx="1828800" cy="274320"/>
+          </a:xfrm>
+          <a:prstGeom prst="rect">
+            <a:avLst/>
+          </a:prstGeom>
+          <a:noFill/>
+          <a:ln/>
+        </p:spPr>
+        <p:txBody>
+          <a:bodyPr wrap="square" lIns="0" tIns="0" rIns="0" bIns="0" rtlCol="0" anchor="ctr"/>
+          <a:lstStyle/>
+          <a:p>
+            <a:pPr indent="0" marL="0">
+              <a:buNone/>
+            </a:pPr>
+            <a:r>
+              <a:rPr lang="en-US" sz="1200" b="1" dirty="0">
+                <a:solidFill>
+                  <a:srgbClr val="68738A"/>
+                </a:solidFill>
+                <a:latin typeface="Calibri" pitchFamily="34" charset="0"/>
+                <a:ea typeface="Calibri" pitchFamily="34" charset="-122"/>
+                <a:cs typeface="Calibri" pitchFamily="34" charset="-120"/>
+              </a:rPr>
+              <a:t>インターネット</a:t>
+            </a:r>
+            <a:endParaRPr lang="en-US" sz="1200" dirty="0"/>
+          </a:p>
+        </p:txBody>
+      </p:sp>
+      <p:sp>
+        <p:nvSpPr>
+          <p:cNvPr id="5" name="Text 3"/>
+          <p:cNvSpPr/>
+          <p:nvPr/>
+        </p:nvSpPr>
+        <p:spPr>
+          <a:xfrm>
+            <a:off x="2468880" y="1572768"/>
+            <a:ext cx="2286000" cy="274320"/>
+          </a:xfrm>
+          <a:prstGeom prst="rect">
+            <a:avLst/>
+          </a:prstGeom>
+          <a:noFill/>
+          <a:ln/>
+        </p:spPr>
+        <p:txBody>
+          <a:bodyPr wrap="square" lIns="0" tIns="0" rIns="0" bIns="0" rtlCol="0" anchor="ctr"/>
+          <a:lstStyle/>
+          <a:p>
+            <a:pPr indent="0" marL="0">
+              <a:buNone/>
+            </a:pPr>
+            <a:r>
+              <a:rPr lang="en-US" sz="1200" b="1" dirty="0">
+                <a:solidFill>
+                  <a:srgbClr val="68738A"/>
+                </a:solidFill>
+                <a:latin typeface="Calibri" pitchFamily="34" charset="0"/>
+                <a:ea typeface="Calibri" pitchFamily="34" charset="-122"/>
+                <a:cs typeface="Calibri" pitchFamily="34" charset="-120"/>
+              </a:rPr>
+              <a:t>リレー（VPN Azure）</a:t>
+            </a:r>
+            <a:endParaRPr lang="en-US" sz="1200" dirty="0"/>
+          </a:p>
+        </p:txBody>
+      </p:sp>
+      <p:sp>
+        <p:nvSpPr>
+          <p:cNvPr id="6" name="Shape 4"/>
+          <p:cNvSpPr/>
+          <p:nvPr/>
+        </p:nvSpPr>
+        <p:spPr>
+          <a:xfrm>
+            <a:off x="4846320" y="1463040"/>
+            <a:ext cx="6903720" cy="2560320"/>
+          </a:xfrm>
+          <a:prstGeom prst="roundRect">
+            <a:avLst>
+              <a:gd name="adj" fmla="val 3214"/>
+            </a:avLst>
+          </a:prstGeom>
+          <a:solidFill>
+            <a:srgbClr val="F7F9FD"/>
+          </a:solidFill>
+          <a:ln w="12700">
+            <a:solidFill>
+              <a:srgbClr val="E2E8F4"/>
+            </a:solidFill>
+            <a:prstDash val="solid"/>
+          </a:ln>
+        </p:spPr>
+      </p:sp>
+      <p:sp>
+        <p:nvSpPr>
+          <p:cNvPr id="7" name="Text 5"/>
+          <p:cNvSpPr/>
+          <p:nvPr/>
+        </p:nvSpPr>
+        <p:spPr>
+          <a:xfrm>
+            <a:off x="5897880" y="1536192"/>
+            <a:ext cx="5669280" cy="292608"/>
+          </a:xfrm>
+          <a:prstGeom prst="rect">
+            <a:avLst/>
+          </a:prstGeom>
+          <a:noFill/>
+          <a:ln/>
+        </p:spPr>
+        <p:txBody>
+          <a:bodyPr wrap="square" lIns="0" tIns="0" rIns="0" bIns="0" rtlCol="0" anchor="ctr"/>
+          <a:lstStyle/>
+          <a:p>
+            <a:pPr indent="0" marL="0">
+              <a:buNone/>
+            </a:pPr>
+            <a:r>
+              <a:rPr lang="en-US" sz="1200" b="1" dirty="0">
+                <a:solidFill>
+                  <a:srgbClr val="0E1B3D"/>
+                </a:solidFill>
+                <a:latin typeface="Calibri" pitchFamily="34" charset="0"/>
+                <a:ea typeface="Calibri" pitchFamily="34" charset="-122"/>
+                <a:cs typeface="Calibri" pitchFamily="34" charset="-120"/>
+              </a:rPr>
+              <a:t>社内ネットワーク（LAN・EDR導入済み）</a:t>
+            </a:r>
+            <a:endParaRPr lang="en-US" sz="1200" dirty="0"/>
+          </a:p>
+        </p:txBody>
+      </p:sp>
+      <p:sp>
+        <p:nvSpPr>
+          <p:cNvPr id="8" name="Shape 6"/>
+          <p:cNvSpPr/>
+          <p:nvPr/>
+        </p:nvSpPr>
+        <p:spPr>
+          <a:xfrm>
+            <a:off x="457200" y="2240280"/>
+            <a:ext cx="1691640" cy="960120"/>
+          </a:xfrm>
+          <a:prstGeom prst="roundRect">
+            <a:avLst>
+              <a:gd name="adj" fmla="val 7619"/>
+            </a:avLst>
+          </a:prstGeom>
+          <a:solidFill>
+            <a:srgbClr val="C8102E"/>
+          </a:solidFill>
+          <a:ln/>
+          <a:effectLst>
+            <a:outerShdw sx="100000" sy="100000" kx="0" ky="0" algn="bl" rotWithShape="0" blurRad="101600" dist="38100" dir="5400000">
+              <a:srgbClr val="8A93A6">
+                <a:alpha val="28000"/>
+              </a:srgbClr>
+            </a:outerShdw>
+          </a:effectLst>
+        </p:spPr>
+      </p:sp>
+      <p:sp>
+        <p:nvSpPr>
+          <p:cNvPr id="9" name="Text 7"/>
+          <p:cNvSpPr/>
+          <p:nvPr/>
+        </p:nvSpPr>
+        <p:spPr>
+          <a:xfrm>
+            <a:off x="457200" y="2240280"/>
+            <a:ext cx="1691640" cy="960120"/>
+          </a:xfrm>
+          <a:prstGeom prst="rect">
+            <a:avLst/>
+          </a:prstGeom>
+          <a:noFill/>
+          <a:ln/>
+        </p:spPr>
+        <p:txBody>
+          <a:bodyPr wrap="square" lIns="0" tIns="0" rIns="0" bIns="0" rtlCol="0" anchor="ctr"/>
+          <a:lstStyle/>
+          <a:p>
+            <a:pPr algn="ctr" indent="0" marL="0">
+              <a:lnSpc>
+                <a:spcPts val="1700"/>
+              </a:lnSpc>
+              <a:buNone/>
+            </a:pPr>
+            <a:r>
+              <a:rPr lang="en-US" sz="1300" b="1" dirty="0">
+                <a:solidFill>
+                  <a:srgbClr val="FFFFFF"/>
+                </a:solidFill>
+                <a:latin typeface="Cambria" pitchFamily="34" charset="0"/>
+                <a:ea typeface="Cambria" pitchFamily="34" charset="-122"/>
+                <a:cs typeface="Cambria" pitchFamily="34" charset="-120"/>
+              </a:rPr>
+              <a:t>攻撃者</a:t>
+            </a:r>
+            <a:endParaRPr lang="en-US" sz="1300" dirty="0"/>
+          </a:p>
+          <a:p>
+            <a:pPr algn="ctr" indent="0" marL="0">
+              <a:lnSpc>
+                <a:spcPts val="1700"/>
+              </a:lnSpc>
+              <a:buNone/>
+            </a:pPr>
+            <a:r>
+              <a:rPr lang="en-US" sz="1300" b="1" dirty="0">
+                <a:solidFill>
+                  <a:srgbClr val="FFFFFF"/>
+                </a:solidFill>
+                <a:latin typeface="Cambria" pitchFamily="34" charset="0"/>
+                <a:ea typeface="Cambria" pitchFamily="34" charset="-122"/>
+                <a:cs typeface="Cambria" pitchFamily="34" charset="-120"/>
+              </a:rPr>
+              <a:t>（社外）</a:t>
+            </a:r>
+            <a:endParaRPr lang="en-US" sz="1300" dirty="0"/>
+          </a:p>
+        </p:txBody>
+      </p:sp>
+      <p:sp>
+        <p:nvSpPr>
+          <p:cNvPr id="10" name="Shape 8"/>
+          <p:cNvSpPr/>
+          <p:nvPr/>
+        </p:nvSpPr>
+        <p:spPr>
+          <a:xfrm>
+            <a:off x="2468880" y="2286000"/>
+            <a:ext cx="2194560" cy="868680"/>
+          </a:xfrm>
+          <a:prstGeom prst="roundRect">
+            <a:avLst>
+              <a:gd name="adj" fmla="val 14737"/>
+            </a:avLst>
+          </a:prstGeom>
+          <a:solidFill>
+            <a:srgbClr val="3E5C76"/>
+          </a:solidFill>
+          <a:ln/>
+          <a:effectLst>
+            <a:outerShdw sx="100000" sy="100000" kx="0" ky="0" algn="bl" rotWithShape="0" blurRad="101600" dist="38100" dir="5400000">
+              <a:srgbClr val="8A93A6">
+                <a:alpha val="28000"/>
+              </a:srgbClr>
+            </a:outerShdw>
+          </a:effectLst>
+        </p:spPr>
+      </p:sp>
+      <p:sp>
+        <p:nvSpPr>
+          <p:cNvPr id="11" name="Text 9"/>
+          <p:cNvSpPr/>
+          <p:nvPr/>
+        </p:nvSpPr>
+        <p:spPr>
+          <a:xfrm>
+            <a:off x="2468880" y="2286000"/>
+            <a:ext cx="2194560" cy="868680"/>
+          </a:xfrm>
+          <a:prstGeom prst="rect">
+            <a:avLst/>
+          </a:prstGeom>
+          <a:noFill/>
+          <a:ln/>
+        </p:spPr>
+        <p:txBody>
+          <a:bodyPr wrap="square" lIns="0" tIns="0" rIns="0" bIns="0" rtlCol="0" anchor="ctr"/>
+          <a:lstStyle/>
+          <a:p>
+            <a:pPr algn="ctr" indent="0" marL="0">
+              <a:lnSpc>
+                <a:spcPts val="1600"/>
+              </a:lnSpc>
+              <a:buNone/>
+            </a:pPr>
+            <a:r>
+              <a:rPr lang="en-US" sz="1150" b="1" dirty="0">
+                <a:solidFill>
+                  <a:srgbClr val="FFFFFF"/>
+                </a:solidFill>
+                <a:latin typeface="Calibri" pitchFamily="34" charset="0"/>
+                <a:ea typeface="Calibri" pitchFamily="34" charset="-122"/>
+                <a:cs typeface="Calibri" pitchFamily="34" charset="-120"/>
+              </a:rPr>
+              <a:t>VPN Azure リレー</a:t>
+            </a:r>
+            <a:endParaRPr lang="en-US" sz="1150" dirty="0"/>
+          </a:p>
+          <a:p>
+            <a:pPr algn="ctr" indent="0" marL="0">
+              <a:lnSpc>
+                <a:spcPts val="1600"/>
+              </a:lnSpc>
+              <a:buNone/>
+            </a:pPr>
+            <a:r>
+              <a:rPr lang="en-US" sz="1150" b="1" dirty="0">
+                <a:solidFill>
+                  <a:srgbClr val="FFFFFF"/>
+                </a:solidFill>
+                <a:latin typeface="Calibri" pitchFamily="34" charset="0"/>
+                <a:ea typeface="Calibri" pitchFamily="34" charset="-122"/>
+                <a:cs typeface="Calibri" pitchFamily="34" charset="-120"/>
+              </a:rPr>
+              <a:t>*.vpnazure.net</a:t>
+            </a:r>
+            <a:endParaRPr lang="en-US" sz="1150" dirty="0"/>
+          </a:p>
+        </p:txBody>
+      </p:sp>
+      <p:sp>
+        <p:nvSpPr>
+          <p:cNvPr id="12" name="Shape 10"/>
+          <p:cNvSpPr/>
+          <p:nvPr/>
+        </p:nvSpPr>
+        <p:spPr>
+          <a:xfrm>
+            <a:off x="4864608" y="1901952"/>
+            <a:ext cx="822960" cy="1773936"/>
           </a:xfrm>
           <a:prstGeom prst="roundRect">
             <a:avLst>
@@ -2580,9 +2995,186 @@
             </a:avLst>
           </a:prstGeom>
           <a:solidFill>
-            <a:srgbClr val="F4F6FB"/>
+            <a:srgbClr val="0E1B3D"/>
           </a:solidFill>
-          <a:ln w="12700">
+          <a:ln/>
+        </p:spPr>
+      </p:sp>
+      <p:sp>
+        <p:nvSpPr>
+          <p:cNvPr id="13" name="Text 11"/>
+          <p:cNvSpPr/>
+          <p:nvPr/>
+        </p:nvSpPr>
+        <p:spPr>
+          <a:xfrm>
+            <a:off x="4864608" y="1956816"/>
+            <a:ext cx="822960" cy="365760"/>
+          </a:xfrm>
+          <a:prstGeom prst="rect">
+            <a:avLst/>
+          </a:prstGeom>
+          <a:noFill/>
+          <a:ln/>
+        </p:spPr>
+        <p:txBody>
+          <a:bodyPr wrap="square" lIns="0" tIns="0" rIns="0" bIns="0" rtlCol="0" anchor="ctr"/>
+          <a:lstStyle/>
+          <a:p>
+            <a:pPr algn="ctr" indent="0" marL="0">
+              <a:buNone/>
+            </a:pPr>
+            <a:r>
+              <a:rPr lang="en-US" sz="1400" b="1" dirty="0">
+                <a:solidFill>
+                  <a:srgbClr val="FFFFFF"/>
+                </a:solidFill>
+                <a:latin typeface="Cambria" pitchFamily="34" charset="0"/>
+                <a:ea typeface="Cambria" pitchFamily="34" charset="-122"/>
+                <a:cs typeface="Cambria" pitchFamily="34" charset="-120"/>
+              </a:rPr>
+              <a:t>F/W</a:t>
+            </a:r>
+            <a:endParaRPr lang="en-US" sz="1400" dirty="0"/>
+          </a:p>
+        </p:txBody>
+      </p:sp>
+      <p:sp>
+        <p:nvSpPr>
+          <p:cNvPr id="14" name="Shape 12"/>
+          <p:cNvSpPr/>
+          <p:nvPr/>
+        </p:nvSpPr>
+        <p:spPr>
+          <a:xfrm>
+            <a:off x="5897880" y="2331720"/>
+            <a:ext cx="1874520" cy="914400"/>
+          </a:xfrm>
+          <a:prstGeom prst="roundRect">
+            <a:avLst>
+              <a:gd name="adj" fmla="val 8000"/>
+            </a:avLst>
+          </a:prstGeom>
+          <a:solidFill>
+            <a:srgbClr val="FBEDEF"/>
+          </a:solidFill>
+          <a:ln w="19050">
+            <a:solidFill>
+              <a:srgbClr val="8E0B20"/>
+            </a:solidFill>
+            <a:prstDash val="solid"/>
+          </a:ln>
+          <a:effectLst>
+            <a:outerShdw sx="100000" sy="100000" kx="0" ky="0" algn="bl" rotWithShape="0" blurRad="101600" dist="38100" dir="5400000">
+              <a:srgbClr val="8A93A6">
+                <a:alpha val="28000"/>
+              </a:srgbClr>
+            </a:outerShdw>
+          </a:effectLst>
+        </p:spPr>
+      </p:sp>
+      <p:sp>
+        <p:nvSpPr>
+          <p:cNvPr id="15" name="Text 13"/>
+          <p:cNvSpPr/>
+          <p:nvPr/>
+        </p:nvSpPr>
+        <p:spPr>
+          <a:xfrm>
+            <a:off x="5897880" y="2286000"/>
+            <a:ext cx="1874520" cy="777240"/>
+          </a:xfrm>
+          <a:prstGeom prst="rect">
+            <a:avLst/>
+          </a:prstGeom>
+          <a:noFill/>
+          <a:ln/>
+        </p:spPr>
+        <p:txBody>
+          <a:bodyPr wrap="square" lIns="0" tIns="0" rIns="0" bIns="0" rtlCol="0" anchor="t"/>
+          <a:lstStyle/>
+          <a:p>
+            <a:pPr algn="ctr" indent="0" marL="0">
+              <a:lnSpc>
+                <a:spcPts val="1400"/>
+              </a:lnSpc>
+              <a:buNone/>
+            </a:pPr>
+            <a:r>
+              <a:rPr lang="en-US" sz="1100" b="1" dirty="0">
+                <a:solidFill>
+                  <a:srgbClr val="0E1B3D"/>
+                </a:solidFill>
+                <a:latin typeface="Cambria" pitchFamily="34" charset="0"/>
+                <a:ea typeface="Cambria" pitchFamily="34" charset="-122"/>
+                <a:cs typeface="Cambria" pitchFamily="34" charset="-120"/>
+              </a:rPr>
+              <a:t>SoftEther</a:t>
+            </a:r>
+            <a:endParaRPr lang="en-US" sz="1100" dirty="0"/>
+          </a:p>
+          <a:p>
+            <a:pPr algn="ctr" indent="0" marL="0">
+              <a:lnSpc>
+                <a:spcPts val="1400"/>
+              </a:lnSpc>
+              <a:buNone/>
+            </a:pPr>
+            <a:r>
+              <a:rPr lang="en-US" sz="1100" b="1" dirty="0">
+                <a:solidFill>
+                  <a:srgbClr val="0E1B3D"/>
+                </a:solidFill>
+                <a:latin typeface="Cambria" pitchFamily="34" charset="0"/>
+                <a:ea typeface="Cambria" pitchFamily="34" charset="-122"/>
+                <a:cs typeface="Cambria" pitchFamily="34" charset="-120"/>
+              </a:rPr>
+              <a:t>エッジノード</a:t>
+            </a:r>
+            <a:endParaRPr lang="en-US" sz="1100" dirty="0"/>
+          </a:p>
+          <a:p>
+            <a:pPr algn="ctr" indent="0" marL="0">
+              <a:lnSpc>
+                <a:spcPts val="1400"/>
+              </a:lnSpc>
+              <a:buNone/>
+            </a:pPr>
+            <a:r>
+              <a:rPr lang="en-US" sz="1100" b="1" dirty="0">
+                <a:solidFill>
+                  <a:srgbClr val="0E1B3D"/>
+                </a:solidFill>
+                <a:latin typeface="Cambria" pitchFamily="34" charset="0"/>
+                <a:ea typeface="Cambria" pitchFamily="34" charset="-122"/>
+                <a:cs typeface="Cambria" pitchFamily="34" charset="-120"/>
+              </a:rPr>
+              <a:t>（VPNサーバ）</a:t>
+            </a:r>
+            <a:endParaRPr lang="en-US" sz="1100" dirty="0"/>
+          </a:p>
+        </p:txBody>
+      </p:sp>
+      <p:sp>
+        <p:nvSpPr>
+          <p:cNvPr id="16" name="Shape 14"/>
+          <p:cNvSpPr/>
+          <p:nvPr/>
+        </p:nvSpPr>
+        <p:spPr>
+          <a:xfrm>
+            <a:off x="8001000" y="2331720"/>
+            <a:ext cx="1737360" cy="914400"/>
+          </a:xfrm>
+          <a:prstGeom prst="roundRect">
+            <a:avLst>
+              <a:gd name="adj" fmla="val 8000"/>
+            </a:avLst>
+          </a:prstGeom>
+          <a:solidFill>
+            <a:srgbClr val="FFFFFF"/>
+          </a:solidFill>
+          <a:ln w="19050">
             <a:solidFill>
               <a:srgbClr val="E2E8F4"/>
             </a:solidFill>
@@ -2599,177 +3191,65 @@
       </p:sp>
       <p:sp>
         <p:nvSpPr>
-          <p:cNvPr id="5" name="Shape 3"/>
-          <p:cNvSpPr/>
-          <p:nvPr/>
-        </p:nvSpPr>
-        <p:spPr>
-          <a:xfrm>
-            <a:off x="795528" y="2267712"/>
-            <a:ext cx="585216" cy="585216"/>
-          </a:xfrm>
-          <a:prstGeom prst="ellipse">
-            <a:avLst/>
-          </a:prstGeom>
-          <a:solidFill>
-            <a:srgbClr val="C8102E"/>
-          </a:solidFill>
-          <a:ln/>
-        </p:spPr>
-      </p:sp>
-      <p:sp>
-        <p:nvSpPr>
-          <p:cNvPr id="6" name="Text 4"/>
-          <p:cNvSpPr/>
-          <p:nvPr/>
-        </p:nvSpPr>
-        <p:spPr>
-          <a:xfrm>
-            <a:off x="795528" y="2267712"/>
-            <a:ext cx="585216" cy="585216"/>
-          </a:xfrm>
-          <a:prstGeom prst="rect">
-            <a:avLst/>
-          </a:prstGeom>
-          <a:noFill/>
-          <a:ln/>
-        </p:spPr>
-        <p:txBody>
-          <a:bodyPr wrap="square" lIns="0" tIns="0" rIns="0" bIns="0" rtlCol="0" anchor="ctr"/>
+          <p:cNvPr id="17" name="Text 15"/>
+          <p:cNvSpPr/>
+          <p:nvPr/>
+        </p:nvSpPr>
+        <p:spPr>
+          <a:xfrm>
+            <a:off x="8001000" y="2395728"/>
+            <a:ext cx="1737360" cy="457200"/>
+          </a:xfrm>
+          <a:prstGeom prst="rect">
+            <a:avLst/>
+          </a:prstGeom>
+          <a:noFill/>
+          <a:ln/>
+        </p:spPr>
+        <p:txBody>
+          <a:bodyPr wrap="square" lIns="0" tIns="0" rIns="0" bIns="0" rtlCol="0" anchor="t"/>
           <a:lstStyle/>
           <a:p>
             <a:pPr algn="ctr" indent="0" marL="0">
               <a:buNone/>
             </a:pPr>
             <a:r>
-              <a:rPr lang="en-US" sz="2200" b="1" dirty="0">
-                <a:solidFill>
-                  <a:srgbClr val="FFFFFF"/>
+              <a:rPr lang="en-US" sz="1200" b="1" dirty="0">
+                <a:solidFill>
+                  <a:srgbClr val="0E1B3D"/>
                 </a:solidFill>
                 <a:latin typeface="Cambria" pitchFamily="34" charset="0"/>
                 <a:ea typeface="Cambria" pitchFamily="34" charset="-122"/>
                 <a:cs typeface="Cambria" pitchFamily="34" charset="-120"/>
               </a:rPr>
-              <a:t>1</a:t>
-            </a:r>
-            <a:endParaRPr lang="en-US" sz="2200" dirty="0"/>
-          </a:p>
-        </p:txBody>
-      </p:sp>
-      <p:sp>
-        <p:nvSpPr>
-          <p:cNvPr id="7" name="Text 5"/>
-          <p:cNvSpPr/>
-          <p:nvPr/>
-        </p:nvSpPr>
-        <p:spPr>
-          <a:xfrm>
-            <a:off x="1572768" y="2157984"/>
-            <a:ext cx="6400800" cy="457200"/>
-          </a:xfrm>
-          <a:prstGeom prst="rect">
-            <a:avLst/>
-          </a:prstGeom>
-          <a:noFill/>
-          <a:ln/>
-        </p:spPr>
-        <p:txBody>
-          <a:bodyPr wrap="square" lIns="0" tIns="0" rIns="0" bIns="0" rtlCol="0" anchor="ctr"/>
-          <a:lstStyle/>
-          <a:p>
-            <a:pPr indent="0" marL="0">
-              <a:buNone/>
-            </a:pPr>
-            <a:r>
-              <a:rPr lang="en-US" sz="1700" b="1" dirty="0">
-                <a:solidFill>
-                  <a:srgbClr val="0E1B3D"/>
-                </a:solidFill>
-                <a:latin typeface="Cambria" pitchFamily="34" charset="0"/>
-                <a:ea typeface="Cambria" pitchFamily="34" charset="-122"/>
-                <a:cs typeface="Cambria" pitchFamily="34" charset="-120"/>
-              </a:rPr>
-              <a:t>入口を塞ぐ   </a:t>
-            </a:r>
-            <a:pPr indent="0" marL="0">
-              <a:buNone/>
-            </a:pPr>
-            <a:r>
-              <a:rPr lang="en-US" sz="1300" b="1" dirty="0">
-                <a:solidFill>
-                  <a:srgbClr val="C8102E"/>
-                </a:solidFill>
-                <a:latin typeface="Cambria" pitchFamily="34" charset="0"/>
-                <a:ea typeface="Cambria" pitchFamily="34" charset="-122"/>
-                <a:cs typeface="Cambria" pitchFamily="34" charset="-120"/>
-              </a:rPr>
-              <a:t>脆弱性検査・パッチ・認証強化(MFA)</a:t>
-            </a:r>
-            <a:endParaRPr lang="en-US" sz="1700" dirty="0"/>
-          </a:p>
-        </p:txBody>
-      </p:sp>
-      <p:sp>
-        <p:nvSpPr>
-          <p:cNvPr id="8" name="Text 6"/>
-          <p:cNvSpPr/>
-          <p:nvPr/>
-        </p:nvSpPr>
-        <p:spPr>
-          <a:xfrm>
-            <a:off x="1572768" y="2578608"/>
-            <a:ext cx="6400800" cy="457200"/>
-          </a:xfrm>
-          <a:prstGeom prst="rect">
-            <a:avLst/>
-          </a:prstGeom>
-          <a:noFill/>
-          <a:ln/>
-        </p:spPr>
-        <p:txBody>
-          <a:bodyPr wrap="square" lIns="0" tIns="0" rIns="0" bIns="0" rtlCol="0" anchor="t"/>
-          <a:lstStyle/>
-          <a:p>
-            <a:pPr indent="0" marL="0">
-              <a:buNone/>
-            </a:pPr>
-            <a:r>
-              <a:rPr lang="en-US" sz="1250" dirty="0">
-                <a:solidFill>
-                  <a:srgbClr val="1A2332"/>
-                </a:solidFill>
-                <a:latin typeface="Calibri" pitchFamily="34" charset="0"/>
-                <a:ea typeface="Calibri" pitchFamily="34" charset="-122"/>
-                <a:cs typeface="Calibri" pitchFamily="34" charset="-120"/>
-              </a:rPr>
-              <a:t>侵入・乗っ取りの起点を事前に潰す</a:t>
-            </a:r>
-            <a:endParaRPr lang="en-US" sz="1250" dirty="0"/>
-          </a:p>
-        </p:txBody>
-      </p:sp>
-      <p:sp>
-        <p:nvSpPr>
-          <p:cNvPr id="9" name="Shape 7"/>
-          <p:cNvSpPr/>
-          <p:nvPr/>
-        </p:nvSpPr>
-        <p:spPr>
-          <a:xfrm>
-            <a:off x="566928" y="3310128"/>
-            <a:ext cx="7498080" cy="1097280"/>
+              <a:t>業務サーバ群</a:t>
+            </a:r>
+            <a:endParaRPr lang="en-US" sz="1200" dirty="0"/>
+          </a:p>
+        </p:txBody>
+      </p:sp>
+      <p:sp>
+        <p:nvSpPr>
+          <p:cNvPr id="18" name="Shape 16"/>
+          <p:cNvSpPr/>
+          <p:nvPr/>
+        </p:nvSpPr>
+        <p:spPr>
+          <a:xfrm>
+            <a:off x="9921240" y="2331720"/>
+            <a:ext cx="1691640" cy="914400"/>
           </a:xfrm>
           <a:prstGeom prst="roundRect">
             <a:avLst>
-              <a:gd name="adj" fmla="val 6667"/>
+              <a:gd name="adj" fmla="val 8000"/>
             </a:avLst>
           </a:prstGeom>
           <a:solidFill>
-            <a:srgbClr val="F4F6FB"/>
+            <a:srgbClr val="FFFFFF"/>
           </a:solidFill>
-          <a:ln w="12700">
+          <a:ln w="19050">
             <a:solidFill>
-              <a:srgbClr val="E2E8F4"/>
+              <a:srgbClr val="C8102E"/>
             </a:solidFill>
             <a:prstDash val="solid"/>
           </a:ln>
@@ -2784,169 +3264,683 @@
       </p:sp>
       <p:sp>
         <p:nvSpPr>
-          <p:cNvPr id="10" name="Shape 8"/>
-          <p:cNvSpPr/>
-          <p:nvPr/>
-        </p:nvSpPr>
-        <p:spPr>
-          <a:xfrm>
-            <a:off x="795528" y="3566160"/>
-            <a:ext cx="585216" cy="585216"/>
-          </a:xfrm>
-          <a:prstGeom prst="ellipse">
-            <a:avLst/>
-          </a:prstGeom>
-          <a:solidFill>
-            <a:srgbClr val="3E5C76"/>
-          </a:solidFill>
-          <a:ln/>
-        </p:spPr>
-      </p:sp>
-      <p:sp>
-        <p:nvSpPr>
-          <p:cNvPr id="11" name="Text 9"/>
-          <p:cNvSpPr/>
-          <p:nvPr/>
-        </p:nvSpPr>
-        <p:spPr>
-          <a:xfrm>
-            <a:off x="795528" y="3566160"/>
-            <a:ext cx="585216" cy="585216"/>
-          </a:xfrm>
-          <a:prstGeom prst="rect">
-            <a:avLst/>
-          </a:prstGeom>
-          <a:noFill/>
-          <a:ln/>
-        </p:spPr>
-        <p:txBody>
-          <a:bodyPr wrap="square" lIns="0" tIns="0" rIns="0" bIns="0" rtlCol="0" anchor="ctr"/>
+          <p:cNvPr id="19" name="Text 17"/>
+          <p:cNvSpPr/>
+          <p:nvPr/>
+        </p:nvSpPr>
+        <p:spPr>
+          <a:xfrm>
+            <a:off x="9921240" y="2377440"/>
+            <a:ext cx="1691640" cy="822960"/>
+          </a:xfrm>
+          <a:prstGeom prst="rect">
+            <a:avLst/>
+          </a:prstGeom>
+          <a:noFill/>
+          <a:ln/>
+        </p:spPr>
+        <p:txBody>
+          <a:bodyPr wrap="square" lIns="0" tIns="0" rIns="0" bIns="0" rtlCol="0" anchor="t"/>
           <a:lstStyle/>
           <a:p>
             <a:pPr algn="ctr" indent="0" marL="0">
-              <a:buNone/>
-            </a:pPr>
-            <a:r>
-              <a:rPr lang="en-US" sz="2200" b="1" dirty="0">
-                <a:solidFill>
-                  <a:srgbClr val="FFFFFF"/>
+              <a:lnSpc>
+                <a:spcPts val="1400"/>
+              </a:lnSpc>
+              <a:buNone/>
+            </a:pPr>
+            <a:r>
+              <a:rPr lang="en-US" sz="1100" b="1" dirty="0">
+                <a:solidFill>
+                  <a:srgbClr val="8E0B20"/>
                 </a:solidFill>
                 <a:latin typeface="Cambria" pitchFamily="34" charset="0"/>
                 <a:ea typeface="Cambria" pitchFamily="34" charset="-122"/>
                 <a:cs typeface="Cambria" pitchFamily="34" charset="-120"/>
               </a:rPr>
-              <a:t>2</a:t>
-            </a:r>
-            <a:endParaRPr lang="en-US" sz="2200" dirty="0"/>
-          </a:p>
-        </p:txBody>
-      </p:sp>
-      <p:sp>
-        <p:nvSpPr>
-          <p:cNvPr id="12" name="Text 10"/>
-          <p:cNvSpPr/>
-          <p:nvPr/>
-        </p:nvSpPr>
-        <p:spPr>
-          <a:xfrm>
-            <a:off x="1572768" y="3456432"/>
-            <a:ext cx="6400800" cy="457200"/>
-          </a:xfrm>
-          <a:prstGeom prst="rect">
-            <a:avLst/>
-          </a:prstGeom>
-          <a:noFill/>
-          <a:ln/>
-        </p:spPr>
-        <p:txBody>
-          <a:bodyPr wrap="square" lIns="0" tIns="0" rIns="0" bIns="0" rtlCol="0" anchor="ctr"/>
-          <a:lstStyle/>
-          <a:p>
-            <a:pPr indent="0" marL="0">
-              <a:buNone/>
-            </a:pPr>
-            <a:r>
-              <a:rPr lang="en-US" sz="1700" b="1" dirty="0">
-                <a:solidFill>
-                  <a:srgbClr val="0E1B3D"/>
+              <a:t>AD サーバ</a:t>
+            </a:r>
+            <a:endParaRPr lang="en-US" sz="1100" dirty="0"/>
+          </a:p>
+          <a:p>
+            <a:pPr algn="ctr" indent="0" marL="0">
+              <a:lnSpc>
+                <a:spcPts val="1400"/>
+              </a:lnSpc>
+              <a:buNone/>
+            </a:pPr>
+            <a:r>
+              <a:rPr lang="en-US" sz="1100" b="1" dirty="0">
+                <a:solidFill>
+                  <a:srgbClr val="8E0B20"/>
                 </a:solidFill>
                 <a:latin typeface="Cambria" pitchFamily="34" charset="0"/>
                 <a:ea typeface="Cambria" pitchFamily="34" charset="-122"/>
                 <a:cs typeface="Cambria" pitchFamily="34" charset="-120"/>
               </a:rPr>
-              <a:t>内側で検知   </a:t>
-            </a:r>
-            <a:pPr indent="0" marL="0">
-              <a:buNone/>
-            </a:pPr>
-            <a:r>
-              <a:rPr lang="en-US" sz="1300" b="1" dirty="0">
-                <a:solidFill>
-                  <a:srgbClr val="3E5C76"/>
+              <a:t>（管理者権限を奪取）</a:t>
+            </a:r>
+            <a:endParaRPr lang="en-US" sz="1100" dirty="0"/>
+          </a:p>
+        </p:txBody>
+      </p:sp>
+      <p:sp>
+        <p:nvSpPr>
+          <p:cNvPr id="20" name="Shape 18"/>
+          <p:cNvSpPr/>
+          <p:nvPr/>
+        </p:nvSpPr>
+        <p:spPr>
+          <a:xfrm>
+            <a:off x="6510528" y="2926080"/>
+            <a:ext cx="658368" cy="256032"/>
+          </a:xfrm>
+          <a:prstGeom prst="roundRect">
+            <a:avLst>
+              <a:gd name="adj" fmla="val 17857"/>
+            </a:avLst>
+          </a:prstGeom>
+          <a:solidFill>
+            <a:srgbClr val="1E7A46"/>
+          </a:solidFill>
+          <a:ln/>
+        </p:spPr>
+      </p:sp>
+      <p:sp>
+        <p:nvSpPr>
+          <p:cNvPr id="21" name="Text 19"/>
+          <p:cNvSpPr/>
+          <p:nvPr/>
+        </p:nvSpPr>
+        <p:spPr>
+          <a:xfrm>
+            <a:off x="6510528" y="2926080"/>
+            <a:ext cx="658368" cy="256032"/>
+          </a:xfrm>
+          <a:prstGeom prst="rect">
+            <a:avLst/>
+          </a:prstGeom>
+          <a:noFill/>
+          <a:ln/>
+        </p:spPr>
+        <p:txBody>
+          <a:bodyPr wrap="square" lIns="0" tIns="0" rIns="0" bIns="0" rtlCol="0" anchor="ctr"/>
+          <a:lstStyle/>
+          <a:p>
+            <a:pPr algn="ctr" indent="0" marL="0">
+              <a:buNone/>
+            </a:pPr>
+            <a:r>
+              <a:rPr lang="en-US" sz="900" b="1" dirty="0">
+                <a:solidFill>
+                  <a:srgbClr val="FFFFFF"/>
+                </a:solidFill>
+                <a:latin typeface="Calibri" pitchFamily="34" charset="0"/>
+                <a:ea typeface="Calibri" pitchFamily="34" charset="-122"/>
+                <a:cs typeface="Calibri" pitchFamily="34" charset="-120"/>
+              </a:rPr>
+              <a:t>EDR</a:t>
+            </a:r>
+            <a:endParaRPr lang="en-US" sz="900" dirty="0"/>
+          </a:p>
+        </p:txBody>
+      </p:sp>
+      <p:sp>
+        <p:nvSpPr>
+          <p:cNvPr id="22" name="Shape 20"/>
+          <p:cNvSpPr/>
+          <p:nvPr/>
+        </p:nvSpPr>
+        <p:spPr>
+          <a:xfrm>
+            <a:off x="8540496" y="2926080"/>
+            <a:ext cx="658368" cy="256032"/>
+          </a:xfrm>
+          <a:prstGeom prst="roundRect">
+            <a:avLst>
+              <a:gd name="adj" fmla="val 17857"/>
+            </a:avLst>
+          </a:prstGeom>
+          <a:solidFill>
+            <a:srgbClr val="1E7A46"/>
+          </a:solidFill>
+          <a:ln/>
+        </p:spPr>
+      </p:sp>
+      <p:sp>
+        <p:nvSpPr>
+          <p:cNvPr id="23" name="Text 21"/>
+          <p:cNvSpPr/>
+          <p:nvPr/>
+        </p:nvSpPr>
+        <p:spPr>
+          <a:xfrm>
+            <a:off x="8540496" y="2926080"/>
+            <a:ext cx="658368" cy="256032"/>
+          </a:xfrm>
+          <a:prstGeom prst="rect">
+            <a:avLst/>
+          </a:prstGeom>
+          <a:noFill/>
+          <a:ln/>
+        </p:spPr>
+        <p:txBody>
+          <a:bodyPr wrap="square" lIns="0" tIns="0" rIns="0" bIns="0" rtlCol="0" anchor="ctr"/>
+          <a:lstStyle/>
+          <a:p>
+            <a:pPr algn="ctr" indent="0" marL="0">
+              <a:buNone/>
+            </a:pPr>
+            <a:r>
+              <a:rPr lang="en-US" sz="900" b="1" dirty="0">
+                <a:solidFill>
+                  <a:srgbClr val="FFFFFF"/>
+                </a:solidFill>
+                <a:latin typeface="Calibri" pitchFamily="34" charset="0"/>
+                <a:ea typeface="Calibri" pitchFamily="34" charset="-122"/>
+                <a:cs typeface="Calibri" pitchFamily="34" charset="-120"/>
+              </a:rPr>
+              <a:t>EDR</a:t>
+            </a:r>
+            <a:endParaRPr lang="en-US" sz="900" dirty="0"/>
+          </a:p>
+        </p:txBody>
+      </p:sp>
+      <p:sp>
+        <p:nvSpPr>
+          <p:cNvPr id="24" name="Shape 22"/>
+          <p:cNvSpPr/>
+          <p:nvPr/>
+        </p:nvSpPr>
+        <p:spPr>
+          <a:xfrm>
+            <a:off x="10442448" y="2926080"/>
+            <a:ext cx="658368" cy="256032"/>
+          </a:xfrm>
+          <a:prstGeom prst="roundRect">
+            <a:avLst>
+              <a:gd name="adj" fmla="val 17857"/>
+            </a:avLst>
+          </a:prstGeom>
+          <a:solidFill>
+            <a:srgbClr val="1E7A46"/>
+          </a:solidFill>
+          <a:ln/>
+        </p:spPr>
+      </p:sp>
+      <p:sp>
+        <p:nvSpPr>
+          <p:cNvPr id="25" name="Text 23"/>
+          <p:cNvSpPr/>
+          <p:nvPr/>
+        </p:nvSpPr>
+        <p:spPr>
+          <a:xfrm>
+            <a:off x="10442448" y="2926080"/>
+            <a:ext cx="658368" cy="256032"/>
+          </a:xfrm>
+          <a:prstGeom prst="rect">
+            <a:avLst/>
+          </a:prstGeom>
+          <a:noFill/>
+          <a:ln/>
+        </p:spPr>
+        <p:txBody>
+          <a:bodyPr wrap="square" lIns="0" tIns="0" rIns="0" bIns="0" rtlCol="0" anchor="ctr"/>
+          <a:lstStyle/>
+          <a:p>
+            <a:pPr algn="ctr" indent="0" marL="0">
+              <a:buNone/>
+            </a:pPr>
+            <a:r>
+              <a:rPr lang="en-US" sz="900" b="1" dirty="0">
+                <a:solidFill>
+                  <a:srgbClr val="FFFFFF"/>
+                </a:solidFill>
+                <a:latin typeface="Calibri" pitchFamily="34" charset="0"/>
+                <a:ea typeface="Calibri" pitchFamily="34" charset="-122"/>
+                <a:cs typeface="Calibri" pitchFamily="34" charset="-120"/>
+              </a:rPr>
+              <a:t>EDR</a:t>
+            </a:r>
+            <a:endParaRPr lang="en-US" sz="900" dirty="0"/>
+          </a:p>
+        </p:txBody>
+      </p:sp>
+      <p:sp>
+        <p:nvSpPr>
+          <p:cNvPr id="26" name="Shape 24"/>
+          <p:cNvSpPr/>
+          <p:nvPr/>
+        </p:nvSpPr>
+        <p:spPr>
+          <a:xfrm>
+            <a:off x="2167128" y="2615184"/>
+            <a:ext cx="274320" cy="256032"/>
+          </a:xfrm>
+          <a:prstGeom prst="rightArrow">
+            <a:avLst/>
+          </a:prstGeom>
+          <a:solidFill>
+            <a:srgbClr val="C8102E"/>
+          </a:solidFill>
+          <a:ln/>
+        </p:spPr>
+      </p:sp>
+      <p:sp>
+        <p:nvSpPr>
+          <p:cNvPr id="27" name="Shape 25"/>
+          <p:cNvSpPr/>
+          <p:nvPr/>
+        </p:nvSpPr>
+        <p:spPr>
+          <a:xfrm>
+            <a:off x="4690872" y="2468880"/>
+            <a:ext cx="1170432" cy="274320"/>
+          </a:xfrm>
+          <a:prstGeom prst="rightArrow">
+            <a:avLst/>
+          </a:prstGeom>
+          <a:solidFill>
+            <a:srgbClr val="C8102E"/>
+          </a:solidFill>
+          <a:ln/>
+        </p:spPr>
+      </p:sp>
+      <p:sp>
+        <p:nvSpPr>
+          <p:cNvPr id="28" name="Shape 26"/>
+          <p:cNvSpPr/>
+          <p:nvPr/>
+        </p:nvSpPr>
+        <p:spPr>
+          <a:xfrm>
+            <a:off x="4690872" y="3310128"/>
+            <a:ext cx="1170432" cy="256032"/>
+          </a:xfrm>
+          <a:prstGeom prst="leftArrow">
+            <a:avLst/>
+          </a:prstGeom>
+          <a:solidFill>
+            <a:srgbClr val="7C93AC"/>
+          </a:solidFill>
+          <a:ln/>
+        </p:spPr>
+      </p:sp>
+      <p:sp>
+        <p:nvSpPr>
+          <p:cNvPr id="29" name="Shape 27"/>
+          <p:cNvSpPr/>
+          <p:nvPr/>
+        </p:nvSpPr>
+        <p:spPr>
+          <a:xfrm>
+            <a:off x="7790688" y="2651760"/>
+            <a:ext cx="182880" cy="256032"/>
+          </a:xfrm>
+          <a:prstGeom prst="rightArrow">
+            <a:avLst/>
+          </a:prstGeom>
+          <a:solidFill>
+            <a:srgbClr val="8E0B20"/>
+          </a:solidFill>
+          <a:ln/>
+        </p:spPr>
+      </p:sp>
+      <p:sp>
+        <p:nvSpPr>
+          <p:cNvPr id="30" name="Shape 28"/>
+          <p:cNvSpPr/>
+          <p:nvPr/>
+        </p:nvSpPr>
+        <p:spPr>
+          <a:xfrm>
+            <a:off x="9756648" y="2651760"/>
+            <a:ext cx="146304" cy="256032"/>
+          </a:xfrm>
+          <a:prstGeom prst="rightArrow">
+            <a:avLst/>
+          </a:prstGeom>
+          <a:solidFill>
+            <a:srgbClr val="8E0B20"/>
+          </a:solidFill>
+          <a:ln/>
+        </p:spPr>
+      </p:sp>
+      <p:sp>
+        <p:nvSpPr>
+          <p:cNvPr id="31" name="Shape 29"/>
+          <p:cNvSpPr/>
+          <p:nvPr/>
+        </p:nvSpPr>
+        <p:spPr>
+          <a:xfrm>
+            <a:off x="2212848" y="2304288"/>
+            <a:ext cx="310896" cy="310896"/>
+          </a:xfrm>
+          <a:prstGeom prst="ellipse">
+            <a:avLst/>
+          </a:prstGeom>
+          <a:solidFill>
+            <a:srgbClr val="C8102E"/>
+          </a:solidFill>
+          <a:ln w="19050">
+            <a:solidFill>
+              <a:srgbClr val="FFFFFF"/>
+            </a:solidFill>
+            <a:prstDash val="solid"/>
+          </a:ln>
+        </p:spPr>
+      </p:sp>
+      <p:sp>
+        <p:nvSpPr>
+          <p:cNvPr id="32" name="Text 30"/>
+          <p:cNvSpPr/>
+          <p:nvPr/>
+        </p:nvSpPr>
+        <p:spPr>
+          <a:xfrm>
+            <a:off x="2212848" y="2304288"/>
+            <a:ext cx="310896" cy="310896"/>
+          </a:xfrm>
+          <a:prstGeom prst="rect">
+            <a:avLst/>
+          </a:prstGeom>
+          <a:noFill/>
+          <a:ln/>
+        </p:spPr>
+        <p:txBody>
+          <a:bodyPr wrap="square" lIns="0" tIns="0" rIns="0" bIns="0" rtlCol="0" anchor="ctr"/>
+          <a:lstStyle/>
+          <a:p>
+            <a:pPr algn="ctr" indent="0" marL="0">
+              <a:buNone/>
+            </a:pPr>
+            <a:r>
+              <a:rPr lang="en-US" sz="1400" b="1" dirty="0">
+                <a:solidFill>
+                  <a:srgbClr val="FFFFFF"/>
                 </a:solidFill>
                 <a:latin typeface="Cambria" pitchFamily="34" charset="0"/>
                 <a:ea typeface="Cambria" pitchFamily="34" charset="-122"/>
                 <a:cs typeface="Cambria" pitchFamily="34" charset="-120"/>
               </a:rPr>
-              <a:t>EDR(SentinelOne)</a:t>
-            </a:r>
-            <a:endParaRPr lang="en-US" sz="1700" dirty="0"/>
-          </a:p>
-        </p:txBody>
-      </p:sp>
-      <p:sp>
-        <p:nvSpPr>
-          <p:cNvPr id="13" name="Text 11"/>
-          <p:cNvSpPr/>
-          <p:nvPr/>
-        </p:nvSpPr>
-        <p:spPr>
-          <a:xfrm>
-            <a:off x="1572768" y="3877056"/>
-            <a:ext cx="6400800" cy="457200"/>
-          </a:xfrm>
-          <a:prstGeom prst="rect">
-            <a:avLst/>
-          </a:prstGeom>
-          <a:noFill/>
-          <a:ln/>
-        </p:spPr>
-        <p:txBody>
-          <a:bodyPr wrap="square" lIns="0" tIns="0" rIns="0" bIns="0" rtlCol="0" anchor="t"/>
-          <a:lstStyle/>
-          <a:p>
-            <a:pPr indent="0" marL="0">
-              <a:buNone/>
-            </a:pPr>
-            <a:r>
-              <a:rPr lang="en-US" sz="1250" dirty="0">
-                <a:solidFill>
-                  <a:srgbClr val="1A2332"/>
-                </a:solidFill>
-                <a:latin typeface="Calibri" pitchFamily="34" charset="0"/>
-                <a:ea typeface="Calibri" pitchFamily="34" charset="-122"/>
-                <a:cs typeface="Calibri" pitchFamily="34" charset="-120"/>
-              </a:rPr>
-              <a:t>侵入されても被害拡大を検知・抑制</a:t>
-            </a:r>
-            <a:endParaRPr lang="en-US" sz="1250" dirty="0"/>
-          </a:p>
-        </p:txBody>
-      </p:sp>
-      <p:sp>
-        <p:nvSpPr>
-          <p:cNvPr id="14" name="Shape 12"/>
-          <p:cNvSpPr/>
-          <p:nvPr/>
-        </p:nvSpPr>
-        <p:spPr>
-          <a:xfrm>
-            <a:off x="566928" y="4608576"/>
-            <a:ext cx="7498080" cy="1097280"/>
+              <a:t>2</a:t>
+            </a:r>
+            <a:endParaRPr lang="en-US" sz="1400" dirty="0"/>
+          </a:p>
+        </p:txBody>
+      </p:sp>
+      <p:sp>
+        <p:nvSpPr>
+          <p:cNvPr id="33" name="Shape 31"/>
+          <p:cNvSpPr/>
+          <p:nvPr/>
+        </p:nvSpPr>
+        <p:spPr>
+          <a:xfrm>
+            <a:off x="5504688" y="2103120"/>
+            <a:ext cx="310896" cy="310896"/>
+          </a:xfrm>
+          <a:prstGeom prst="ellipse">
+            <a:avLst/>
+          </a:prstGeom>
+          <a:solidFill>
+            <a:srgbClr val="C8102E"/>
+          </a:solidFill>
+          <a:ln w="19050">
+            <a:solidFill>
+              <a:srgbClr val="FFFFFF"/>
+            </a:solidFill>
+            <a:prstDash val="solid"/>
+          </a:ln>
+        </p:spPr>
+      </p:sp>
+      <p:sp>
+        <p:nvSpPr>
+          <p:cNvPr id="34" name="Text 32"/>
+          <p:cNvSpPr/>
+          <p:nvPr/>
+        </p:nvSpPr>
+        <p:spPr>
+          <a:xfrm>
+            <a:off x="5504688" y="2103120"/>
+            <a:ext cx="310896" cy="310896"/>
+          </a:xfrm>
+          <a:prstGeom prst="rect">
+            <a:avLst/>
+          </a:prstGeom>
+          <a:noFill/>
+          <a:ln/>
+        </p:spPr>
+        <p:txBody>
+          <a:bodyPr wrap="square" lIns="0" tIns="0" rIns="0" bIns="0" rtlCol="0" anchor="ctr"/>
+          <a:lstStyle/>
+          <a:p>
+            <a:pPr algn="ctr" indent="0" marL="0">
+              <a:buNone/>
+            </a:pPr>
+            <a:r>
+              <a:rPr lang="en-US" sz="1400" b="1" dirty="0">
+                <a:solidFill>
+                  <a:srgbClr val="FFFFFF"/>
+                </a:solidFill>
+                <a:latin typeface="Cambria" pitchFamily="34" charset="0"/>
+                <a:ea typeface="Cambria" pitchFamily="34" charset="-122"/>
+                <a:cs typeface="Cambria" pitchFamily="34" charset="-120"/>
+              </a:rPr>
+              <a:t>3</a:t>
+            </a:r>
+            <a:endParaRPr lang="en-US" sz="1400" dirty="0"/>
+          </a:p>
+        </p:txBody>
+      </p:sp>
+      <p:sp>
+        <p:nvSpPr>
+          <p:cNvPr id="35" name="Shape 33"/>
+          <p:cNvSpPr/>
+          <p:nvPr/>
+        </p:nvSpPr>
+        <p:spPr>
+          <a:xfrm>
+            <a:off x="5120640" y="3246120"/>
+            <a:ext cx="310896" cy="310896"/>
+          </a:xfrm>
+          <a:prstGeom prst="ellipse">
+            <a:avLst/>
+          </a:prstGeom>
+          <a:solidFill>
+            <a:srgbClr val="5E7186"/>
+          </a:solidFill>
+          <a:ln w="19050">
+            <a:solidFill>
+              <a:srgbClr val="FFFFFF"/>
+            </a:solidFill>
+            <a:prstDash val="solid"/>
+          </a:ln>
+        </p:spPr>
+      </p:sp>
+      <p:sp>
+        <p:nvSpPr>
+          <p:cNvPr id="36" name="Text 34"/>
+          <p:cNvSpPr/>
+          <p:nvPr/>
+        </p:nvSpPr>
+        <p:spPr>
+          <a:xfrm>
+            <a:off x="5120640" y="3246120"/>
+            <a:ext cx="310896" cy="310896"/>
+          </a:xfrm>
+          <a:prstGeom prst="rect">
+            <a:avLst/>
+          </a:prstGeom>
+          <a:noFill/>
+          <a:ln/>
+        </p:spPr>
+        <p:txBody>
+          <a:bodyPr wrap="square" lIns="0" tIns="0" rIns="0" bIns="0" rtlCol="0" anchor="ctr"/>
+          <a:lstStyle/>
+          <a:p>
+            <a:pPr algn="ctr" indent="0" marL="0">
+              <a:buNone/>
+            </a:pPr>
+            <a:r>
+              <a:rPr lang="en-US" sz="1400" b="1" dirty="0">
+                <a:solidFill>
+                  <a:srgbClr val="FFFFFF"/>
+                </a:solidFill>
+                <a:latin typeface="Cambria" pitchFamily="34" charset="0"/>
+                <a:ea typeface="Cambria" pitchFamily="34" charset="-122"/>
+                <a:cs typeface="Cambria" pitchFamily="34" charset="-120"/>
+              </a:rPr>
+              <a:t>1</a:t>
+            </a:r>
+            <a:endParaRPr lang="en-US" sz="1400" dirty="0"/>
+          </a:p>
+        </p:txBody>
+      </p:sp>
+      <p:sp>
+        <p:nvSpPr>
+          <p:cNvPr id="37" name="Shape 35"/>
+          <p:cNvSpPr/>
+          <p:nvPr/>
+        </p:nvSpPr>
+        <p:spPr>
+          <a:xfrm>
+            <a:off x="7726680" y="3200400"/>
+            <a:ext cx="310896" cy="310896"/>
+          </a:xfrm>
+          <a:prstGeom prst="ellipse">
+            <a:avLst/>
+          </a:prstGeom>
+          <a:solidFill>
+            <a:srgbClr val="8E0B20"/>
+          </a:solidFill>
+          <a:ln w="19050">
+            <a:solidFill>
+              <a:srgbClr val="FFFFFF"/>
+            </a:solidFill>
+            <a:prstDash val="solid"/>
+          </a:ln>
+        </p:spPr>
+      </p:sp>
+      <p:sp>
+        <p:nvSpPr>
+          <p:cNvPr id="38" name="Text 36"/>
+          <p:cNvSpPr/>
+          <p:nvPr/>
+        </p:nvSpPr>
+        <p:spPr>
+          <a:xfrm>
+            <a:off x="7726680" y="3200400"/>
+            <a:ext cx="310896" cy="310896"/>
+          </a:xfrm>
+          <a:prstGeom prst="rect">
+            <a:avLst/>
+          </a:prstGeom>
+          <a:noFill/>
+          <a:ln/>
+        </p:spPr>
+        <p:txBody>
+          <a:bodyPr wrap="square" lIns="0" tIns="0" rIns="0" bIns="0" rtlCol="0" anchor="ctr"/>
+          <a:lstStyle/>
+          <a:p>
+            <a:pPr algn="ctr" indent="0" marL="0">
+              <a:buNone/>
+            </a:pPr>
+            <a:r>
+              <a:rPr lang="en-US" sz="1400" b="1" dirty="0">
+                <a:solidFill>
+                  <a:srgbClr val="FFFFFF"/>
+                </a:solidFill>
+                <a:latin typeface="Cambria" pitchFamily="34" charset="0"/>
+                <a:ea typeface="Cambria" pitchFamily="34" charset="-122"/>
+                <a:cs typeface="Cambria" pitchFamily="34" charset="-120"/>
+              </a:rPr>
+              <a:t>4</a:t>
+            </a:r>
+            <a:endParaRPr lang="en-US" sz="1400" dirty="0"/>
+          </a:p>
+        </p:txBody>
+      </p:sp>
+      <p:sp>
+        <p:nvSpPr>
+          <p:cNvPr id="39" name="Shape 37"/>
+          <p:cNvSpPr/>
+          <p:nvPr/>
+        </p:nvSpPr>
+        <p:spPr>
+          <a:xfrm>
+            <a:off x="9646920" y="3200400"/>
+            <a:ext cx="310896" cy="310896"/>
+          </a:xfrm>
+          <a:prstGeom prst="ellipse">
+            <a:avLst/>
+          </a:prstGeom>
+          <a:solidFill>
+            <a:srgbClr val="8E0B20"/>
+          </a:solidFill>
+          <a:ln w="19050">
+            <a:solidFill>
+              <a:srgbClr val="FFFFFF"/>
+            </a:solidFill>
+            <a:prstDash val="solid"/>
+          </a:ln>
+        </p:spPr>
+      </p:sp>
+      <p:sp>
+        <p:nvSpPr>
+          <p:cNvPr id="40" name="Text 38"/>
+          <p:cNvSpPr/>
+          <p:nvPr/>
+        </p:nvSpPr>
+        <p:spPr>
+          <a:xfrm>
+            <a:off x="9646920" y="3200400"/>
+            <a:ext cx="310896" cy="310896"/>
+          </a:xfrm>
+          <a:prstGeom prst="rect">
+            <a:avLst/>
+          </a:prstGeom>
+          <a:noFill/>
+          <a:ln/>
+        </p:spPr>
+        <p:txBody>
+          <a:bodyPr wrap="square" lIns="0" tIns="0" rIns="0" bIns="0" rtlCol="0" anchor="ctr"/>
+          <a:lstStyle/>
+          <a:p>
+            <a:pPr algn="ctr" indent="0" marL="0">
+              <a:buNone/>
+            </a:pPr>
+            <a:r>
+              <a:rPr lang="en-US" sz="1400" b="1" dirty="0">
+                <a:solidFill>
+                  <a:srgbClr val="FFFFFF"/>
+                </a:solidFill>
+                <a:latin typeface="Cambria" pitchFamily="34" charset="0"/>
+                <a:ea typeface="Cambria" pitchFamily="34" charset="-122"/>
+                <a:cs typeface="Cambria" pitchFamily="34" charset="-120"/>
+              </a:rPr>
+              <a:t>5</a:t>
+            </a:r>
+            <a:endParaRPr lang="en-US" sz="1400" dirty="0"/>
+          </a:p>
+        </p:txBody>
+      </p:sp>
+      <p:sp>
+        <p:nvSpPr>
+          <p:cNvPr id="41" name="Shape 39"/>
+          <p:cNvSpPr/>
+          <p:nvPr/>
+        </p:nvSpPr>
+        <p:spPr>
+          <a:xfrm>
+            <a:off x="457200" y="4169664"/>
+            <a:ext cx="11292840" cy="658368"/>
           </a:xfrm>
           <a:prstGeom prst="roundRect">
             <a:avLst>
-              <a:gd name="adj" fmla="val 6667"/>
+              <a:gd name="adj" fmla="val 9722"/>
             </a:avLst>
           </a:prstGeom>
           <a:solidFill>
@@ -2958,45 +3952,18 @@
             </a:solidFill>
             <a:prstDash val="solid"/>
           </a:ln>
-          <a:effectLst>
-            <a:outerShdw sx="100000" sy="100000" kx="0" ky="0" algn="bl" rotWithShape="0" blurRad="101600" dist="38100" dir="5400000">
-              <a:srgbClr val="8A93A6">
-                <a:alpha val="28000"/>
-              </a:srgbClr>
-            </a:outerShdw>
-          </a:effectLst>
-        </p:spPr>
-      </p:sp>
-      <p:sp>
-        <p:nvSpPr>
-          <p:cNvPr id="15" name="Shape 13"/>
-          <p:cNvSpPr/>
-          <p:nvPr/>
-        </p:nvSpPr>
-        <p:spPr>
-          <a:xfrm>
-            <a:off x="795528" y="4864608"/>
-            <a:ext cx="585216" cy="585216"/>
-          </a:xfrm>
-          <a:prstGeom prst="ellipse">
-            <a:avLst/>
-          </a:prstGeom>
-          <a:solidFill>
-            <a:srgbClr val="1E7A46"/>
-          </a:solidFill>
-          <a:ln/>
-        </p:spPr>
-      </p:sp>
-      <p:sp>
-        <p:nvSpPr>
-          <p:cNvPr id="16" name="Text 14"/>
-          <p:cNvSpPr/>
-          <p:nvPr/>
-        </p:nvSpPr>
-        <p:spPr>
-          <a:xfrm>
-            <a:off x="795528" y="4864608"/>
-            <a:ext cx="585216" cy="585216"/>
+        </p:spPr>
+      </p:sp>
+      <p:sp>
+        <p:nvSpPr>
+          <p:cNvPr id="42" name="Text 40"/>
+          <p:cNvSpPr/>
+          <p:nvPr/>
+        </p:nvSpPr>
+        <p:spPr>
+          <a:xfrm>
+            <a:off x="658368" y="4169664"/>
+            <a:ext cx="10881360" cy="658368"/>
           </a:xfrm>
           <a:prstGeom prst="rect">
             <a:avLst/>
@@ -3008,103 +3975,65 @@
           <a:bodyPr wrap="square" lIns="0" tIns="0" rIns="0" bIns="0" rtlCol="0" anchor="ctr"/>
           <a:lstStyle/>
           <a:p>
-            <a:pPr algn="ctr" indent="0" marL="0">
-              <a:buNone/>
-            </a:pPr>
-            <a:r>
-              <a:rPr lang="en-US" sz="2200" b="1" dirty="0">
-                <a:solidFill>
-                  <a:srgbClr val="FFFFFF"/>
-                </a:solidFill>
-                <a:latin typeface="Cambria" pitchFamily="34" charset="0"/>
-                <a:ea typeface="Cambria" pitchFamily="34" charset="-122"/>
-                <a:cs typeface="Cambria" pitchFamily="34" charset="-120"/>
-              </a:rPr>
-              <a:t>3</a:t>
-            </a:r>
-            <a:endParaRPr lang="en-US" sz="2200" dirty="0"/>
-          </a:p>
-        </p:txBody>
-      </p:sp>
-      <p:sp>
-        <p:nvSpPr>
-          <p:cNvPr id="17" name="Text 15"/>
-          <p:cNvSpPr/>
-          <p:nvPr/>
-        </p:nvSpPr>
-        <p:spPr>
-          <a:xfrm>
-            <a:off x="1572768" y="4754880"/>
-            <a:ext cx="6400800" cy="457200"/>
-          </a:xfrm>
-          <a:prstGeom prst="rect">
-            <a:avLst/>
-          </a:prstGeom>
-          <a:noFill/>
-          <a:ln/>
-        </p:spPr>
-        <p:txBody>
-          <a:bodyPr wrap="square" lIns="0" tIns="0" rIns="0" bIns="0" rtlCol="0" anchor="ctr"/>
-          <a:lstStyle/>
-          <a:p>
             <a:pPr indent="0" marL="0">
-              <a:buNone/>
-            </a:pPr>
-            <a:r>
-              <a:rPr lang="en-US" sz="1700" b="1" dirty="0">
-                <a:solidFill>
-                  <a:srgbClr val="0E1B3D"/>
-                </a:solidFill>
-                <a:latin typeface="Cambria" pitchFamily="34" charset="0"/>
-                <a:ea typeface="Cambria" pitchFamily="34" charset="-122"/>
-                <a:cs typeface="Cambria" pitchFamily="34" charset="-120"/>
-              </a:rPr>
-              <a:t>備えと復旧   </a:t>
+              <a:lnSpc>
+                <a:spcPts val="1700"/>
+              </a:lnSpc>
+              <a:buNone/>
+            </a:pPr>
+            <a:r>
+              <a:rPr lang="en-US" sz="1150" b="1" dirty="0">
+                <a:solidFill>
+                  <a:srgbClr val="5E7186"/>
+                </a:solidFill>
+                <a:latin typeface="Calibri" pitchFamily="34" charset="0"/>
+                <a:ea typeface="Calibri" pitchFamily="34" charset="-122"/>
+                <a:cs typeface="Calibri" pitchFamily="34" charset="-120"/>
+              </a:rPr>
+              <a:t>①</a:t>
             </a:r>
             <a:pPr indent="0" marL="0">
-              <a:buNone/>
-            </a:pPr>
-            <a:r>
-              <a:rPr lang="en-US" sz="1300" b="1" dirty="0">
-                <a:solidFill>
-                  <a:srgbClr val="1E7A46"/>
-                </a:solidFill>
-                <a:latin typeface="Cambria" pitchFamily="34" charset="0"/>
-                <a:ea typeface="Cambria" pitchFamily="34" charset="-122"/>
-                <a:cs typeface="Cambria" pitchFamily="34" charset="-120"/>
-              </a:rPr>
-              <a:t>バックアップ・監視・訓練</a:t>
-            </a:r>
-            <a:endParaRPr lang="en-US" sz="1700" dirty="0"/>
-          </a:p>
-        </p:txBody>
-      </p:sp>
-      <p:sp>
-        <p:nvSpPr>
-          <p:cNvPr id="18" name="Text 16"/>
-          <p:cNvSpPr/>
-          <p:nvPr/>
-        </p:nvSpPr>
-        <p:spPr>
-          <a:xfrm>
-            <a:off x="1572768" y="5175504"/>
-            <a:ext cx="6400800" cy="457200"/>
-          </a:xfrm>
-          <a:prstGeom prst="rect">
-            <a:avLst/>
-          </a:prstGeom>
-          <a:noFill/>
-          <a:ln/>
-        </p:spPr>
-        <p:txBody>
-          <a:bodyPr wrap="square" lIns="0" tIns="0" rIns="0" bIns="0" rtlCol="0" anchor="t"/>
-          <a:lstStyle/>
-          <a:p>
+              <a:lnSpc>
+                <a:spcPts val="1700"/>
+              </a:lnSpc>
+              <a:buNone/>
+            </a:pPr>
+            <a:r>
+              <a:rPr lang="en-US" sz="1150" dirty="0">
+                <a:solidFill>
+                  <a:srgbClr val="1A2332"/>
+                </a:solidFill>
+                <a:latin typeface="Calibri" pitchFamily="34" charset="0"/>
+                <a:ea typeface="Calibri" pitchFamily="34" charset="-122"/>
+                <a:cs typeface="Calibri" pitchFamily="34" charset="-120"/>
+              </a:rPr>
+              <a:t> エッジが常時アウトバウンド接続(443)→F/Wが許可　　</a:t>
+            </a:r>
             <a:pPr indent="0" marL="0">
-              <a:buNone/>
-            </a:pPr>
-            <a:r>
-              <a:rPr lang="en-US" sz="1250" dirty="0">
+              <a:lnSpc>
+                <a:spcPts val="1700"/>
+              </a:lnSpc>
+              <a:buNone/>
+            </a:pPr>
+            <a:r>
+              <a:rPr lang="en-US" sz="1150" b="1" dirty="0">
+                <a:solidFill>
+                  <a:srgbClr val="C8102E"/>
+                </a:solidFill>
+                <a:latin typeface="Calibri" pitchFamily="34" charset="0"/>
+                <a:ea typeface="Calibri" pitchFamily="34" charset="-122"/>
+                <a:cs typeface="Calibri" pitchFamily="34" charset="-120"/>
+              </a:rPr>
+              <a:t>②</a:t>
+            </a:r>
+            <a:pPr indent="0" marL="0">
+              <a:lnSpc>
+                <a:spcPts val="1700"/>
+              </a:lnSpc>
+              <a:buNone/>
+            </a:pPr>
+            <a:r>
+              <a:rPr lang="en-US" sz="1150" dirty="0">
                 <a:solidFill>
                   <a:srgbClr val="1A2332"/>
                 </a:solidFill>
@@ -3112,73 +4041,303 @@
                 <a:ea typeface="Calibri" pitchFamily="34" charset="-122"/>
                 <a:cs typeface="Calibri" pitchFamily="34" charset="-120"/>
               </a:rPr>
-              <a:t>最悪時に事業を止めない</a:t>
-            </a:r>
-            <a:endParaRPr lang="en-US" sz="1250" dirty="0"/>
-          </a:p>
-        </p:txBody>
-      </p:sp>
-      <p:sp>
-        <p:nvSpPr>
-          <p:cNvPr id="19" name="Shape 17"/>
-          <p:cNvSpPr/>
-          <p:nvPr/>
-        </p:nvSpPr>
-        <p:spPr>
-          <a:xfrm>
-            <a:off x="8366760" y="2011680"/>
-            <a:ext cx="3255264" cy="3712464"/>
+              <a:t> 攻撃者はリレー越しに到達　　</a:t>
+            </a:r>
+            <a:pPr indent="0" marL="0">
+              <a:lnSpc>
+                <a:spcPts val="1700"/>
+              </a:lnSpc>
+              <a:buNone/>
+            </a:pPr>
+            <a:r>
+              <a:rPr lang="en-US" sz="1150" b="1" dirty="0">
+                <a:solidFill>
+                  <a:srgbClr val="C8102E"/>
+                </a:solidFill>
+                <a:latin typeface="Calibri" pitchFamily="34" charset="0"/>
+                <a:ea typeface="Calibri" pitchFamily="34" charset="-122"/>
+                <a:cs typeface="Calibri" pitchFamily="34" charset="-120"/>
+              </a:rPr>
+              <a:t>③</a:t>
+            </a:r>
+            <a:pPr indent="0" marL="0">
+              <a:lnSpc>
+                <a:spcPts val="1700"/>
+              </a:lnSpc>
+              <a:buNone/>
+            </a:pPr>
+            <a:r>
+              <a:rPr lang="en-US" sz="1150" dirty="0">
+                <a:solidFill>
+                  <a:srgbClr val="1A2332"/>
+                </a:solidFill>
+                <a:latin typeface="Calibri" pitchFamily="34" charset="0"/>
+                <a:ea typeface="Calibri" pitchFamily="34" charset="-122"/>
+                <a:cs typeface="Calibri" pitchFamily="34" charset="-120"/>
+              </a:rPr>
+              <a:t> 正規認証／未パッチCVEで侵入　　</a:t>
+            </a:r>
+            <a:pPr indent="0" marL="0">
+              <a:lnSpc>
+                <a:spcPts val="1700"/>
+              </a:lnSpc>
+              <a:buNone/>
+            </a:pPr>
+            <a:r>
+              <a:rPr lang="en-US" sz="1150" b="1" dirty="0">
+                <a:solidFill>
+                  <a:srgbClr val="8E0B20"/>
+                </a:solidFill>
+                <a:latin typeface="Calibri" pitchFamily="34" charset="0"/>
+                <a:ea typeface="Calibri" pitchFamily="34" charset="-122"/>
+                <a:cs typeface="Calibri" pitchFamily="34" charset="-120"/>
+              </a:rPr>
+              <a:t>④</a:t>
+            </a:r>
+            <a:pPr indent="0" marL="0">
+              <a:lnSpc>
+                <a:spcPts val="1700"/>
+              </a:lnSpc>
+              <a:buNone/>
+            </a:pPr>
+            <a:r>
+              <a:rPr lang="en-US" sz="1150" dirty="0">
+                <a:solidFill>
+                  <a:srgbClr val="1A2332"/>
+                </a:solidFill>
+                <a:latin typeface="Calibri" pitchFamily="34" charset="0"/>
+                <a:ea typeface="Calibri" pitchFamily="34" charset="-122"/>
+                <a:cs typeface="Calibri" pitchFamily="34" charset="-120"/>
+              </a:rPr>
+              <a:t> 内部を横展開　　</a:t>
+            </a:r>
+            <a:pPr indent="0" marL="0">
+              <a:lnSpc>
+                <a:spcPts val="1700"/>
+              </a:lnSpc>
+              <a:buNone/>
+            </a:pPr>
+            <a:r>
+              <a:rPr lang="en-US" sz="1150" b="1" dirty="0">
+                <a:solidFill>
+                  <a:srgbClr val="8E0B20"/>
+                </a:solidFill>
+                <a:latin typeface="Calibri" pitchFamily="34" charset="0"/>
+                <a:ea typeface="Calibri" pitchFamily="34" charset="-122"/>
+                <a:cs typeface="Calibri" pitchFamily="34" charset="-120"/>
+              </a:rPr>
+              <a:t>⑤</a:t>
+            </a:r>
+            <a:pPr indent="0" marL="0">
+              <a:lnSpc>
+                <a:spcPts val="1700"/>
+              </a:lnSpc>
+              <a:buNone/>
+            </a:pPr>
+            <a:r>
+              <a:rPr lang="en-US" sz="1150" dirty="0">
+                <a:solidFill>
+                  <a:srgbClr val="1A2332"/>
+                </a:solidFill>
+                <a:latin typeface="Calibri" pitchFamily="34" charset="0"/>
+                <a:ea typeface="Calibri" pitchFamily="34" charset="-122"/>
+                <a:cs typeface="Calibri" pitchFamily="34" charset="-120"/>
+              </a:rPr>
+              <a:t> AD管理者権限を奪取しEDRを無効化</a:t>
+            </a:r>
+            <a:endParaRPr lang="en-US" sz="1150" dirty="0"/>
+          </a:p>
+        </p:txBody>
+      </p:sp>
+      <p:sp>
+        <p:nvSpPr>
+          <p:cNvPr id="43" name="Shape 41"/>
+          <p:cNvSpPr/>
+          <p:nvPr/>
+        </p:nvSpPr>
+        <p:spPr>
+          <a:xfrm>
+            <a:off x="457200" y="4956048"/>
+            <a:ext cx="4315968" cy="585216"/>
           </a:xfrm>
           <a:prstGeom prst="roundRect">
             <a:avLst>
-              <a:gd name="adj" fmla="val 2809"/>
+              <a:gd name="adj" fmla="val 10938"/>
+            </a:avLst>
+          </a:prstGeom>
+          <a:solidFill>
+            <a:srgbClr val="FBEDEF"/>
+          </a:solidFill>
+          <a:ln w="12700">
+            <a:solidFill>
+              <a:srgbClr val="E7B9C1"/>
+            </a:solidFill>
+            <a:prstDash val="solid"/>
+          </a:ln>
+        </p:spPr>
+      </p:sp>
+      <p:sp>
+        <p:nvSpPr>
+          <p:cNvPr id="44" name="Text 42"/>
+          <p:cNvSpPr/>
+          <p:nvPr/>
+        </p:nvSpPr>
+        <p:spPr>
+          <a:xfrm>
+            <a:off x="621792" y="4956048"/>
+            <a:ext cx="4023360" cy="585216"/>
+          </a:xfrm>
+          <a:prstGeom prst="rect">
+            <a:avLst/>
+          </a:prstGeom>
+          <a:noFill/>
+          <a:ln/>
+        </p:spPr>
+        <p:txBody>
+          <a:bodyPr wrap="square" lIns="0" tIns="0" rIns="0" bIns="0" rtlCol="0" anchor="ctr"/>
+          <a:lstStyle/>
+          <a:p>
+            <a:pPr indent="0" marL="0">
+              <a:lnSpc>
+                <a:spcPts val="1400"/>
+              </a:lnSpc>
+              <a:buNone/>
+            </a:pPr>
+            <a:r>
+              <a:rPr lang="en-US" sz="1050" b="1" dirty="0">
+                <a:solidFill>
+                  <a:srgbClr val="8E0B20"/>
+                </a:solidFill>
+                <a:latin typeface="Calibri" pitchFamily="34" charset="0"/>
+                <a:ea typeface="Calibri" pitchFamily="34" charset="-122"/>
+                <a:cs typeface="Calibri" pitchFamily="34" charset="-120"/>
+              </a:rPr>
+              <a:t>EDRの盲点｜①〜③は検知できない（社外偵察・リレー到達・正規ログイン）</a:t>
+            </a:r>
+            <a:endParaRPr lang="en-US" sz="1050" dirty="0"/>
+          </a:p>
+        </p:txBody>
+      </p:sp>
+      <p:sp>
+        <p:nvSpPr>
+          <p:cNvPr id="45" name="Shape 43"/>
+          <p:cNvSpPr/>
+          <p:nvPr/>
+        </p:nvSpPr>
+        <p:spPr>
+          <a:xfrm>
+            <a:off x="4892040" y="4956048"/>
+            <a:ext cx="6858000" cy="585216"/>
+          </a:xfrm>
+          <a:prstGeom prst="roundRect">
+            <a:avLst>
+              <a:gd name="adj" fmla="val 10938"/>
+            </a:avLst>
+          </a:prstGeom>
+          <a:solidFill>
+            <a:srgbClr val="FBF2E6"/>
+          </a:solidFill>
+          <a:ln w="12700">
+            <a:solidFill>
+              <a:srgbClr val="E8CBA0"/>
+            </a:solidFill>
+            <a:prstDash val="solid"/>
+          </a:ln>
+        </p:spPr>
+      </p:sp>
+      <p:sp>
+        <p:nvSpPr>
+          <p:cNvPr id="46" name="Text 44"/>
+          <p:cNvSpPr/>
+          <p:nvPr/>
+        </p:nvSpPr>
+        <p:spPr>
+          <a:xfrm>
+            <a:off x="5056632" y="4956048"/>
+            <a:ext cx="6583680" cy="585216"/>
+          </a:xfrm>
+          <a:prstGeom prst="rect">
+            <a:avLst/>
+          </a:prstGeom>
+          <a:noFill/>
+          <a:ln/>
+        </p:spPr>
+        <p:txBody>
+          <a:bodyPr wrap="square" lIns="0" tIns="0" rIns="0" bIns="0" rtlCol="0" anchor="ctr"/>
+          <a:lstStyle/>
+          <a:p>
+            <a:pPr indent="0" marL="0">
+              <a:lnSpc>
+                <a:spcPts val="1400"/>
+              </a:lnSpc>
+              <a:buNone/>
+            </a:pPr>
+            <a:r>
+              <a:rPr lang="en-US" sz="1050" b="1" dirty="0">
+                <a:solidFill>
+                  <a:srgbClr val="9A5B12"/>
+                </a:solidFill>
+                <a:latin typeface="Calibri" pitchFamily="34" charset="0"/>
+                <a:ea typeface="Calibri" pitchFamily="34" charset="-122"/>
+                <a:cs typeface="Calibri" pitchFamily="34" charset="-120"/>
+              </a:rPr>
+              <a:t>④〜⑤で初めて検知の余地。ただし攻撃者にEDRを無効化されうる（S-1でも実例あり）</a:t>
+            </a:r>
+            <a:endParaRPr lang="en-US" sz="1050" dirty="0"/>
+          </a:p>
+        </p:txBody>
+      </p:sp>
+      <p:sp>
+        <p:nvSpPr>
+          <p:cNvPr id="47" name="Shape 45"/>
+          <p:cNvSpPr/>
+          <p:nvPr/>
+        </p:nvSpPr>
+        <p:spPr>
+          <a:xfrm>
+            <a:off x="457200" y="5669280"/>
+            <a:ext cx="11292840" cy="658368"/>
+          </a:xfrm>
+          <a:prstGeom prst="roundRect">
+            <a:avLst>
+              <a:gd name="adj" fmla="val 11111"/>
             </a:avLst>
           </a:prstGeom>
           <a:solidFill>
             <a:srgbClr val="0E1B3D"/>
           </a:solidFill>
           <a:ln/>
-          <a:effectLst>
-            <a:outerShdw sx="100000" sy="100000" kx="0" ky="0" algn="bl" rotWithShape="0" blurRad="101600" dist="38100" dir="5400000">
-              <a:srgbClr val="8A93A6">
-                <a:alpha val="28000"/>
-              </a:srgbClr>
-            </a:outerShdw>
-          </a:effectLst>
-        </p:spPr>
-      </p:sp>
-      <p:sp>
-        <p:nvSpPr>
-          <p:cNvPr id="20" name="Text 18"/>
-          <p:cNvSpPr/>
-          <p:nvPr/>
-        </p:nvSpPr>
-        <p:spPr>
-          <a:xfrm>
-            <a:off x="8595360" y="2286000"/>
-            <a:ext cx="2779776" cy="3200400"/>
-          </a:xfrm>
-          <a:prstGeom prst="rect">
-            <a:avLst/>
-          </a:prstGeom>
-          <a:noFill/>
-          <a:ln/>
-        </p:spPr>
-        <p:txBody>
-          <a:bodyPr wrap="square" lIns="0" tIns="0" rIns="0" bIns="0" rtlCol="0" anchor="t"/>
+        </p:spPr>
+      </p:sp>
+      <p:sp>
+        <p:nvSpPr>
+          <p:cNvPr id="48" name="Text 46"/>
+          <p:cNvSpPr/>
+          <p:nvPr/>
+        </p:nvSpPr>
+        <p:spPr>
+          <a:xfrm>
+            <a:off x="777240" y="5669280"/>
+            <a:ext cx="10698480" cy="658368"/>
+          </a:xfrm>
+          <a:prstGeom prst="rect">
+            <a:avLst/>
+          </a:prstGeom>
+          <a:noFill/>
+          <a:ln/>
+        </p:spPr>
+        <p:txBody>
+          <a:bodyPr wrap="square" lIns="0" tIns="0" rIns="0" bIns="0" rtlCol="0" anchor="ctr"/>
           <a:lstStyle/>
           <a:p>
             <a:pPr indent="0" marL="0">
               <a:lnSpc>
-                <a:spcPts val="2000"/>
+                <a:spcPts val="1800"/>
               </a:lnSpc>
-              <a:spcAft>
-                <a:spcPts val="1000"/>
-              </a:spcAft>
-              <a:buNone/>
-            </a:pPr>
-            <a:r>
-              <a:rPr lang="en-US" sz="1800" b="1" dirty="0">
+              <a:buNone/>
+            </a:pPr>
+            <a:r>
+              <a:rPr lang="en-US" sz="1300" b="1" dirty="0">
                 <a:solidFill>
                   <a:srgbClr val="FF6B81"/>
                 </a:solidFill>
@@ -3186,22 +4345,16 @@
                 <a:ea typeface="Calibri" pitchFamily="34" charset="-122"/>
                 <a:cs typeface="Calibri" pitchFamily="34" charset="-120"/>
               </a:rPr>
-              <a:t>S-1は層②。</a:t>
-            </a:r>
-            <a:endParaRPr lang="en-US" sz="1800" dirty="0"/>
-          </a:p>
-          <a:p>
+              <a:t>要点：  </a:t>
+            </a:r>
             <a:pPr indent="0" marL="0">
               <a:lnSpc>
-                <a:spcPts val="2000"/>
+                <a:spcPts val="1800"/>
               </a:lnSpc>
-              <a:spcAft>
-                <a:spcPts val="1400"/>
-              </a:spcAft>
-              <a:buNone/>
-            </a:pPr>
-            <a:r>
-              <a:rPr lang="en-US" sz="1400" dirty="0">
+              <a:buNone/>
+            </a:pPr>
+            <a:r>
+              <a:rPr lang="en-US" sz="1300" dirty="0">
                 <a:solidFill>
                   <a:srgbClr val="DCE6F5"/>
                 </a:solidFill>
@@ -3209,35 +4362,15 @@
                 <a:ea typeface="Calibri" pitchFamily="34" charset="-122"/>
                 <a:cs typeface="Calibri" pitchFamily="34" charset="-120"/>
               </a:rPr>
-              <a:t>層①（入口）が抜けたままでは、攻撃者は容易に侵入し、層②を無効化しにいく。</a:t>
-            </a:r>
-            <a:endParaRPr lang="en-US" sz="1800" dirty="0"/>
-          </a:p>
-          <a:p>
-            <a:pPr indent="0" marL="0">
-              <a:lnSpc>
-                <a:spcPts val="2000"/>
-              </a:lnSpc>
-              <a:buNone/>
-            </a:pPr>
-            <a:r>
-              <a:rPr lang="en-US" sz="1400" b="1" dirty="0">
-                <a:solidFill>
-                  <a:srgbClr val="FFFFFF"/>
-                </a:solidFill>
-                <a:latin typeface="Calibri" pitchFamily="34" charset="0"/>
-                <a:ea typeface="Calibri" pitchFamily="34" charset="-122"/>
-                <a:cs typeface="Calibri" pitchFamily="34" charset="-120"/>
-              </a:rPr>
-              <a:t>脆弱性検査は層②を置き換えるものではなく、層②が守る前提となる層①を成立させるもの。</a:t>
-            </a:r>
-            <a:endParaRPr lang="en-US" sz="1800" dirty="0"/>
-          </a:p>
-        </p:txBody>
-      </p:sp>
-      <p:sp>
-        <p:nvSpPr>
-          <p:cNvPr id="21" name="Text 19"/>
+              <a:t>F/Wの内側にあるVPNエッジが「入口」。①〜③はEDRの管轄外で、脆弱性検査・MFA・資産棚卸しでしか塞げない。</a:t>
+            </a:r>
+            <a:endParaRPr lang="en-US" sz="1300" dirty="0"/>
+          </a:p>
+        </p:txBody>
+      </p:sp>
+      <p:sp>
+        <p:nvSpPr>
+          <p:cNvPr id="49" name="Text 47"/>
           <p:cNvSpPr/>
           <p:nvPr/>
         </p:nvSpPr>
@@ -3339,7 +4472,7 @@
                 <a:ea typeface="Calibri" pitchFamily="34" charset="-122"/>
                 <a:cs typeface="Calibri" pitchFamily="34" charset="-120"/>
               </a:rPr>
-              <a:t>Aenaへの提言</a:t>
+              <a:t>あるべき考え方</a:t>
             </a:r>
             <a:endParaRPr lang="en-US" sz="1200" dirty="0"/>
           </a:p>
@@ -3378,7 +4511,7 @@
                 <a:ea typeface="Cambria" pitchFamily="34" charset="-122"/>
                 <a:cs typeface="Cambria" pitchFamily="34" charset="-120"/>
               </a:rPr>
-              <a:t>S-1に加えて今すぐ着手したい5項目</a:t>
+              <a:t>脆弱性検査とEDRは「補完関係」― 多層で守る</a:t>
             </a:r>
             <a:endParaRPr lang="en-US" sz="3200" dirty="0"/>
           </a:p>
@@ -3392,12 +4525,12 @@
         </p:nvSpPr>
         <p:spPr>
           <a:xfrm>
-            <a:off x="566928" y="1920240"/>
-            <a:ext cx="5344668" cy="1143000"/>
+            <a:off x="566928" y="2011680"/>
+            <a:ext cx="7498080" cy="1097280"/>
           </a:xfrm>
           <a:prstGeom prst="roundRect">
             <a:avLst>
-              <a:gd name="adj" fmla="val 6400"/>
+              <a:gd name="adj" fmla="val 6667"/>
             </a:avLst>
           </a:prstGeom>
           <a:solidFill>
@@ -3426,8 +4559,8 @@
         </p:nvSpPr>
         <p:spPr>
           <a:xfrm>
-            <a:off x="795528" y="2203704"/>
-            <a:ext cx="566928" cy="566928"/>
+            <a:off x="795528" y="2267712"/>
+            <a:ext cx="585216" cy="585216"/>
           </a:xfrm>
           <a:prstGeom prst="ellipse">
             <a:avLst/>
@@ -3446,8 +4579,8 @@
         </p:nvSpPr>
         <p:spPr>
           <a:xfrm>
-            <a:off x="795528" y="2203704"/>
-            <a:ext cx="566928" cy="566928"/>
+            <a:off x="795528" y="2267712"/>
+            <a:ext cx="585216" cy="585216"/>
           </a:xfrm>
           <a:prstGeom prst="rect">
             <a:avLst/>
@@ -3485,24 +4618,24 @@
         </p:nvSpPr>
         <p:spPr>
           <a:xfrm>
-            <a:off x="1527048" y="2066544"/>
-            <a:ext cx="4155948" cy="457200"/>
-          </a:xfrm>
-          <a:prstGeom prst="rect">
-            <a:avLst/>
-          </a:prstGeom>
-          <a:noFill/>
-          <a:ln/>
-        </p:spPr>
-        <p:txBody>
-          <a:bodyPr wrap="square" lIns="0" tIns="0" rIns="0" bIns="0" rtlCol="0" anchor="t"/>
+            <a:off x="1572768" y="2157984"/>
+            <a:ext cx="6400800" cy="457200"/>
+          </a:xfrm>
+          <a:prstGeom prst="rect">
+            <a:avLst/>
+          </a:prstGeom>
+          <a:noFill/>
+          <a:ln/>
+        </p:spPr>
+        <p:txBody>
+          <a:bodyPr wrap="square" lIns="0" tIns="0" rIns="0" bIns="0" rtlCol="0" anchor="ctr"/>
           <a:lstStyle/>
           <a:p>
             <a:pPr indent="0" marL="0">
               <a:buNone/>
             </a:pPr>
             <a:r>
-              <a:rPr lang="en-US" sz="1550" b="1" dirty="0">
+              <a:rPr lang="en-US" sz="1700" b="1" dirty="0">
                 <a:solidFill>
                   <a:srgbClr val="0E1B3D"/>
                 </a:solidFill>
@@ -3510,9 +4643,23 @@
                 <a:ea typeface="Cambria" pitchFamily="34" charset="-122"/>
                 <a:cs typeface="Cambria" pitchFamily="34" charset="-120"/>
               </a:rPr>
-              <a:t>外部公開資産の脆弱性検査を定期実施</a:t>
-            </a:r>
-            <a:endParaRPr lang="en-US" sz="1550" dirty="0"/>
+              <a:t>入口を塞ぐ   </a:t>
+            </a:r>
+            <a:pPr indent="0" marL="0">
+              <a:buNone/>
+            </a:pPr>
+            <a:r>
+              <a:rPr lang="en-US" sz="1300" b="1" dirty="0">
+                <a:solidFill>
+                  <a:srgbClr val="C8102E"/>
+                </a:solidFill>
+                <a:latin typeface="Cambria" pitchFamily="34" charset="0"/>
+                <a:ea typeface="Cambria" pitchFamily="34" charset="-122"/>
+                <a:cs typeface="Cambria" pitchFamily="34" charset="-120"/>
+              </a:rPr>
+              <a:t>脆弱性検査・パッチ・認証強化(MFA)</a:t>
+            </a:r>
+            <a:endParaRPr lang="en-US" sz="1700" dirty="0"/>
           </a:p>
         </p:txBody>
       </p:sp>
@@ -3524,8 +4671,8 @@
         </p:nvSpPr>
         <p:spPr>
           <a:xfrm>
-            <a:off x="1527048" y="2487168"/>
-            <a:ext cx="4155948" cy="502920"/>
+            <a:off x="1572768" y="2578608"/>
+            <a:ext cx="6400800" cy="457200"/>
           </a:xfrm>
           <a:prstGeom prst="rect">
             <a:avLst/>
@@ -3538,9 +4685,6 @@
           <a:lstStyle/>
           <a:p>
             <a:pPr indent="0" marL="0">
-              <a:lnSpc>
-                <a:spcPts val="1600"/>
-              </a:lnSpc>
               <a:buNone/>
             </a:pPr>
             <a:r>
@@ -3552,7 +4696,7 @@
                 <a:ea typeface="Calibri" pitchFamily="34" charset="-122"/>
                 <a:cs typeface="Calibri" pitchFamily="34" charset="-120"/>
               </a:rPr>
-              <a:t>VPN・公開サーバ・Webを対象に、悪用可能な入口を洗い出す</a:t>
+              <a:t>侵入・乗っ取りの起点を事前に潰す</a:t>
             </a:r>
             <a:endParaRPr lang="en-US" sz="1250" dirty="0"/>
           </a:p>
@@ -3566,12 +4710,12 @@
         </p:nvSpPr>
         <p:spPr>
           <a:xfrm>
-            <a:off x="6277356" y="1920240"/>
-            <a:ext cx="5344668" cy="1143000"/>
+            <a:off x="566928" y="3310128"/>
+            <a:ext cx="7498080" cy="1097280"/>
           </a:xfrm>
           <a:prstGeom prst="roundRect">
             <a:avLst>
-              <a:gd name="adj" fmla="val 6400"/>
+              <a:gd name="adj" fmla="val 6667"/>
             </a:avLst>
           </a:prstGeom>
           <a:solidFill>
@@ -3600,14 +4744,14 @@
         </p:nvSpPr>
         <p:spPr>
           <a:xfrm>
-            <a:off x="6505956" y="2203704"/>
-            <a:ext cx="566928" cy="566928"/>
+            <a:off x="795528" y="3566160"/>
+            <a:ext cx="585216" cy="585216"/>
           </a:xfrm>
           <a:prstGeom prst="ellipse">
             <a:avLst/>
           </a:prstGeom>
           <a:solidFill>
-            <a:srgbClr val="C8102E"/>
+            <a:srgbClr val="3E5C76"/>
           </a:solidFill>
           <a:ln/>
         </p:spPr>
@@ -3620,8 +4764,8 @@
         </p:nvSpPr>
         <p:spPr>
           <a:xfrm>
-            <a:off x="6505956" y="2203704"/>
-            <a:ext cx="566928" cy="566928"/>
+            <a:off x="795528" y="3566160"/>
+            <a:ext cx="585216" cy="585216"/>
           </a:xfrm>
           <a:prstGeom prst="rect">
             <a:avLst/>
@@ -3659,24 +4803,24 @@
         </p:nvSpPr>
         <p:spPr>
           <a:xfrm>
-            <a:off x="7237476" y="2066544"/>
-            <a:ext cx="4155948" cy="457200"/>
-          </a:xfrm>
-          <a:prstGeom prst="rect">
-            <a:avLst/>
-          </a:prstGeom>
-          <a:noFill/>
-          <a:ln/>
-        </p:spPr>
-        <p:txBody>
-          <a:bodyPr wrap="square" lIns="0" tIns="0" rIns="0" bIns="0" rtlCol="0" anchor="t"/>
+            <a:off x="1572768" y="3456432"/>
+            <a:ext cx="6400800" cy="457200"/>
+          </a:xfrm>
+          <a:prstGeom prst="rect">
+            <a:avLst/>
+          </a:prstGeom>
+          <a:noFill/>
+          <a:ln/>
+        </p:spPr>
+        <p:txBody>
+          <a:bodyPr wrap="square" lIns="0" tIns="0" rIns="0" bIns="0" rtlCol="0" anchor="ctr"/>
           <a:lstStyle/>
           <a:p>
             <a:pPr indent="0" marL="0">
               <a:buNone/>
             </a:pPr>
             <a:r>
-              <a:rPr lang="en-US" sz="1550" b="1" dirty="0">
+              <a:rPr lang="en-US" sz="1700" b="1" dirty="0">
                 <a:solidFill>
                   <a:srgbClr val="0E1B3D"/>
                 </a:solidFill>
@@ -3684,9 +4828,23 @@
                 <a:ea typeface="Cambria" pitchFamily="34" charset="-122"/>
                 <a:cs typeface="Cambria" pitchFamily="34" charset="-120"/>
               </a:rPr>
-              <a:t>パッチ運用の徹底と棚卸し</a:t>
-            </a:r>
-            <a:endParaRPr lang="en-US" sz="1550" dirty="0"/>
+              <a:t>内側で検知   </a:t>
+            </a:r>
+            <a:pPr indent="0" marL="0">
+              <a:buNone/>
+            </a:pPr>
+            <a:r>
+              <a:rPr lang="en-US" sz="1300" b="1" dirty="0">
+                <a:solidFill>
+                  <a:srgbClr val="3E5C76"/>
+                </a:solidFill>
+                <a:latin typeface="Cambria" pitchFamily="34" charset="0"/>
+                <a:ea typeface="Cambria" pitchFamily="34" charset="-122"/>
+                <a:cs typeface="Cambria" pitchFamily="34" charset="-120"/>
+              </a:rPr>
+              <a:t>EDR(SentinelOne)</a:t>
+            </a:r>
+            <a:endParaRPr lang="en-US" sz="1700" dirty="0"/>
           </a:p>
         </p:txBody>
       </p:sp>
@@ -3698,8 +4856,8 @@
         </p:nvSpPr>
         <p:spPr>
           <a:xfrm>
-            <a:off x="7237476" y="2487168"/>
-            <a:ext cx="4155948" cy="502920"/>
+            <a:off x="1572768" y="3877056"/>
+            <a:ext cx="6400800" cy="457200"/>
           </a:xfrm>
           <a:prstGeom prst="rect">
             <a:avLst/>
@@ -3712,9 +4870,6 @@
           <a:lstStyle/>
           <a:p>
             <a:pPr indent="0" marL="0">
-              <a:lnSpc>
-                <a:spcPts val="1600"/>
-              </a:lnSpc>
               <a:buNone/>
             </a:pPr>
             <a:r>
@@ -3726,7 +4881,7 @@
                 <a:ea typeface="Calibri" pitchFamily="34" charset="-122"/>
                 <a:cs typeface="Calibri" pitchFamily="34" charset="-120"/>
               </a:rPr>
-              <a:t>侵入元の約半数は未パッチ。適用状況を継続的に可視化</a:t>
+              <a:t>侵入されても被害拡大を検知・抑制</a:t>
             </a:r>
             <a:endParaRPr lang="en-US" sz="1250" dirty="0"/>
           </a:p>
@@ -3740,12 +4895,12 @@
         </p:nvSpPr>
         <p:spPr>
           <a:xfrm>
-            <a:off x="566928" y="3246120"/>
-            <a:ext cx="5344668" cy="1143000"/>
+            <a:off x="566928" y="4608576"/>
+            <a:ext cx="7498080" cy="1097280"/>
           </a:xfrm>
           <a:prstGeom prst="roundRect">
             <a:avLst>
-              <a:gd name="adj" fmla="val 6400"/>
+              <a:gd name="adj" fmla="val 6667"/>
             </a:avLst>
           </a:prstGeom>
           <a:solidFill>
@@ -3774,14 +4929,14 @@
         </p:nvSpPr>
         <p:spPr>
           <a:xfrm>
-            <a:off x="795528" y="3529584"/>
-            <a:ext cx="566928" cy="566928"/>
+            <a:off x="795528" y="4864608"/>
+            <a:ext cx="585216" cy="585216"/>
           </a:xfrm>
           <a:prstGeom prst="ellipse">
             <a:avLst/>
           </a:prstGeom>
           <a:solidFill>
-            <a:srgbClr val="C8102E"/>
+            <a:srgbClr val="1E7A46"/>
           </a:solidFill>
           <a:ln/>
         </p:spPr>
@@ -3794,8 +4949,8 @@
         </p:nvSpPr>
         <p:spPr>
           <a:xfrm>
-            <a:off x="795528" y="3529584"/>
-            <a:ext cx="566928" cy="566928"/>
+            <a:off x="795528" y="4864608"/>
+            <a:ext cx="585216" cy="585216"/>
           </a:xfrm>
           <a:prstGeom prst="rect">
             <a:avLst/>
@@ -3833,24 +4988,24 @@
         </p:nvSpPr>
         <p:spPr>
           <a:xfrm>
-            <a:off x="1527048" y="3392424"/>
-            <a:ext cx="4155948" cy="457200"/>
-          </a:xfrm>
-          <a:prstGeom prst="rect">
-            <a:avLst/>
-          </a:prstGeom>
-          <a:noFill/>
-          <a:ln/>
-        </p:spPr>
-        <p:txBody>
-          <a:bodyPr wrap="square" lIns="0" tIns="0" rIns="0" bIns="0" rtlCol="0" anchor="t"/>
+            <a:off x="1572768" y="4754880"/>
+            <a:ext cx="6400800" cy="457200"/>
+          </a:xfrm>
+          <a:prstGeom prst="rect">
+            <a:avLst/>
+          </a:prstGeom>
+          <a:noFill/>
+          <a:ln/>
+        </p:spPr>
+        <p:txBody>
+          <a:bodyPr wrap="square" lIns="0" tIns="0" rIns="0" bIns="0" rtlCol="0" anchor="ctr"/>
           <a:lstStyle/>
           <a:p>
             <a:pPr indent="0" marL="0">
               <a:buNone/>
             </a:pPr>
             <a:r>
-              <a:rPr lang="en-US" sz="1550" b="1" dirty="0">
+              <a:rPr lang="en-US" sz="1700" b="1" dirty="0">
                 <a:solidFill>
                   <a:srgbClr val="0E1B3D"/>
                 </a:solidFill>
@@ -3858,9 +5013,23 @@
                 <a:ea typeface="Cambria" pitchFamily="34" charset="-122"/>
                 <a:cs typeface="Cambria" pitchFamily="34" charset="-120"/>
               </a:rPr>
-              <a:t>認証の強化（MFA・特権管理）</a:t>
-            </a:r>
-            <a:endParaRPr lang="en-US" sz="1550" dirty="0"/>
+              <a:t>備えと復旧   </a:t>
+            </a:r>
+            <a:pPr indent="0" marL="0">
+              <a:buNone/>
+            </a:pPr>
+            <a:r>
+              <a:rPr lang="en-US" sz="1300" b="1" dirty="0">
+                <a:solidFill>
+                  <a:srgbClr val="1E7A46"/>
+                </a:solidFill>
+                <a:latin typeface="Cambria" pitchFamily="34" charset="0"/>
+                <a:ea typeface="Cambria" pitchFamily="34" charset="-122"/>
+                <a:cs typeface="Cambria" pitchFamily="34" charset="-120"/>
+              </a:rPr>
+              <a:t>バックアップ・監視・訓練</a:t>
+            </a:r>
+            <a:endParaRPr lang="en-US" sz="1700" dirty="0"/>
           </a:p>
         </p:txBody>
       </p:sp>
@@ -3872,8 +5041,76 @@
         </p:nvSpPr>
         <p:spPr>
           <a:xfrm>
-            <a:off x="1527048" y="3813048"/>
-            <a:ext cx="4155948" cy="502920"/>
+            <a:off x="1572768" y="5175504"/>
+            <a:ext cx="6400800" cy="457200"/>
+          </a:xfrm>
+          <a:prstGeom prst="rect">
+            <a:avLst/>
+          </a:prstGeom>
+          <a:noFill/>
+          <a:ln/>
+        </p:spPr>
+        <p:txBody>
+          <a:bodyPr wrap="square" lIns="0" tIns="0" rIns="0" bIns="0" rtlCol="0" anchor="t"/>
+          <a:lstStyle/>
+          <a:p>
+            <a:pPr indent="0" marL="0">
+              <a:buNone/>
+            </a:pPr>
+            <a:r>
+              <a:rPr lang="en-US" sz="1250" dirty="0">
+                <a:solidFill>
+                  <a:srgbClr val="1A2332"/>
+                </a:solidFill>
+                <a:latin typeface="Calibri" pitchFamily="34" charset="0"/>
+                <a:ea typeface="Calibri" pitchFamily="34" charset="-122"/>
+                <a:cs typeface="Calibri" pitchFamily="34" charset="-120"/>
+              </a:rPr>
+              <a:t>最悪時に事業を止めない</a:t>
+            </a:r>
+            <a:endParaRPr lang="en-US" sz="1250" dirty="0"/>
+          </a:p>
+        </p:txBody>
+      </p:sp>
+      <p:sp>
+        <p:nvSpPr>
+          <p:cNvPr id="19" name="Shape 17"/>
+          <p:cNvSpPr/>
+          <p:nvPr/>
+        </p:nvSpPr>
+        <p:spPr>
+          <a:xfrm>
+            <a:off x="8366760" y="2011680"/>
+            <a:ext cx="3255264" cy="3712464"/>
+          </a:xfrm>
+          <a:prstGeom prst="roundRect">
+            <a:avLst>
+              <a:gd name="adj" fmla="val 2809"/>
+            </a:avLst>
+          </a:prstGeom>
+          <a:solidFill>
+            <a:srgbClr val="0E1B3D"/>
+          </a:solidFill>
+          <a:ln/>
+          <a:effectLst>
+            <a:outerShdw sx="100000" sy="100000" kx="0" ky="0" algn="bl" rotWithShape="0" blurRad="101600" dist="38100" dir="5400000">
+              <a:srgbClr val="8A93A6">
+                <a:alpha val="28000"/>
+              </a:srgbClr>
+            </a:outerShdw>
+          </a:effectLst>
+        </p:spPr>
+      </p:sp>
+      <p:sp>
+        <p:nvSpPr>
+          <p:cNvPr id="20" name="Text 18"/>
+          <p:cNvSpPr/>
+          <p:nvPr/>
+        </p:nvSpPr>
+        <p:spPr>
+          <a:xfrm>
+            <a:off x="8595360" y="2286000"/>
+            <a:ext cx="2779776" cy="3200400"/>
           </a:xfrm>
           <a:prstGeom prst="rect">
             <a:avLst/>
@@ -3887,34 +5124,229 @@
           <a:p>
             <a:pPr indent="0" marL="0">
               <a:lnSpc>
-                <a:spcPts val="1600"/>
+                <a:spcPts val="2000"/>
               </a:lnSpc>
-              <a:buNone/>
-            </a:pPr>
-            <a:r>
-              <a:rPr lang="en-US" sz="1250" dirty="0">
-                <a:solidFill>
-                  <a:srgbClr val="1A2332"/>
-                </a:solidFill>
-                <a:latin typeface="Calibri" pitchFamily="34" charset="0"/>
-                <a:ea typeface="Calibri" pitchFamily="34" charset="-122"/>
-                <a:cs typeface="Calibri" pitchFamily="34" charset="-120"/>
-              </a:rPr>
-              <a:t>盗まれた正規アカウントでの侵入を防ぐ。ADの保護を優先</a:t>
-            </a:r>
-            <a:endParaRPr lang="en-US" sz="1250" dirty="0"/>
-          </a:p>
-        </p:txBody>
-      </p:sp>
-      <p:sp>
-        <p:nvSpPr>
-          <p:cNvPr id="19" name="Shape 17"/>
-          <p:cNvSpPr/>
-          <p:nvPr/>
-        </p:nvSpPr>
-        <p:spPr>
-          <a:xfrm>
-            <a:off x="6277356" y="3246120"/>
+              <a:spcAft>
+                <a:spcPts val="1000"/>
+              </a:spcAft>
+              <a:buNone/>
+            </a:pPr>
+            <a:r>
+              <a:rPr lang="en-US" sz="1800" b="1" dirty="0">
+                <a:solidFill>
+                  <a:srgbClr val="FF6B81"/>
+                </a:solidFill>
+                <a:latin typeface="Calibri" pitchFamily="34" charset="0"/>
+                <a:ea typeface="Calibri" pitchFamily="34" charset="-122"/>
+                <a:cs typeface="Calibri" pitchFamily="34" charset="-120"/>
+              </a:rPr>
+              <a:t>S-1は層②。</a:t>
+            </a:r>
+            <a:endParaRPr lang="en-US" sz="1800" dirty="0"/>
+          </a:p>
+          <a:p>
+            <a:pPr indent="0" marL="0">
+              <a:lnSpc>
+                <a:spcPts val="2000"/>
+              </a:lnSpc>
+              <a:spcAft>
+                <a:spcPts val="1400"/>
+              </a:spcAft>
+              <a:buNone/>
+            </a:pPr>
+            <a:r>
+              <a:rPr lang="en-US" sz="1400" dirty="0">
+                <a:solidFill>
+                  <a:srgbClr val="DCE6F5"/>
+                </a:solidFill>
+                <a:latin typeface="Calibri" pitchFamily="34" charset="0"/>
+                <a:ea typeface="Calibri" pitchFamily="34" charset="-122"/>
+                <a:cs typeface="Calibri" pitchFamily="34" charset="-120"/>
+              </a:rPr>
+              <a:t>層①（入口）が抜けたままでは、攻撃者は容易に侵入し、層②を無効化しにいく。</a:t>
+            </a:r>
+            <a:endParaRPr lang="en-US" sz="1800" dirty="0"/>
+          </a:p>
+          <a:p>
+            <a:pPr indent="0" marL="0">
+              <a:lnSpc>
+                <a:spcPts val="2000"/>
+              </a:lnSpc>
+              <a:buNone/>
+            </a:pPr>
+            <a:r>
+              <a:rPr lang="en-US" sz="1400" b="1" dirty="0">
+                <a:solidFill>
+                  <a:srgbClr val="FFFFFF"/>
+                </a:solidFill>
+                <a:latin typeface="Calibri" pitchFamily="34" charset="0"/>
+                <a:ea typeface="Calibri" pitchFamily="34" charset="-122"/>
+                <a:cs typeface="Calibri" pitchFamily="34" charset="-120"/>
+              </a:rPr>
+              <a:t>脆弱性検査は層②を置き換えるものではなく、層②が守る前提となる層①を成立させるもの。</a:t>
+            </a:r>
+            <a:endParaRPr lang="en-US" sz="1800" dirty="0"/>
+          </a:p>
+        </p:txBody>
+      </p:sp>
+      <p:sp>
+        <p:nvSpPr>
+          <p:cNvPr id="21" name="Text 19"/>
+          <p:cNvSpPr/>
+          <p:nvPr/>
+        </p:nvSpPr>
+        <p:spPr>
+          <a:xfrm>
+            <a:off x="11411712" y="6400800"/>
+            <a:ext cx="457200" cy="274320"/>
+          </a:xfrm>
+          <a:prstGeom prst="rect">
+            <a:avLst/>
+          </a:prstGeom>
+          <a:noFill/>
+          <a:ln/>
+        </p:spPr>
+        <p:txBody>
+          <a:bodyPr wrap="square" lIns="0" tIns="0" rIns="0" bIns="0" rtlCol="0" anchor="ctr"/>
+          <a:lstStyle/>
+          <a:p>
+            <a:pPr algn="r" indent="0" marL="0">
+              <a:buNone/>
+            </a:pPr>
+            <a:r>
+              <a:rPr lang="en-US" sz="1000" dirty="0">
+                <a:solidFill>
+                  <a:srgbClr val="68738A"/>
+                </a:solidFill>
+                <a:latin typeface="Calibri" pitchFamily="34" charset="0"/>
+                <a:ea typeface="Calibri" pitchFamily="34" charset="-122"/>
+                <a:cs typeface="Calibri" pitchFamily="34" charset="-120"/>
+              </a:rPr>
+              <a:t>11</a:t>
+            </a:r>
+            <a:endParaRPr lang="en-US" sz="1000" dirty="0"/>
+          </a:p>
+        </p:txBody>
+      </p:sp>
+    </p:spTree>
+  </p:cSld>
+  <p:clrMapOvr>
+    <a:masterClrMapping/>
+  </p:clrMapOvr>
+</p:sld>
+</file>
+
+<file path=ppt/slides/slide12.xml><?xml version="1.0" encoding="utf-8"?>
+<p:sld xmlns:a="http://schemas.openxmlformats.org/drawingml/2006/main" xmlns:r="http://schemas.openxmlformats.org/officeDocument/2006/relationships" xmlns:p="http://schemas.openxmlformats.org/presentationml/2006/main">
+  <p:cSld name="Slide 12">
+    <p:bg>
+      <p:bgPr>
+        <a:solidFill>
+          <a:srgbClr val="FFFFFF"/>
+        </a:solidFill>
+      </p:bgPr>
+    </p:bg>
+    <p:spTree>
+      <p:nvGrpSpPr>
+        <p:cNvPr id="1" name=""/>
+        <p:cNvGrpSpPr/>
+        <p:nvPr/>
+      </p:nvGrpSpPr>
+      <p:grpSpPr>
+        <a:xfrm>
+          <a:off x="0" y="0"/>
+          <a:ext cx="0" cy="0"/>
+          <a:chOff x="0" y="0"/>
+          <a:chExt cx="0" cy="0"/>
+        </a:xfrm>
+      </p:grpSpPr>
+      <p:sp>
+        <p:nvSpPr>
+          <p:cNvPr id="2" name="Text 0"/>
+          <p:cNvSpPr/>
+          <p:nvPr/>
+        </p:nvSpPr>
+        <p:spPr>
+          <a:xfrm>
+            <a:off x="566928" y="384048"/>
+            <a:ext cx="8229600" cy="274320"/>
+          </a:xfrm>
+          <a:prstGeom prst="rect">
+            <a:avLst/>
+          </a:prstGeom>
+          <a:noFill/>
+          <a:ln/>
+        </p:spPr>
+        <p:txBody>
+          <a:bodyPr wrap="square" lIns="0" tIns="0" rIns="0" bIns="0" rtlCol="0" anchor="ctr"/>
+          <a:lstStyle/>
+          <a:p>
+            <a:pPr algn="l" indent="0" marL="0">
+              <a:buNone/>
+            </a:pPr>
+            <a:r>
+              <a:rPr lang="en-US" sz="1200" b="1" spc="300" kern="0" dirty="0">
+                <a:solidFill>
+                  <a:srgbClr val="C8102E"/>
+                </a:solidFill>
+                <a:latin typeface="Calibri" pitchFamily="34" charset="0"/>
+                <a:ea typeface="Calibri" pitchFamily="34" charset="-122"/>
+                <a:cs typeface="Calibri" pitchFamily="34" charset="-120"/>
+              </a:rPr>
+              <a:t>Aenaへの提言</a:t>
+            </a:r>
+            <a:endParaRPr lang="en-US" sz="1200" dirty="0"/>
+          </a:p>
+        </p:txBody>
+      </p:sp>
+      <p:sp>
+        <p:nvSpPr>
+          <p:cNvPr id="3" name="Text 1"/>
+          <p:cNvSpPr/>
+          <p:nvPr/>
+        </p:nvSpPr>
+        <p:spPr>
+          <a:xfrm>
+            <a:off x="566928" y="658368"/>
+            <a:ext cx="11055096" cy="868680"/>
+          </a:xfrm>
+          <a:prstGeom prst="rect">
+            <a:avLst/>
+          </a:prstGeom>
+          <a:noFill/>
+          <a:ln/>
+        </p:spPr>
+        <p:txBody>
+          <a:bodyPr wrap="square" lIns="0" tIns="0" rIns="0" bIns="0" rtlCol="0" anchor="t"/>
+          <a:lstStyle/>
+          <a:p>
+            <a:pPr algn="l" indent="0" marL="0">
+              <a:buNone/>
+            </a:pPr>
+            <a:r>
+              <a:rPr lang="en-US" sz="3200" b="1" dirty="0">
+                <a:solidFill>
+                  <a:srgbClr val="0E1B3D"/>
+                </a:solidFill>
+                <a:latin typeface="Cambria" pitchFamily="34" charset="0"/>
+                <a:ea typeface="Cambria" pitchFamily="34" charset="-122"/>
+                <a:cs typeface="Cambria" pitchFamily="34" charset="-120"/>
+              </a:rPr>
+              <a:t>S-1に加えて今すぐ着手したい5項目</a:t>
+            </a:r>
+            <a:endParaRPr lang="en-US" sz="3200" dirty="0"/>
+          </a:p>
+        </p:txBody>
+      </p:sp>
+      <p:sp>
+        <p:nvSpPr>
+          <p:cNvPr id="4" name="Shape 2"/>
+          <p:cNvSpPr/>
+          <p:nvPr/>
+        </p:nvSpPr>
+        <p:spPr>
+          <a:xfrm>
+            <a:off x="566928" y="1920240"/>
             <a:ext cx="5344668" cy="1143000"/>
           </a:xfrm>
           <a:prstGeom prst="roundRect">
@@ -3942,13 +5374,13 @@
       </p:sp>
       <p:sp>
         <p:nvSpPr>
-          <p:cNvPr id="20" name="Shape 18"/>
-          <p:cNvSpPr/>
-          <p:nvPr/>
-        </p:nvSpPr>
-        <p:spPr>
-          <a:xfrm>
-            <a:off x="6505956" y="3529584"/>
+          <p:cNvPr id="5" name="Shape 3"/>
+          <p:cNvSpPr/>
+          <p:nvPr/>
+        </p:nvSpPr>
+        <p:spPr>
+          <a:xfrm>
+            <a:off x="795528" y="2203704"/>
             <a:ext cx="566928" cy="566928"/>
           </a:xfrm>
           <a:prstGeom prst="ellipse">
@@ -3962,13 +5394,13 @@
       </p:sp>
       <p:sp>
         <p:nvSpPr>
-          <p:cNvPr id="21" name="Text 19"/>
-          <p:cNvSpPr/>
-          <p:nvPr/>
-        </p:nvSpPr>
-        <p:spPr>
-          <a:xfrm>
-            <a:off x="6505956" y="3529584"/>
+          <p:cNvPr id="6" name="Text 4"/>
+          <p:cNvSpPr/>
+          <p:nvPr/>
+        </p:nvSpPr>
+        <p:spPr>
+          <a:xfrm>
+            <a:off x="795528" y="2203704"/>
             <a:ext cx="566928" cy="566928"/>
           </a:xfrm>
           <a:prstGeom prst="rect">
@@ -3993,7 +5425,7 @@
                 <a:ea typeface="Cambria" pitchFamily="34" charset="-122"/>
                 <a:cs typeface="Cambria" pitchFamily="34" charset="-120"/>
               </a:rPr>
-              <a:t>4</a:t>
+              <a:t>1</a:t>
             </a:r>
             <a:endParaRPr lang="en-US" sz="2200" dirty="0"/>
           </a:p>
@@ -4001,13 +5433,13 @@
       </p:sp>
       <p:sp>
         <p:nvSpPr>
-          <p:cNvPr id="22" name="Text 20"/>
-          <p:cNvSpPr/>
-          <p:nvPr/>
-        </p:nvSpPr>
-        <p:spPr>
-          <a:xfrm>
-            <a:off x="7237476" y="3392424"/>
+          <p:cNvPr id="7" name="Text 5"/>
+          <p:cNvSpPr/>
+          <p:nvPr/>
+        </p:nvSpPr>
+        <p:spPr>
+          <a:xfrm>
+            <a:off x="1527048" y="2066544"/>
             <a:ext cx="4155948" cy="457200"/>
           </a:xfrm>
           <a:prstGeom prst="rect">
@@ -4032,7 +5464,7 @@
                 <a:ea typeface="Cambria" pitchFamily="34" charset="-122"/>
                 <a:cs typeface="Cambria" pitchFamily="34" charset="-120"/>
               </a:rPr>
-              <a:t>SentinelOneの堅牢化設定</a:t>
+              <a:t>外部公開資産の脆弱性検査を定期実施</a:t>
             </a:r>
             <a:endParaRPr lang="en-US" sz="1550" dirty="0"/>
           </a:p>
@@ -4040,13 +5472,13 @@
       </p:sp>
       <p:sp>
         <p:nvSpPr>
-          <p:cNvPr id="23" name="Text 21"/>
-          <p:cNvSpPr/>
-          <p:nvPr/>
-        </p:nvSpPr>
-        <p:spPr>
-          <a:xfrm>
-            <a:off x="7237476" y="3813048"/>
+          <p:cNvPr id="8" name="Text 6"/>
+          <p:cNvSpPr/>
+          <p:nvPr/>
+        </p:nvSpPr>
+        <p:spPr>
+          <a:xfrm>
+            <a:off x="1527048" y="2487168"/>
             <a:ext cx="4155948" cy="502920"/>
           </a:xfrm>
           <a:prstGeom prst="rect">
@@ -4074,7 +5506,7 @@
                 <a:ea typeface="Calibri" pitchFamily="34" charset="-122"/>
                 <a:cs typeface="Calibri" pitchFamily="34" charset="-120"/>
               </a:rPr>
-              <a:t>Online Authorization等で無効化・改ざん回避を難しくする</a:t>
+              <a:t>VPN・公開サーバ・Webを対象に、悪用可能な入口を洗い出す</a:t>
             </a:r>
             <a:endParaRPr lang="en-US" sz="1250" dirty="0"/>
           </a:p>
@@ -4082,14 +5514,14 @@
       </p:sp>
       <p:sp>
         <p:nvSpPr>
-          <p:cNvPr id="24" name="Shape 22"/>
-          <p:cNvSpPr/>
-          <p:nvPr/>
-        </p:nvSpPr>
-        <p:spPr>
-          <a:xfrm>
-            <a:off x="566928" y="4572000"/>
-            <a:ext cx="11055096" cy="1143000"/>
+          <p:cNvPr id="9" name="Shape 7"/>
+          <p:cNvSpPr/>
+          <p:nvPr/>
+        </p:nvSpPr>
+        <p:spPr>
+          <a:xfrm>
+            <a:off x="6277356" y="1920240"/>
+            <a:ext cx="5344668" cy="1143000"/>
           </a:xfrm>
           <a:prstGeom prst="roundRect">
             <a:avLst>
@@ -4116,13 +5548,13 @@
       </p:sp>
       <p:sp>
         <p:nvSpPr>
-          <p:cNvPr id="25" name="Shape 23"/>
-          <p:cNvSpPr/>
-          <p:nvPr/>
-        </p:nvSpPr>
-        <p:spPr>
-          <a:xfrm>
-            <a:off x="795528" y="4855464"/>
+          <p:cNvPr id="10" name="Shape 8"/>
+          <p:cNvSpPr/>
+          <p:nvPr/>
+        </p:nvSpPr>
+        <p:spPr>
+          <a:xfrm>
+            <a:off x="6505956" y="2203704"/>
             <a:ext cx="566928" cy="566928"/>
           </a:xfrm>
           <a:prstGeom prst="ellipse">
@@ -4136,13 +5568,13 @@
       </p:sp>
       <p:sp>
         <p:nvSpPr>
-          <p:cNvPr id="26" name="Text 24"/>
-          <p:cNvSpPr/>
-          <p:nvPr/>
-        </p:nvSpPr>
-        <p:spPr>
-          <a:xfrm>
-            <a:off x="795528" y="4855464"/>
+          <p:cNvPr id="11" name="Text 9"/>
+          <p:cNvSpPr/>
+          <p:nvPr/>
+        </p:nvSpPr>
+        <p:spPr>
+          <a:xfrm>
+            <a:off x="6505956" y="2203704"/>
             <a:ext cx="566928" cy="566928"/>
           </a:xfrm>
           <a:prstGeom prst="rect">
@@ -4167,7 +5599,7 @@
                 <a:ea typeface="Cambria" pitchFamily="34" charset="-122"/>
                 <a:cs typeface="Cambria" pitchFamily="34" charset="-120"/>
               </a:rPr>
-              <a:t>5</a:t>
+              <a:t>2</a:t>
             </a:r>
             <a:endParaRPr lang="en-US" sz="2200" dirty="0"/>
           </a:p>
@@ -4175,14 +5607,14 @@
       </p:sp>
       <p:sp>
         <p:nvSpPr>
-          <p:cNvPr id="27" name="Text 25"/>
-          <p:cNvSpPr/>
-          <p:nvPr/>
-        </p:nvSpPr>
-        <p:spPr>
-          <a:xfrm>
-            <a:off x="1527048" y="4718304"/>
-            <a:ext cx="9866376" cy="457200"/>
+          <p:cNvPr id="12" name="Text 10"/>
+          <p:cNvSpPr/>
+          <p:nvPr/>
+        </p:nvSpPr>
+        <p:spPr>
+          <a:xfrm>
+            <a:off x="7237476" y="2066544"/>
+            <a:ext cx="4155948" cy="457200"/>
           </a:xfrm>
           <a:prstGeom prst="rect">
             <a:avLst/>
@@ -4206,7 +5638,7 @@
                 <a:ea typeface="Cambria" pitchFamily="34" charset="-122"/>
                 <a:cs typeface="Cambria" pitchFamily="34" charset="-120"/>
               </a:rPr>
-              <a:t>バックアップと復旧訓練</a:t>
+              <a:t>パッチ運用の徹底と棚卸し</a:t>
             </a:r>
             <a:endParaRPr lang="en-US" sz="1550" dirty="0"/>
           </a:p>
@@ -4214,14 +5646,14 @@
       </p:sp>
       <p:sp>
         <p:nvSpPr>
-          <p:cNvPr id="28" name="Text 26"/>
-          <p:cNvSpPr/>
-          <p:nvPr/>
-        </p:nvSpPr>
-        <p:spPr>
-          <a:xfrm>
-            <a:off x="1527048" y="5138928"/>
-            <a:ext cx="9866376" cy="502920"/>
+          <p:cNvPr id="13" name="Text 11"/>
+          <p:cNvSpPr/>
+          <p:nvPr/>
+        </p:nvSpPr>
+        <p:spPr>
+          <a:xfrm>
+            <a:off x="7237476" y="2487168"/>
+            <a:ext cx="4155948" cy="502920"/>
           </a:xfrm>
           <a:prstGeom prst="rect">
             <a:avLst/>
@@ -4248,6 +5680,528 @@
                 <a:ea typeface="Calibri" pitchFamily="34" charset="-122"/>
                 <a:cs typeface="Calibri" pitchFamily="34" charset="-120"/>
               </a:rPr>
+              <a:t>侵入元の約半数は未パッチ。適用状況を継続的に可視化</a:t>
+            </a:r>
+            <a:endParaRPr lang="en-US" sz="1250" dirty="0"/>
+          </a:p>
+        </p:txBody>
+      </p:sp>
+      <p:sp>
+        <p:nvSpPr>
+          <p:cNvPr id="14" name="Shape 12"/>
+          <p:cNvSpPr/>
+          <p:nvPr/>
+        </p:nvSpPr>
+        <p:spPr>
+          <a:xfrm>
+            <a:off x="566928" y="3246120"/>
+            <a:ext cx="5344668" cy="1143000"/>
+          </a:xfrm>
+          <a:prstGeom prst="roundRect">
+            <a:avLst>
+              <a:gd name="adj" fmla="val 6400"/>
+            </a:avLst>
+          </a:prstGeom>
+          <a:solidFill>
+            <a:srgbClr val="F4F6FB"/>
+          </a:solidFill>
+          <a:ln w="12700">
+            <a:solidFill>
+              <a:srgbClr val="E2E8F4"/>
+            </a:solidFill>
+            <a:prstDash val="solid"/>
+          </a:ln>
+          <a:effectLst>
+            <a:outerShdw sx="100000" sy="100000" kx="0" ky="0" algn="bl" rotWithShape="0" blurRad="101600" dist="38100" dir="5400000">
+              <a:srgbClr val="8A93A6">
+                <a:alpha val="28000"/>
+              </a:srgbClr>
+            </a:outerShdw>
+          </a:effectLst>
+        </p:spPr>
+      </p:sp>
+      <p:sp>
+        <p:nvSpPr>
+          <p:cNvPr id="15" name="Shape 13"/>
+          <p:cNvSpPr/>
+          <p:nvPr/>
+        </p:nvSpPr>
+        <p:spPr>
+          <a:xfrm>
+            <a:off x="795528" y="3529584"/>
+            <a:ext cx="566928" cy="566928"/>
+          </a:xfrm>
+          <a:prstGeom prst="ellipse">
+            <a:avLst/>
+          </a:prstGeom>
+          <a:solidFill>
+            <a:srgbClr val="C8102E"/>
+          </a:solidFill>
+          <a:ln/>
+        </p:spPr>
+      </p:sp>
+      <p:sp>
+        <p:nvSpPr>
+          <p:cNvPr id="16" name="Text 14"/>
+          <p:cNvSpPr/>
+          <p:nvPr/>
+        </p:nvSpPr>
+        <p:spPr>
+          <a:xfrm>
+            <a:off x="795528" y="3529584"/>
+            <a:ext cx="566928" cy="566928"/>
+          </a:xfrm>
+          <a:prstGeom prst="rect">
+            <a:avLst/>
+          </a:prstGeom>
+          <a:noFill/>
+          <a:ln/>
+        </p:spPr>
+        <p:txBody>
+          <a:bodyPr wrap="square" lIns="0" tIns="0" rIns="0" bIns="0" rtlCol="0" anchor="ctr"/>
+          <a:lstStyle/>
+          <a:p>
+            <a:pPr algn="ctr" indent="0" marL="0">
+              <a:buNone/>
+            </a:pPr>
+            <a:r>
+              <a:rPr lang="en-US" sz="2200" b="1" dirty="0">
+                <a:solidFill>
+                  <a:srgbClr val="FFFFFF"/>
+                </a:solidFill>
+                <a:latin typeface="Cambria" pitchFamily="34" charset="0"/>
+                <a:ea typeface="Cambria" pitchFamily="34" charset="-122"/>
+                <a:cs typeface="Cambria" pitchFamily="34" charset="-120"/>
+              </a:rPr>
+              <a:t>3</a:t>
+            </a:r>
+            <a:endParaRPr lang="en-US" sz="2200" dirty="0"/>
+          </a:p>
+        </p:txBody>
+      </p:sp>
+      <p:sp>
+        <p:nvSpPr>
+          <p:cNvPr id="17" name="Text 15"/>
+          <p:cNvSpPr/>
+          <p:nvPr/>
+        </p:nvSpPr>
+        <p:spPr>
+          <a:xfrm>
+            <a:off x="1527048" y="3392424"/>
+            <a:ext cx="4155948" cy="457200"/>
+          </a:xfrm>
+          <a:prstGeom prst="rect">
+            <a:avLst/>
+          </a:prstGeom>
+          <a:noFill/>
+          <a:ln/>
+        </p:spPr>
+        <p:txBody>
+          <a:bodyPr wrap="square" lIns="0" tIns="0" rIns="0" bIns="0" rtlCol="0" anchor="t"/>
+          <a:lstStyle/>
+          <a:p>
+            <a:pPr indent="0" marL="0">
+              <a:buNone/>
+            </a:pPr>
+            <a:r>
+              <a:rPr lang="en-US" sz="1550" b="1" dirty="0">
+                <a:solidFill>
+                  <a:srgbClr val="0E1B3D"/>
+                </a:solidFill>
+                <a:latin typeface="Cambria" pitchFamily="34" charset="0"/>
+                <a:ea typeface="Cambria" pitchFamily="34" charset="-122"/>
+                <a:cs typeface="Cambria" pitchFamily="34" charset="-120"/>
+              </a:rPr>
+              <a:t>認証の強化（MFA・特権管理）</a:t>
+            </a:r>
+            <a:endParaRPr lang="en-US" sz="1550" dirty="0"/>
+          </a:p>
+        </p:txBody>
+      </p:sp>
+      <p:sp>
+        <p:nvSpPr>
+          <p:cNvPr id="18" name="Text 16"/>
+          <p:cNvSpPr/>
+          <p:nvPr/>
+        </p:nvSpPr>
+        <p:spPr>
+          <a:xfrm>
+            <a:off x="1527048" y="3813048"/>
+            <a:ext cx="4155948" cy="502920"/>
+          </a:xfrm>
+          <a:prstGeom prst="rect">
+            <a:avLst/>
+          </a:prstGeom>
+          <a:noFill/>
+          <a:ln/>
+        </p:spPr>
+        <p:txBody>
+          <a:bodyPr wrap="square" lIns="0" tIns="0" rIns="0" bIns="0" rtlCol="0" anchor="t"/>
+          <a:lstStyle/>
+          <a:p>
+            <a:pPr indent="0" marL="0">
+              <a:lnSpc>
+                <a:spcPts val="1600"/>
+              </a:lnSpc>
+              <a:buNone/>
+            </a:pPr>
+            <a:r>
+              <a:rPr lang="en-US" sz="1250" dirty="0">
+                <a:solidFill>
+                  <a:srgbClr val="1A2332"/>
+                </a:solidFill>
+                <a:latin typeface="Calibri" pitchFamily="34" charset="0"/>
+                <a:ea typeface="Calibri" pitchFamily="34" charset="-122"/>
+                <a:cs typeface="Calibri" pitchFamily="34" charset="-120"/>
+              </a:rPr>
+              <a:t>盗まれた正規アカウントでの侵入を防ぐ。ADの保護を優先</a:t>
+            </a:r>
+            <a:endParaRPr lang="en-US" sz="1250" dirty="0"/>
+          </a:p>
+        </p:txBody>
+      </p:sp>
+      <p:sp>
+        <p:nvSpPr>
+          <p:cNvPr id="19" name="Shape 17"/>
+          <p:cNvSpPr/>
+          <p:nvPr/>
+        </p:nvSpPr>
+        <p:spPr>
+          <a:xfrm>
+            <a:off x="6277356" y="3246120"/>
+            <a:ext cx="5344668" cy="1143000"/>
+          </a:xfrm>
+          <a:prstGeom prst="roundRect">
+            <a:avLst>
+              <a:gd name="adj" fmla="val 6400"/>
+            </a:avLst>
+          </a:prstGeom>
+          <a:solidFill>
+            <a:srgbClr val="F4F6FB"/>
+          </a:solidFill>
+          <a:ln w="12700">
+            <a:solidFill>
+              <a:srgbClr val="E2E8F4"/>
+            </a:solidFill>
+            <a:prstDash val="solid"/>
+          </a:ln>
+          <a:effectLst>
+            <a:outerShdw sx="100000" sy="100000" kx="0" ky="0" algn="bl" rotWithShape="0" blurRad="101600" dist="38100" dir="5400000">
+              <a:srgbClr val="8A93A6">
+                <a:alpha val="28000"/>
+              </a:srgbClr>
+            </a:outerShdw>
+          </a:effectLst>
+        </p:spPr>
+      </p:sp>
+      <p:sp>
+        <p:nvSpPr>
+          <p:cNvPr id="20" name="Shape 18"/>
+          <p:cNvSpPr/>
+          <p:nvPr/>
+        </p:nvSpPr>
+        <p:spPr>
+          <a:xfrm>
+            <a:off x="6505956" y="3529584"/>
+            <a:ext cx="566928" cy="566928"/>
+          </a:xfrm>
+          <a:prstGeom prst="ellipse">
+            <a:avLst/>
+          </a:prstGeom>
+          <a:solidFill>
+            <a:srgbClr val="C8102E"/>
+          </a:solidFill>
+          <a:ln/>
+        </p:spPr>
+      </p:sp>
+      <p:sp>
+        <p:nvSpPr>
+          <p:cNvPr id="21" name="Text 19"/>
+          <p:cNvSpPr/>
+          <p:nvPr/>
+        </p:nvSpPr>
+        <p:spPr>
+          <a:xfrm>
+            <a:off x="6505956" y="3529584"/>
+            <a:ext cx="566928" cy="566928"/>
+          </a:xfrm>
+          <a:prstGeom prst="rect">
+            <a:avLst/>
+          </a:prstGeom>
+          <a:noFill/>
+          <a:ln/>
+        </p:spPr>
+        <p:txBody>
+          <a:bodyPr wrap="square" lIns="0" tIns="0" rIns="0" bIns="0" rtlCol="0" anchor="ctr"/>
+          <a:lstStyle/>
+          <a:p>
+            <a:pPr algn="ctr" indent="0" marL="0">
+              <a:buNone/>
+            </a:pPr>
+            <a:r>
+              <a:rPr lang="en-US" sz="2200" b="1" dirty="0">
+                <a:solidFill>
+                  <a:srgbClr val="FFFFFF"/>
+                </a:solidFill>
+                <a:latin typeface="Cambria" pitchFamily="34" charset="0"/>
+                <a:ea typeface="Cambria" pitchFamily="34" charset="-122"/>
+                <a:cs typeface="Cambria" pitchFamily="34" charset="-120"/>
+              </a:rPr>
+              <a:t>4</a:t>
+            </a:r>
+            <a:endParaRPr lang="en-US" sz="2200" dirty="0"/>
+          </a:p>
+        </p:txBody>
+      </p:sp>
+      <p:sp>
+        <p:nvSpPr>
+          <p:cNvPr id="22" name="Text 20"/>
+          <p:cNvSpPr/>
+          <p:nvPr/>
+        </p:nvSpPr>
+        <p:spPr>
+          <a:xfrm>
+            <a:off x="7237476" y="3392424"/>
+            <a:ext cx="4155948" cy="457200"/>
+          </a:xfrm>
+          <a:prstGeom prst="rect">
+            <a:avLst/>
+          </a:prstGeom>
+          <a:noFill/>
+          <a:ln/>
+        </p:spPr>
+        <p:txBody>
+          <a:bodyPr wrap="square" lIns="0" tIns="0" rIns="0" bIns="0" rtlCol="0" anchor="t"/>
+          <a:lstStyle/>
+          <a:p>
+            <a:pPr indent="0" marL="0">
+              <a:buNone/>
+            </a:pPr>
+            <a:r>
+              <a:rPr lang="en-US" sz="1550" b="1" dirty="0">
+                <a:solidFill>
+                  <a:srgbClr val="0E1B3D"/>
+                </a:solidFill>
+                <a:latin typeface="Cambria" pitchFamily="34" charset="0"/>
+                <a:ea typeface="Cambria" pitchFamily="34" charset="-122"/>
+                <a:cs typeface="Cambria" pitchFamily="34" charset="-120"/>
+              </a:rPr>
+              <a:t>SentinelOneの堅牢化設定</a:t>
+            </a:r>
+            <a:endParaRPr lang="en-US" sz="1550" dirty="0"/>
+          </a:p>
+        </p:txBody>
+      </p:sp>
+      <p:sp>
+        <p:nvSpPr>
+          <p:cNvPr id="23" name="Text 21"/>
+          <p:cNvSpPr/>
+          <p:nvPr/>
+        </p:nvSpPr>
+        <p:spPr>
+          <a:xfrm>
+            <a:off x="7237476" y="3813048"/>
+            <a:ext cx="4155948" cy="502920"/>
+          </a:xfrm>
+          <a:prstGeom prst="rect">
+            <a:avLst/>
+          </a:prstGeom>
+          <a:noFill/>
+          <a:ln/>
+        </p:spPr>
+        <p:txBody>
+          <a:bodyPr wrap="square" lIns="0" tIns="0" rIns="0" bIns="0" rtlCol="0" anchor="t"/>
+          <a:lstStyle/>
+          <a:p>
+            <a:pPr indent="0" marL="0">
+              <a:lnSpc>
+                <a:spcPts val="1600"/>
+              </a:lnSpc>
+              <a:buNone/>
+            </a:pPr>
+            <a:r>
+              <a:rPr lang="en-US" sz="1250" dirty="0">
+                <a:solidFill>
+                  <a:srgbClr val="1A2332"/>
+                </a:solidFill>
+                <a:latin typeface="Calibri" pitchFamily="34" charset="0"/>
+                <a:ea typeface="Calibri" pitchFamily="34" charset="-122"/>
+                <a:cs typeface="Calibri" pitchFamily="34" charset="-120"/>
+              </a:rPr>
+              <a:t>Online Authorization等で無効化・改ざん回避を難しくする</a:t>
+            </a:r>
+            <a:endParaRPr lang="en-US" sz="1250" dirty="0"/>
+          </a:p>
+        </p:txBody>
+      </p:sp>
+      <p:sp>
+        <p:nvSpPr>
+          <p:cNvPr id="24" name="Shape 22"/>
+          <p:cNvSpPr/>
+          <p:nvPr/>
+        </p:nvSpPr>
+        <p:spPr>
+          <a:xfrm>
+            <a:off x="566928" y="4572000"/>
+            <a:ext cx="11055096" cy="1143000"/>
+          </a:xfrm>
+          <a:prstGeom prst="roundRect">
+            <a:avLst>
+              <a:gd name="adj" fmla="val 6400"/>
+            </a:avLst>
+          </a:prstGeom>
+          <a:solidFill>
+            <a:srgbClr val="F4F6FB"/>
+          </a:solidFill>
+          <a:ln w="12700">
+            <a:solidFill>
+              <a:srgbClr val="E2E8F4"/>
+            </a:solidFill>
+            <a:prstDash val="solid"/>
+          </a:ln>
+          <a:effectLst>
+            <a:outerShdw sx="100000" sy="100000" kx="0" ky="0" algn="bl" rotWithShape="0" blurRad="101600" dist="38100" dir="5400000">
+              <a:srgbClr val="8A93A6">
+                <a:alpha val="28000"/>
+              </a:srgbClr>
+            </a:outerShdw>
+          </a:effectLst>
+        </p:spPr>
+      </p:sp>
+      <p:sp>
+        <p:nvSpPr>
+          <p:cNvPr id="25" name="Shape 23"/>
+          <p:cNvSpPr/>
+          <p:nvPr/>
+        </p:nvSpPr>
+        <p:spPr>
+          <a:xfrm>
+            <a:off x="795528" y="4855464"/>
+            <a:ext cx="566928" cy="566928"/>
+          </a:xfrm>
+          <a:prstGeom prst="ellipse">
+            <a:avLst/>
+          </a:prstGeom>
+          <a:solidFill>
+            <a:srgbClr val="C8102E"/>
+          </a:solidFill>
+          <a:ln/>
+        </p:spPr>
+      </p:sp>
+      <p:sp>
+        <p:nvSpPr>
+          <p:cNvPr id="26" name="Text 24"/>
+          <p:cNvSpPr/>
+          <p:nvPr/>
+        </p:nvSpPr>
+        <p:spPr>
+          <a:xfrm>
+            <a:off x="795528" y="4855464"/>
+            <a:ext cx="566928" cy="566928"/>
+          </a:xfrm>
+          <a:prstGeom prst="rect">
+            <a:avLst/>
+          </a:prstGeom>
+          <a:noFill/>
+          <a:ln/>
+        </p:spPr>
+        <p:txBody>
+          <a:bodyPr wrap="square" lIns="0" tIns="0" rIns="0" bIns="0" rtlCol="0" anchor="ctr"/>
+          <a:lstStyle/>
+          <a:p>
+            <a:pPr algn="ctr" indent="0" marL="0">
+              <a:buNone/>
+            </a:pPr>
+            <a:r>
+              <a:rPr lang="en-US" sz="2200" b="1" dirty="0">
+                <a:solidFill>
+                  <a:srgbClr val="FFFFFF"/>
+                </a:solidFill>
+                <a:latin typeface="Cambria" pitchFamily="34" charset="0"/>
+                <a:ea typeface="Cambria" pitchFamily="34" charset="-122"/>
+                <a:cs typeface="Cambria" pitchFamily="34" charset="-120"/>
+              </a:rPr>
+              <a:t>5</a:t>
+            </a:r>
+            <a:endParaRPr lang="en-US" sz="2200" dirty="0"/>
+          </a:p>
+        </p:txBody>
+      </p:sp>
+      <p:sp>
+        <p:nvSpPr>
+          <p:cNvPr id="27" name="Text 25"/>
+          <p:cNvSpPr/>
+          <p:nvPr/>
+        </p:nvSpPr>
+        <p:spPr>
+          <a:xfrm>
+            <a:off x="1527048" y="4718304"/>
+            <a:ext cx="9866376" cy="457200"/>
+          </a:xfrm>
+          <a:prstGeom prst="rect">
+            <a:avLst/>
+          </a:prstGeom>
+          <a:noFill/>
+          <a:ln/>
+        </p:spPr>
+        <p:txBody>
+          <a:bodyPr wrap="square" lIns="0" tIns="0" rIns="0" bIns="0" rtlCol="0" anchor="t"/>
+          <a:lstStyle/>
+          <a:p>
+            <a:pPr indent="0" marL="0">
+              <a:buNone/>
+            </a:pPr>
+            <a:r>
+              <a:rPr lang="en-US" sz="1550" b="1" dirty="0">
+                <a:solidFill>
+                  <a:srgbClr val="0E1B3D"/>
+                </a:solidFill>
+                <a:latin typeface="Cambria" pitchFamily="34" charset="0"/>
+                <a:ea typeface="Cambria" pitchFamily="34" charset="-122"/>
+                <a:cs typeface="Cambria" pitchFamily="34" charset="-120"/>
+              </a:rPr>
+              <a:t>バックアップと復旧訓練</a:t>
+            </a:r>
+            <a:endParaRPr lang="en-US" sz="1550" dirty="0"/>
+          </a:p>
+        </p:txBody>
+      </p:sp>
+      <p:sp>
+        <p:nvSpPr>
+          <p:cNvPr id="28" name="Text 26"/>
+          <p:cNvSpPr/>
+          <p:nvPr/>
+        </p:nvSpPr>
+        <p:spPr>
+          <a:xfrm>
+            <a:off x="1527048" y="5138928"/>
+            <a:ext cx="9866376" cy="502920"/>
+          </a:xfrm>
+          <a:prstGeom prst="rect">
+            <a:avLst/>
+          </a:prstGeom>
+          <a:noFill/>
+          <a:ln/>
+        </p:spPr>
+        <p:txBody>
+          <a:bodyPr wrap="square" lIns="0" tIns="0" rIns="0" bIns="0" rtlCol="0" anchor="t"/>
+          <a:lstStyle/>
+          <a:p>
+            <a:pPr indent="0" marL="0">
+              <a:lnSpc>
+                <a:spcPts val="1600"/>
+              </a:lnSpc>
+              <a:buNone/>
+            </a:pPr>
+            <a:r>
+              <a:rPr lang="en-US" sz="1250" dirty="0">
+                <a:solidFill>
+                  <a:srgbClr val="1A2332"/>
+                </a:solidFill>
+                <a:latin typeface="Calibri" pitchFamily="34" charset="0"/>
+                <a:ea typeface="Calibri" pitchFamily="34" charset="-122"/>
+                <a:cs typeface="Calibri" pitchFamily="34" charset="-120"/>
+              </a:rPr>
               <a:t>暗号化されても事業を止めない。オフライン保管と定期演習</a:t>
             </a:r>
             <a:endParaRPr lang="en-US" sz="1250" dirty="0"/>
@@ -4287,7 +6241,7 @@
                 <a:ea typeface="Calibri" pitchFamily="34" charset="-122"/>
                 <a:cs typeface="Calibri" pitchFamily="34" charset="-120"/>
               </a:rPr>
-              <a:t>11</a:t>
+              <a:t>12</a:t>
             </a:r>
             <a:endParaRPr lang="en-US" sz="1000" dirty="0"/>
           </a:p>
@@ -4301,9 +6255,9 @@
 </p:sld>
 </file>
 
-<file path=ppt/slides/slide12.xml><?xml version="1.0" encoding="utf-8"?>
+<file path=ppt/slides/slide13.xml><?xml version="1.0" encoding="utf-8"?>
 <p:sld xmlns:a="http://schemas.openxmlformats.org/drawingml/2006/main" xmlns:r="http://schemas.openxmlformats.org/officeDocument/2006/relationships" xmlns:p="http://schemas.openxmlformats.org/presentationml/2006/main">
-  <p:cSld name="Slide 12">
+  <p:cSld name="Slide 13">
     <p:bg>
       <p:bgPr>
         <a:solidFill>
@@ -4640,7 +6594,7 @@
                 <a:ea typeface="Calibri" pitchFamily="34" charset="-122"/>
                 <a:cs typeface="Calibri" pitchFamily="34" charset="-120"/>
               </a:rPr>
-              <a:t>12</a:t>
+              <a:t>13</a:t>
             </a:r>
             <a:endParaRPr lang="en-US" sz="1000" dirty="0"/>
           </a:p>
@@ -4654,9 +6608,9 @@
 </p:sld>
 </file>
 
-<file path=ppt/slides/slide13.xml><?xml version="1.0" encoding="utf-8"?>
+<file path=ppt/slides/slide14.xml><?xml version="1.0" encoding="utf-8"?>
 <p:sld xmlns:a="http://schemas.openxmlformats.org/drawingml/2006/main" xmlns:r="http://schemas.openxmlformats.org/officeDocument/2006/relationships" xmlns:p="http://schemas.openxmlformats.org/presentationml/2006/main">
-  <p:cSld name="Slide 13">
+  <p:cSld name="Slide 14">
     <p:bg>
       <p:bgPr>
         <a:solidFill>
@@ -5018,7 +6972,7 @@
                 <a:ea typeface="Calibri" pitchFamily="34" charset="-122"/>
                 <a:cs typeface="Calibri" pitchFamily="34" charset="-120"/>
               </a:rPr>
-              <a:t>13</a:t>
+              <a:t>14</a:t>
             </a:r>
             <a:endParaRPr lang="en-US" sz="1000" dirty="0"/>
           </a:p>

</xml_diff>

<commit_message>
Generalize auth backend to AD/SQL, add SQL-auth credential-theft slide, note S-1 BYOI remediation status
- スライド4/10: 「AD管理者権限奪取」→「認証基盤（AD／SQL認証DB）の権限奪取」に一般化
- スライド11を新設: 「SQL認証でも認証情報は盗まれる 5つの経路」(SQLi/弱い保存/DB直接侵害/接続文字列散在/sa悪用)
- スライド7: BYOI緩和策は2025年1月提供・既存導入は既定OFFで手動有効化が必要、と注記
- 全15スライドに更新、memory/context.md を更新

Co-Authored-By: Claude Opus 4.8 <noreply@anthropic.com>
Claude-Session: https://claude.ai/code/session_01EA4xD6dzVHyb75mdD2BWfh
</commit_message>
<xml_diff>
--- a/成果物/SentinelOne導入後も脆弱性検査が必要な理由.pptx
+++ b/成果物/SentinelOne導入後も脆弱性検査が必要な理由.pptx
@@ -19,9 +19,10 @@
     <p:sldId id="267" r:id="rId13"/>
     <p:sldId id="268" r:id="rId14"/>
     <p:sldId id="269" r:id="rId15"/>
+    <p:sldId id="270" r:id="rId16"/>
   </p:sldIdLst>
   <p:notesMasterIdLst>
-    <p:notesMasterId r:id="rId16"/>
+    <p:notesMasterId r:id="rId17"/>
   </p:notesMasterIdLst>
   <p:sldSz cx="12192000" cy="6858000"/>
   <p:notesSz cx="6858000" cy="12192000"/>
@@ -1243,6 +1244,94 @@
             <a:fld id="{F7021451-1387-4CA6-816F-3879F97B5CBC}" type="slidenum">
               <a:rPr lang="en-US"/>
               <a:t>14</a:t>
+            </a:fld>
+            <a:endParaRPr lang="en-US"/>
+          </a:p>
+        </p:txBody>
+      </p:sp>
+    </p:spTree>
+    <p:extLst>
+      <p:ext uri="{BB962C8B-B14F-4D97-AF65-F5344CB8AC3E}">
+        <p14:creationId xmlns:p14="http://schemas.microsoft.com/office/powerpoint/2010/main" val="1024086991"/>
+      </p:ext>
+    </p:extLst>
+  </p:cSld>
+  <p:clrMapOvr>
+    <a:masterClrMapping/>
+  </p:clrMapOvr>
+</p:notes>
+</file>
+
+<file path=ppt/notesSlides/notesSlide15.xml><?xml version="1.0" encoding="utf-8"?>
+<p:notes xmlns:a="http://schemas.openxmlformats.org/drawingml/2006/main" xmlns:r="http://schemas.openxmlformats.org/officeDocument/2006/relationships" xmlns:p="http://schemas.openxmlformats.org/presentationml/2006/main">
+  <p:cSld>
+    <p:spTree>
+      <p:nvGrpSpPr>
+        <p:cNvPr id="1" name=""/>
+        <p:cNvGrpSpPr/>
+        <p:nvPr/>
+      </p:nvGrpSpPr>
+      <p:grpSpPr>
+        <a:xfrm>
+          <a:off x="0" y="0"/>
+          <a:ext cx="0" cy="0"/>
+          <a:chOff x="0" y="0"/>
+          <a:chExt cx="0" cy="0"/>
+        </a:xfrm>
+      </p:grpSpPr>
+      <p:sp>
+        <p:nvSpPr>
+          <p:cNvPr id="2" name="Slide Image Placeholder 1"/>
+          <p:cNvSpPr>
+            <a:spLocks noGrp="1" noRot="1" noChangeAspect="1"/>
+          </p:cNvSpPr>
+          <p:nvPr>
+            <p:ph type="sldImg"/>
+          </p:nvPr>
+        </p:nvSpPr>
+        <p:spPr/>
+      </p:sp>
+      <p:sp>
+        <p:nvSpPr>
+          <p:cNvPr id="3" name="Notes Placeholder 2"/>
+          <p:cNvSpPr>
+            <a:spLocks noGrp="1"/>
+          </p:cNvSpPr>
+          <p:nvPr>
+            <p:ph type="body" idx="1"/>
+          </p:nvPr>
+        </p:nvSpPr>
+        <p:spPr/>
+        <p:txBody>
+          <a:bodyPr/>
+          <a:lstStyle/>
+          <a:p>
+            <a:r>
+              <a:rPr lang="en-US" dirty="0"/>
+              <a:t/>
+            </a:r>
+            <a:endParaRPr lang="en-US" dirty="0"/>
+          </a:p>
+        </p:txBody>
+      </p:sp>
+      <p:sp>
+        <p:nvSpPr>
+          <p:cNvPr id="4" name="Slide Number Placeholder 3"/>
+          <p:cNvSpPr>
+            <a:spLocks noGrp="1"/>
+          </p:cNvSpPr>
+          <p:nvPr>
+            <p:ph type="sldNum" sz="quarter" idx="10"/>
+          </p:nvPr>
+        </p:nvSpPr>
+        <p:spPr/>
+        <p:txBody>
+          <a:bodyPr/>
+          <a:lstStyle/>
+          <a:p>
+            <a:fld id="{F7021451-1387-4CA6-816F-3879F97B5CBC}" type="slidenum">
+              <a:rPr lang="en-US"/>
+              <a:t>15</a:t>
             </a:fld>
             <a:endParaRPr lang="en-US"/>
           </a:p>
@@ -3270,7 +3359,7 @@
         </p:nvSpPr>
         <p:spPr>
           <a:xfrm>
-            <a:off x="9921240" y="2377440"/>
+            <a:off x="9921240" y="2395728"/>
             <a:ext cx="1691640" cy="822960"/>
           </a:xfrm>
           <a:prstGeom prst="rect">
@@ -3290,7 +3379,7 @@
               <a:buNone/>
             </a:pPr>
             <a:r>
-              <a:rPr lang="en-US" sz="1100" b="1" dirty="0">
+              <a:rPr lang="en-US" sz="1050" b="1" dirty="0">
                 <a:solidFill>
                   <a:srgbClr val="8E0B20"/>
                 </a:solidFill>
@@ -3298,9 +3387,9 @@
                 <a:ea typeface="Cambria" pitchFamily="34" charset="-122"/>
                 <a:cs typeface="Cambria" pitchFamily="34" charset="-120"/>
               </a:rPr>
-              <a:t>AD サーバ</a:t>
-            </a:r>
-            <a:endParaRPr lang="en-US" sz="1100" dirty="0"/>
+              <a:t>認証基盤サーバ</a:t>
+            </a:r>
+            <a:endParaRPr lang="en-US" sz="1050" dirty="0"/>
           </a:p>
           <a:p>
             <a:pPr algn="ctr" indent="0" marL="0">
@@ -3310,7 +3399,7 @@
               <a:buNone/>
             </a:pPr>
             <a:r>
-              <a:rPr lang="en-US" sz="1100" b="1" dirty="0">
+              <a:rPr lang="en-US" sz="1050" b="1" dirty="0">
                 <a:solidFill>
                   <a:srgbClr val="8E0B20"/>
                 </a:solidFill>
@@ -3318,9 +3407,9 @@
                 <a:ea typeface="Cambria" pitchFamily="34" charset="-122"/>
                 <a:cs typeface="Cambria" pitchFamily="34" charset="-120"/>
               </a:rPr>
-              <a:t>（管理者権限を奪取）</a:t>
-            </a:r>
-            <a:endParaRPr lang="en-US" sz="1100" dirty="0"/>
+              <a:t>(AD/SQL認証DB)</a:t>
+            </a:r>
+            <a:endParaRPr lang="en-US" sz="1050" dirty="0"/>
           </a:p>
         </p:txBody>
       </p:sp>
@@ -4143,7 +4232,7 @@
                 <a:ea typeface="Calibri" pitchFamily="34" charset="-122"/>
                 <a:cs typeface="Calibri" pitchFamily="34" charset="-120"/>
               </a:rPr>
-              <a:t> AD管理者権限を奪取しEDRを無効化</a:t>
+              <a:t> 認証基盤の権限を奪取しEDRを無効化</a:t>
             </a:r>
             <a:endParaRPr lang="en-US" sz="1150" dirty="0"/>
           </a:p>
@@ -4472,7 +4561,7 @@
                 <a:ea typeface="Calibri" pitchFamily="34" charset="-122"/>
                 <a:cs typeface="Calibri" pitchFamily="34" charset="-120"/>
               </a:rPr>
-              <a:t>あるべき考え方</a:t>
+              <a:t>SQL認証環境の追加リスク（ADが無くても）</a:t>
             </a:r>
             <a:endParaRPr lang="en-US" sz="1200" dirty="0"/>
           </a:p>
@@ -4511,7 +4600,7 @@
                 <a:ea typeface="Cambria" pitchFamily="34" charset="-122"/>
                 <a:cs typeface="Cambria" pitchFamily="34" charset="-120"/>
               </a:rPr>
-              <a:t>脆弱性検査とEDRは「補完関係」― 多層で守る</a:t>
+              <a:t>SQL認証でも認証情報は盗まれる ― 5つの経路</a:t>
             </a:r>
             <a:endParaRPr lang="en-US" sz="3200" dirty="0"/>
           </a:p>
@@ -4525,12 +4614,12 @@
         </p:nvSpPr>
         <p:spPr>
           <a:xfrm>
-            <a:off x="566928" y="2011680"/>
-            <a:ext cx="7498080" cy="1097280"/>
+            <a:off x="566928" y="1783080"/>
+            <a:ext cx="11055096" cy="713232"/>
           </a:xfrm>
           <a:prstGeom prst="roundRect">
             <a:avLst>
-              <a:gd name="adj" fmla="val 6667"/>
+              <a:gd name="adj" fmla="val 8974"/>
             </a:avLst>
           </a:prstGeom>
           <a:solidFill>
@@ -4559,8 +4648,8 @@
         </p:nvSpPr>
         <p:spPr>
           <a:xfrm>
-            <a:off x="795528" y="2267712"/>
-            <a:ext cx="585216" cy="585216"/>
+            <a:off x="749808" y="1911096"/>
+            <a:ext cx="457200" cy="457200"/>
           </a:xfrm>
           <a:prstGeom prst="ellipse">
             <a:avLst/>
@@ -4579,8 +4668,8 @@
         </p:nvSpPr>
         <p:spPr>
           <a:xfrm>
-            <a:off x="795528" y="2267712"/>
-            <a:ext cx="585216" cy="585216"/>
+            <a:off x="749808" y="1911096"/>
+            <a:ext cx="457200" cy="457200"/>
           </a:xfrm>
           <a:prstGeom prst="rect">
             <a:avLst/>
@@ -4596,7 +4685,7 @@
               <a:buNone/>
             </a:pPr>
             <a:r>
-              <a:rPr lang="en-US" sz="2200" b="1" dirty="0">
+              <a:rPr lang="en-US" sz="1800" b="1" dirty="0">
                 <a:solidFill>
                   <a:srgbClr val="FFFFFF"/>
                 </a:solidFill>
@@ -4606,7 +4695,7 @@
               </a:rPr>
               <a:t>1</a:t>
             </a:r>
-            <a:endParaRPr lang="en-US" sz="2200" dirty="0"/>
+            <a:endParaRPr lang="en-US" sz="1800" dirty="0"/>
           </a:p>
         </p:txBody>
       </p:sp>
@@ -4618,8 +4707,8 @@
         </p:nvSpPr>
         <p:spPr>
           <a:xfrm>
-            <a:off x="1572768" y="2157984"/>
-            <a:ext cx="6400800" cy="457200"/>
+            <a:off x="1344168" y="1856232"/>
+            <a:ext cx="3383280" cy="566928"/>
           </a:xfrm>
           <a:prstGeom prst="rect">
             <a:avLst/>
@@ -4632,10 +4721,13 @@
           <a:lstStyle/>
           <a:p>
             <a:pPr indent="0" marL="0">
-              <a:buNone/>
-            </a:pPr>
-            <a:r>
-              <a:rPr lang="en-US" sz="1700" b="1" dirty="0">
+              <a:lnSpc>
+                <a:spcPts val="1600"/>
+              </a:lnSpc>
+              <a:buNone/>
+            </a:pPr>
+            <a:r>
+              <a:rPr lang="en-US" sz="1450" b="1" dirty="0">
                 <a:solidFill>
                   <a:srgbClr val="0E1B3D"/>
                 </a:solidFill>
@@ -4643,52 +4735,41 @@
                 <a:ea typeface="Cambria" pitchFamily="34" charset="-122"/>
                 <a:cs typeface="Cambria" pitchFamily="34" charset="-120"/>
               </a:rPr>
-              <a:t>入口を塞ぐ   </a:t>
-            </a:r>
+              <a:t>SQLインジェクション</a:t>
+            </a:r>
+            <a:endParaRPr lang="en-US" sz="1450" dirty="0"/>
+          </a:p>
+        </p:txBody>
+      </p:sp>
+      <p:sp>
+        <p:nvSpPr>
+          <p:cNvPr id="8" name="Text 6"/>
+          <p:cNvSpPr/>
+          <p:nvPr/>
+        </p:nvSpPr>
+        <p:spPr>
+          <a:xfrm>
+            <a:off x="4864608" y="1856232"/>
+            <a:ext cx="6574536" cy="566928"/>
+          </a:xfrm>
+          <a:prstGeom prst="rect">
+            <a:avLst/>
+          </a:prstGeom>
+          <a:noFill/>
+          <a:ln/>
+        </p:spPr>
+        <p:txBody>
+          <a:bodyPr wrap="square" lIns="0" tIns="0" rIns="0" bIns="0" rtlCol="0" anchor="ctr"/>
+          <a:lstStyle/>
+          <a:p>
             <a:pPr indent="0" marL="0">
-              <a:buNone/>
-            </a:pPr>
-            <a:r>
-              <a:rPr lang="en-US" sz="1300" b="1" dirty="0">
-                <a:solidFill>
-                  <a:srgbClr val="C8102E"/>
-                </a:solidFill>
-                <a:latin typeface="Cambria" pitchFamily="34" charset="0"/>
-                <a:ea typeface="Cambria" pitchFamily="34" charset="-122"/>
-                <a:cs typeface="Cambria" pitchFamily="34" charset="-120"/>
-              </a:rPr>
-              <a:t>脆弱性検査・パッチ・認証強化(MFA)</a:t>
-            </a:r>
-            <a:endParaRPr lang="en-US" sz="1700" dirty="0"/>
-          </a:p>
-        </p:txBody>
-      </p:sp>
-      <p:sp>
-        <p:nvSpPr>
-          <p:cNvPr id="8" name="Text 6"/>
-          <p:cNvSpPr/>
-          <p:nvPr/>
-        </p:nvSpPr>
-        <p:spPr>
-          <a:xfrm>
-            <a:off x="1572768" y="2578608"/>
-            <a:ext cx="6400800" cy="457200"/>
-          </a:xfrm>
-          <a:prstGeom prst="rect">
-            <a:avLst/>
-          </a:prstGeom>
-          <a:noFill/>
-          <a:ln/>
-        </p:spPr>
-        <p:txBody>
-          <a:bodyPr wrap="square" lIns="0" tIns="0" rIns="0" bIns="0" rtlCol="0" anchor="t"/>
-          <a:lstStyle/>
-          <a:p>
-            <a:pPr indent="0" marL="0">
-              <a:buNone/>
-            </a:pPr>
-            <a:r>
-              <a:rPr lang="en-US" sz="1250" dirty="0">
+              <a:lnSpc>
+                <a:spcPts val="1500"/>
+              </a:lnSpc>
+              <a:buNone/>
+            </a:pPr>
+            <a:r>
+              <a:rPr lang="en-US" sz="1200" dirty="0">
                 <a:solidFill>
                   <a:srgbClr val="1A2332"/>
                 </a:solidFill>
@@ -4696,9 +4777,9 @@
                 <a:ea typeface="Calibri" pitchFamily="34" charset="-122"/>
                 <a:cs typeface="Calibri" pitchFamily="34" charset="-120"/>
               </a:rPr>
-              <a:t>侵入・乗っ取りの起点を事前に潰す</a:t>
-            </a:r>
-            <a:endParaRPr lang="en-US" sz="1250" dirty="0"/>
+              <a:t>ログイン/アプリの脆弱性で認証テーブルを丸ごとダンプ。1件ずつ破る必要すらない。</a:t>
+            </a:r>
+            <a:endParaRPr lang="en-US" sz="1200" dirty="0"/>
           </a:p>
         </p:txBody>
       </p:sp>
@@ -4710,12 +4791,12 @@
         </p:nvSpPr>
         <p:spPr>
           <a:xfrm>
-            <a:off x="566928" y="3310128"/>
-            <a:ext cx="7498080" cy="1097280"/>
+            <a:off x="566928" y="2606040"/>
+            <a:ext cx="11055096" cy="713232"/>
           </a:xfrm>
           <a:prstGeom prst="roundRect">
             <a:avLst>
-              <a:gd name="adj" fmla="val 6667"/>
+              <a:gd name="adj" fmla="val 8974"/>
             </a:avLst>
           </a:prstGeom>
           <a:solidFill>
@@ -4744,14 +4825,14 @@
         </p:nvSpPr>
         <p:spPr>
           <a:xfrm>
-            <a:off x="795528" y="3566160"/>
-            <a:ext cx="585216" cy="585216"/>
+            <a:off x="749808" y="2734056"/>
+            <a:ext cx="457200" cy="457200"/>
           </a:xfrm>
           <a:prstGeom prst="ellipse">
             <a:avLst/>
           </a:prstGeom>
           <a:solidFill>
-            <a:srgbClr val="3E5C76"/>
+            <a:srgbClr val="C8102E"/>
           </a:solidFill>
           <a:ln/>
         </p:spPr>
@@ -4764,8 +4845,8 @@
         </p:nvSpPr>
         <p:spPr>
           <a:xfrm>
-            <a:off x="795528" y="3566160"/>
-            <a:ext cx="585216" cy="585216"/>
+            <a:off x="749808" y="2734056"/>
+            <a:ext cx="457200" cy="457200"/>
           </a:xfrm>
           <a:prstGeom prst="rect">
             <a:avLst/>
@@ -4781,7 +4862,7 @@
               <a:buNone/>
             </a:pPr>
             <a:r>
-              <a:rPr lang="en-US" sz="2200" b="1" dirty="0">
+              <a:rPr lang="en-US" sz="1800" b="1" dirty="0">
                 <a:solidFill>
                   <a:srgbClr val="FFFFFF"/>
                 </a:solidFill>
@@ -4791,7 +4872,7 @@
               </a:rPr>
               <a:t>2</a:t>
             </a:r>
-            <a:endParaRPr lang="en-US" sz="2200" dirty="0"/>
+            <a:endParaRPr lang="en-US" sz="1800" dirty="0"/>
           </a:p>
         </p:txBody>
       </p:sp>
@@ -4803,8 +4884,8 @@
         </p:nvSpPr>
         <p:spPr>
           <a:xfrm>
-            <a:off x="1572768" y="3456432"/>
-            <a:ext cx="6400800" cy="457200"/>
+            <a:off x="1344168" y="2679192"/>
+            <a:ext cx="3383280" cy="566928"/>
           </a:xfrm>
           <a:prstGeom prst="rect">
             <a:avLst/>
@@ -4817,10 +4898,13 @@
           <a:lstStyle/>
           <a:p>
             <a:pPr indent="0" marL="0">
-              <a:buNone/>
-            </a:pPr>
-            <a:r>
-              <a:rPr lang="en-US" sz="1700" b="1" dirty="0">
+              <a:lnSpc>
+                <a:spcPts val="1600"/>
+              </a:lnSpc>
+              <a:buNone/>
+            </a:pPr>
+            <a:r>
+              <a:rPr lang="en-US" sz="1450" b="1" dirty="0">
                 <a:solidFill>
                   <a:srgbClr val="0E1B3D"/>
                 </a:solidFill>
@@ -4828,52 +4912,41 @@
                 <a:ea typeface="Cambria" pitchFamily="34" charset="-122"/>
                 <a:cs typeface="Cambria" pitchFamily="34" charset="-120"/>
               </a:rPr>
-              <a:t>内側で検知   </a:t>
-            </a:r>
+              <a:t>パスワード保存の弱さ</a:t>
+            </a:r>
+            <a:endParaRPr lang="en-US" sz="1450" dirty="0"/>
+          </a:p>
+        </p:txBody>
+      </p:sp>
+      <p:sp>
+        <p:nvSpPr>
+          <p:cNvPr id="13" name="Text 11"/>
+          <p:cNvSpPr/>
+          <p:nvPr/>
+        </p:nvSpPr>
+        <p:spPr>
+          <a:xfrm>
+            <a:off x="4864608" y="2679192"/>
+            <a:ext cx="6574536" cy="566928"/>
+          </a:xfrm>
+          <a:prstGeom prst="rect">
+            <a:avLst/>
+          </a:prstGeom>
+          <a:noFill/>
+          <a:ln/>
+        </p:spPr>
+        <p:txBody>
+          <a:bodyPr wrap="square" lIns="0" tIns="0" rIns="0" bIns="0" rtlCol="0" anchor="ctr"/>
+          <a:lstStyle/>
+          <a:p>
             <a:pPr indent="0" marL="0">
-              <a:buNone/>
-            </a:pPr>
-            <a:r>
-              <a:rPr lang="en-US" sz="1300" b="1" dirty="0">
-                <a:solidFill>
-                  <a:srgbClr val="3E5C76"/>
-                </a:solidFill>
-                <a:latin typeface="Cambria" pitchFamily="34" charset="0"/>
-                <a:ea typeface="Cambria" pitchFamily="34" charset="-122"/>
-                <a:cs typeface="Cambria" pitchFamily="34" charset="-120"/>
-              </a:rPr>
-              <a:t>EDR(SentinelOne)</a:t>
-            </a:r>
-            <a:endParaRPr lang="en-US" sz="1700" dirty="0"/>
-          </a:p>
-        </p:txBody>
-      </p:sp>
-      <p:sp>
-        <p:nvSpPr>
-          <p:cNvPr id="13" name="Text 11"/>
-          <p:cNvSpPr/>
-          <p:nvPr/>
-        </p:nvSpPr>
-        <p:spPr>
-          <a:xfrm>
-            <a:off x="1572768" y="3877056"/>
-            <a:ext cx="6400800" cy="457200"/>
-          </a:xfrm>
-          <a:prstGeom prst="rect">
-            <a:avLst/>
-          </a:prstGeom>
-          <a:noFill/>
-          <a:ln/>
-        </p:spPr>
-        <p:txBody>
-          <a:bodyPr wrap="square" lIns="0" tIns="0" rIns="0" bIns="0" rtlCol="0" anchor="t"/>
-          <a:lstStyle/>
-          <a:p>
-            <a:pPr indent="0" marL="0">
-              <a:buNone/>
-            </a:pPr>
-            <a:r>
-              <a:rPr lang="en-US" sz="1250" dirty="0">
+              <a:lnSpc>
+                <a:spcPts val="1500"/>
+              </a:lnSpc>
+              <a:buNone/>
+            </a:pPr>
+            <a:r>
+              <a:rPr lang="en-US" sz="1200" dirty="0">
                 <a:solidFill>
                   <a:srgbClr val="1A2332"/>
                 </a:solidFill>
@@ -4881,9 +4954,9 @@
                 <a:ea typeface="Calibri" pitchFamily="34" charset="-122"/>
                 <a:cs typeface="Calibri" pitchFamily="34" charset="-120"/>
               </a:rPr>
-              <a:t>侵入されても被害拡大を検知・抑制</a:t>
-            </a:r>
-            <a:endParaRPr lang="en-US" sz="1250" dirty="0"/>
+              <a:t>平文・MD5/SHA1(ソルト無)・可逆暗号だと、DBを1回読むだけで全アカウントが判明。</a:t>
+            </a:r>
+            <a:endParaRPr lang="en-US" sz="1200" dirty="0"/>
           </a:p>
         </p:txBody>
       </p:sp>
@@ -4895,12 +4968,12 @@
         </p:nvSpPr>
         <p:spPr>
           <a:xfrm>
-            <a:off x="566928" y="4608576"/>
-            <a:ext cx="7498080" cy="1097280"/>
+            <a:off x="566928" y="3429000"/>
+            <a:ext cx="11055096" cy="713232"/>
           </a:xfrm>
           <a:prstGeom prst="roundRect">
             <a:avLst>
-              <a:gd name="adj" fmla="val 6667"/>
+              <a:gd name="adj" fmla="val 8974"/>
             </a:avLst>
           </a:prstGeom>
           <a:solidFill>
@@ -4929,14 +5002,14 @@
         </p:nvSpPr>
         <p:spPr>
           <a:xfrm>
-            <a:off x="795528" y="4864608"/>
-            <a:ext cx="585216" cy="585216"/>
+            <a:off x="749808" y="3557016"/>
+            <a:ext cx="457200" cy="457200"/>
           </a:xfrm>
           <a:prstGeom prst="ellipse">
             <a:avLst/>
           </a:prstGeom>
           <a:solidFill>
-            <a:srgbClr val="1E7A46"/>
+            <a:srgbClr val="C8102E"/>
           </a:solidFill>
           <a:ln/>
         </p:spPr>
@@ -4949,8 +5022,8 @@
         </p:nvSpPr>
         <p:spPr>
           <a:xfrm>
-            <a:off x="795528" y="4864608"/>
-            <a:ext cx="585216" cy="585216"/>
+            <a:off x="749808" y="3557016"/>
+            <a:ext cx="457200" cy="457200"/>
           </a:xfrm>
           <a:prstGeom prst="rect">
             <a:avLst/>
@@ -4966,7 +5039,7 @@
               <a:buNone/>
             </a:pPr>
             <a:r>
-              <a:rPr lang="en-US" sz="2200" b="1" dirty="0">
+              <a:rPr lang="en-US" sz="1800" b="1" dirty="0">
                 <a:solidFill>
                   <a:srgbClr val="FFFFFF"/>
                 </a:solidFill>
@@ -4976,7 +5049,7 @@
               </a:rPr>
               <a:t>3</a:t>
             </a:r>
-            <a:endParaRPr lang="en-US" sz="2200" dirty="0"/>
+            <a:endParaRPr lang="en-US" sz="1800" dirty="0"/>
           </a:p>
         </p:txBody>
       </p:sp>
@@ -4988,8 +5061,8 @@
         </p:nvSpPr>
         <p:spPr>
           <a:xfrm>
-            <a:off x="1572768" y="4754880"/>
-            <a:ext cx="6400800" cy="457200"/>
+            <a:off x="1344168" y="3502152"/>
+            <a:ext cx="3383280" cy="566928"/>
           </a:xfrm>
           <a:prstGeom prst="rect">
             <a:avLst/>
@@ -5002,10 +5075,13 @@
           <a:lstStyle/>
           <a:p>
             <a:pPr indent="0" marL="0">
-              <a:buNone/>
-            </a:pPr>
-            <a:r>
-              <a:rPr lang="en-US" sz="1700" b="1" dirty="0">
+              <a:lnSpc>
+                <a:spcPts val="1600"/>
+              </a:lnSpc>
+              <a:buNone/>
+            </a:pPr>
+            <a:r>
+              <a:rPr lang="en-US" sz="1450" b="1" dirty="0">
                 <a:solidFill>
                   <a:srgbClr val="0E1B3D"/>
                 </a:solidFill>
@@ -5013,52 +5089,41 @@
                 <a:ea typeface="Cambria" pitchFamily="34" charset="-122"/>
                 <a:cs typeface="Cambria" pitchFamily="34" charset="-120"/>
               </a:rPr>
-              <a:t>備えと復旧   </a:t>
-            </a:r>
+              <a:t>DBサーバの直接侵害</a:t>
+            </a:r>
+            <a:endParaRPr lang="en-US" sz="1450" dirty="0"/>
+          </a:p>
+        </p:txBody>
+      </p:sp>
+      <p:sp>
+        <p:nvSpPr>
+          <p:cNvPr id="18" name="Text 16"/>
+          <p:cNvSpPr/>
+          <p:nvPr/>
+        </p:nvSpPr>
+        <p:spPr>
+          <a:xfrm>
+            <a:off x="4864608" y="3502152"/>
+            <a:ext cx="6574536" cy="566928"/>
+          </a:xfrm>
+          <a:prstGeom prst="rect">
+            <a:avLst/>
+          </a:prstGeom>
+          <a:noFill/>
+          <a:ln/>
+        </p:spPr>
+        <p:txBody>
+          <a:bodyPr wrap="square" lIns="0" tIns="0" rIns="0" bIns="0" rtlCol="0" anchor="ctr"/>
+          <a:lstStyle/>
+          <a:p>
             <a:pPr indent="0" marL="0">
-              <a:buNone/>
-            </a:pPr>
-            <a:r>
-              <a:rPr lang="en-US" sz="1300" b="1" dirty="0">
-                <a:solidFill>
-                  <a:srgbClr val="1E7A46"/>
-                </a:solidFill>
-                <a:latin typeface="Cambria" pitchFamily="34" charset="0"/>
-                <a:ea typeface="Cambria" pitchFamily="34" charset="-122"/>
-                <a:cs typeface="Cambria" pitchFamily="34" charset="-120"/>
-              </a:rPr>
-              <a:t>バックアップ・監視・訓練</a:t>
-            </a:r>
-            <a:endParaRPr lang="en-US" sz="1700" dirty="0"/>
-          </a:p>
-        </p:txBody>
-      </p:sp>
-      <p:sp>
-        <p:nvSpPr>
-          <p:cNvPr id="18" name="Text 16"/>
-          <p:cNvSpPr/>
-          <p:nvPr/>
-        </p:nvSpPr>
-        <p:spPr>
-          <a:xfrm>
-            <a:off x="1572768" y="5175504"/>
-            <a:ext cx="6400800" cy="457200"/>
-          </a:xfrm>
-          <a:prstGeom prst="rect">
-            <a:avLst/>
-          </a:prstGeom>
-          <a:noFill/>
-          <a:ln/>
-        </p:spPr>
-        <p:txBody>
-          <a:bodyPr wrap="square" lIns="0" tIns="0" rIns="0" bIns="0" rtlCol="0" anchor="t"/>
-          <a:lstStyle/>
-          <a:p>
-            <a:pPr indent="0" marL="0">
-              <a:buNone/>
-            </a:pPr>
-            <a:r>
-              <a:rPr lang="en-US" sz="1250" dirty="0">
+              <a:lnSpc>
+                <a:spcPts val="1500"/>
+              </a:lnSpc>
+              <a:buNone/>
+            </a:pPr>
+            <a:r>
+              <a:rPr lang="en-US" sz="1200" dirty="0">
                 <a:solidFill>
                   <a:srgbClr val="1A2332"/>
                 </a:solidFill>
@@ -5066,9 +5131,9 @@
                 <a:ea typeface="Calibri" pitchFamily="34" charset="-122"/>
                 <a:cs typeface="Calibri" pitchFamily="34" charset="-120"/>
               </a:rPr>
-              <a:t>最悪時に事業を止めない</a:t>
-            </a:r>
-            <a:endParaRPr lang="en-US" sz="1250" dirty="0"/>
+              <a:t>露出した1433/3306/5432、弱いsa/root、バックアップ流出から認証テーブルを直読み。</a:t>
+            </a:r>
+            <a:endParaRPr lang="en-US" sz="1200" dirty="0"/>
           </a:p>
         </p:txBody>
       </p:sp>
@@ -5080,18 +5145,23 @@
         </p:nvSpPr>
         <p:spPr>
           <a:xfrm>
-            <a:off x="8366760" y="2011680"/>
-            <a:ext cx="3255264" cy="3712464"/>
+            <a:off x="566928" y="4251960"/>
+            <a:ext cx="11055096" cy="713232"/>
           </a:xfrm>
           <a:prstGeom prst="roundRect">
             <a:avLst>
-              <a:gd name="adj" fmla="val 2809"/>
+              <a:gd name="adj" fmla="val 8974"/>
             </a:avLst>
           </a:prstGeom>
           <a:solidFill>
-            <a:srgbClr val="0E1B3D"/>
+            <a:srgbClr val="F4F6FB"/>
           </a:solidFill>
-          <a:ln/>
+          <a:ln w="12700">
+            <a:solidFill>
+              <a:srgbClr val="E2E8F4"/>
+            </a:solidFill>
+            <a:prstDash val="solid"/>
+          </a:ln>
           <a:effectLst>
             <a:outerShdw sx="100000" sy="100000" kx="0" ky="0" algn="bl" rotWithShape="0" blurRad="101600" dist="38100" dir="5400000">
               <a:srgbClr val="8A93A6">
@@ -5103,95 +5173,402 @@
       </p:sp>
       <p:sp>
         <p:nvSpPr>
-          <p:cNvPr id="20" name="Text 18"/>
-          <p:cNvSpPr/>
-          <p:nvPr/>
-        </p:nvSpPr>
-        <p:spPr>
-          <a:xfrm>
-            <a:off x="8595360" y="2286000"/>
-            <a:ext cx="2779776" cy="3200400"/>
-          </a:xfrm>
-          <a:prstGeom prst="rect">
-            <a:avLst/>
-          </a:prstGeom>
-          <a:noFill/>
-          <a:ln/>
-        </p:spPr>
-        <p:txBody>
-          <a:bodyPr wrap="square" lIns="0" tIns="0" rIns="0" bIns="0" rtlCol="0" anchor="t"/>
+          <p:cNvPr id="20" name="Shape 18"/>
+          <p:cNvSpPr/>
+          <p:nvPr/>
+        </p:nvSpPr>
+        <p:spPr>
+          <a:xfrm>
+            <a:off x="749808" y="4379976"/>
+            <a:ext cx="457200" cy="457200"/>
+          </a:xfrm>
+          <a:prstGeom prst="ellipse">
+            <a:avLst/>
+          </a:prstGeom>
+          <a:solidFill>
+            <a:srgbClr val="C8102E"/>
+          </a:solidFill>
+          <a:ln/>
+        </p:spPr>
+      </p:sp>
+      <p:sp>
+        <p:nvSpPr>
+          <p:cNvPr id="21" name="Text 19"/>
+          <p:cNvSpPr/>
+          <p:nvPr/>
+        </p:nvSpPr>
+        <p:spPr>
+          <a:xfrm>
+            <a:off x="749808" y="4379976"/>
+            <a:ext cx="457200" cy="457200"/>
+          </a:xfrm>
+          <a:prstGeom prst="rect">
+            <a:avLst/>
+          </a:prstGeom>
+          <a:noFill/>
+          <a:ln/>
+        </p:spPr>
+        <p:txBody>
+          <a:bodyPr wrap="square" lIns="0" tIns="0" rIns="0" bIns="0" rtlCol="0" anchor="ctr"/>
+          <a:lstStyle/>
+          <a:p>
+            <a:pPr algn="ctr" indent="0" marL="0">
+              <a:buNone/>
+            </a:pPr>
+            <a:r>
+              <a:rPr lang="en-US" sz="1800" b="1" dirty="0">
+                <a:solidFill>
+                  <a:srgbClr val="FFFFFF"/>
+                </a:solidFill>
+                <a:latin typeface="Cambria" pitchFamily="34" charset="0"/>
+                <a:ea typeface="Cambria" pitchFamily="34" charset="-122"/>
+                <a:cs typeface="Cambria" pitchFamily="34" charset="-120"/>
+              </a:rPr>
+              <a:t>4</a:t>
+            </a:r>
+            <a:endParaRPr lang="en-US" sz="1800" dirty="0"/>
+          </a:p>
+        </p:txBody>
+      </p:sp>
+      <p:sp>
+        <p:nvSpPr>
+          <p:cNvPr id="22" name="Text 20"/>
+          <p:cNvSpPr/>
+          <p:nvPr/>
+        </p:nvSpPr>
+        <p:spPr>
+          <a:xfrm>
+            <a:off x="1344168" y="4325112"/>
+            <a:ext cx="3383280" cy="566928"/>
+          </a:xfrm>
+          <a:prstGeom prst="rect">
+            <a:avLst/>
+          </a:prstGeom>
+          <a:noFill/>
+          <a:ln/>
+        </p:spPr>
+        <p:txBody>
+          <a:bodyPr wrap="square" lIns="0" tIns="0" rIns="0" bIns="0" rtlCol="0" anchor="ctr"/>
           <a:lstStyle/>
           <a:p>
             <a:pPr indent="0" marL="0">
               <a:lnSpc>
-                <a:spcPts val="2000"/>
+                <a:spcPts val="1600"/>
               </a:lnSpc>
-              <a:spcAft>
-                <a:spcPts val="1000"/>
-              </a:spcAft>
-              <a:buNone/>
-            </a:pPr>
-            <a:r>
-              <a:rPr lang="en-US" sz="1800" b="1" dirty="0">
-                <a:solidFill>
-                  <a:srgbClr val="FF6B81"/>
+              <a:buNone/>
+            </a:pPr>
+            <a:r>
+              <a:rPr lang="en-US" sz="1450" b="1" dirty="0">
+                <a:solidFill>
+                  <a:srgbClr val="0E1B3D"/>
+                </a:solidFill>
+                <a:latin typeface="Cambria" pitchFamily="34" charset="0"/>
+                <a:ea typeface="Cambria" pitchFamily="34" charset="-122"/>
+                <a:cs typeface="Cambria" pitchFamily="34" charset="-120"/>
+              </a:rPr>
+              <a:t>接続文字列・秘密情報の散在</a:t>
+            </a:r>
+            <a:endParaRPr lang="en-US" sz="1450" dirty="0"/>
+          </a:p>
+        </p:txBody>
+      </p:sp>
+      <p:sp>
+        <p:nvSpPr>
+          <p:cNvPr id="23" name="Text 21"/>
+          <p:cNvSpPr/>
+          <p:nvPr/>
+        </p:nvSpPr>
+        <p:spPr>
+          <a:xfrm>
+            <a:off x="4864608" y="4325112"/>
+            <a:ext cx="6574536" cy="566928"/>
+          </a:xfrm>
+          <a:prstGeom prst="rect">
+            <a:avLst/>
+          </a:prstGeom>
+          <a:noFill/>
+          <a:ln/>
+        </p:spPr>
+        <p:txBody>
+          <a:bodyPr wrap="square" lIns="0" tIns="0" rIns="0" bIns="0" rtlCol="0" anchor="ctr"/>
+          <a:lstStyle/>
+          <a:p>
+            <a:pPr indent="0" marL="0">
+              <a:lnSpc>
+                <a:spcPts val="1500"/>
+              </a:lnSpc>
+              <a:buNone/>
+            </a:pPr>
+            <a:r>
+              <a:rPr lang="en-US" sz="1200" dirty="0">
+                <a:solidFill>
+                  <a:srgbClr val="1A2332"/>
                 </a:solidFill>
                 <a:latin typeface="Calibri" pitchFamily="34" charset="0"/>
                 <a:ea typeface="Calibri" pitchFamily="34" charset="-122"/>
                 <a:cs typeface="Calibri" pitchFamily="34" charset="-120"/>
               </a:rPr>
-              <a:t>S-1は層②。</a:t>
+              <a:t>web.config・appsettings・環境変数・ソースからDB資格情報を回収し即アクセス。</a:t>
+            </a:r>
+            <a:endParaRPr lang="en-US" sz="1200" dirty="0"/>
+          </a:p>
+        </p:txBody>
+      </p:sp>
+      <p:sp>
+        <p:nvSpPr>
+          <p:cNvPr id="24" name="Shape 22"/>
+          <p:cNvSpPr/>
+          <p:nvPr/>
+        </p:nvSpPr>
+        <p:spPr>
+          <a:xfrm>
+            <a:off x="566928" y="5074920"/>
+            <a:ext cx="11055096" cy="713232"/>
+          </a:xfrm>
+          <a:prstGeom prst="roundRect">
+            <a:avLst>
+              <a:gd name="adj" fmla="val 8974"/>
+            </a:avLst>
+          </a:prstGeom>
+          <a:solidFill>
+            <a:srgbClr val="F4F6FB"/>
+          </a:solidFill>
+          <a:ln w="12700">
+            <a:solidFill>
+              <a:srgbClr val="E2E8F4"/>
+            </a:solidFill>
+            <a:prstDash val="solid"/>
+          </a:ln>
+          <a:effectLst>
+            <a:outerShdw sx="100000" sy="100000" kx="0" ky="0" algn="bl" rotWithShape="0" blurRad="101600" dist="38100" dir="5400000">
+              <a:srgbClr val="8A93A6">
+                <a:alpha val="28000"/>
+              </a:srgbClr>
+            </a:outerShdw>
+          </a:effectLst>
+        </p:spPr>
+      </p:sp>
+      <p:sp>
+        <p:nvSpPr>
+          <p:cNvPr id="25" name="Shape 23"/>
+          <p:cNvSpPr/>
+          <p:nvPr/>
+        </p:nvSpPr>
+        <p:spPr>
+          <a:xfrm>
+            <a:off x="749808" y="5202936"/>
+            <a:ext cx="457200" cy="457200"/>
+          </a:xfrm>
+          <a:prstGeom prst="ellipse">
+            <a:avLst/>
+          </a:prstGeom>
+          <a:solidFill>
+            <a:srgbClr val="C8102E"/>
+          </a:solidFill>
+          <a:ln/>
+        </p:spPr>
+      </p:sp>
+      <p:sp>
+        <p:nvSpPr>
+          <p:cNvPr id="26" name="Text 24"/>
+          <p:cNvSpPr/>
+          <p:nvPr/>
+        </p:nvSpPr>
+        <p:spPr>
+          <a:xfrm>
+            <a:off x="749808" y="5202936"/>
+            <a:ext cx="457200" cy="457200"/>
+          </a:xfrm>
+          <a:prstGeom prst="rect">
+            <a:avLst/>
+          </a:prstGeom>
+          <a:noFill/>
+          <a:ln/>
+        </p:spPr>
+        <p:txBody>
+          <a:bodyPr wrap="square" lIns="0" tIns="0" rIns="0" bIns="0" rtlCol="0" anchor="ctr"/>
+          <a:lstStyle/>
+          <a:p>
+            <a:pPr algn="ctr" indent="0" marL="0">
+              <a:buNone/>
+            </a:pPr>
+            <a:r>
+              <a:rPr lang="en-US" sz="1800" b="1" dirty="0">
+                <a:solidFill>
+                  <a:srgbClr val="FFFFFF"/>
+                </a:solidFill>
+                <a:latin typeface="Cambria" pitchFamily="34" charset="0"/>
+                <a:ea typeface="Cambria" pitchFamily="34" charset="-122"/>
+                <a:cs typeface="Cambria" pitchFamily="34" charset="-120"/>
+              </a:rPr>
+              <a:t>5</a:t>
             </a:r>
             <a:endParaRPr lang="en-US" sz="1800" dirty="0"/>
           </a:p>
+        </p:txBody>
+      </p:sp>
+      <p:sp>
+        <p:nvSpPr>
+          <p:cNvPr id="27" name="Text 25"/>
+          <p:cNvSpPr/>
+          <p:nvPr/>
+        </p:nvSpPr>
+        <p:spPr>
+          <a:xfrm>
+            <a:off x="1344168" y="5148072"/>
+            <a:ext cx="3383280" cy="566928"/>
+          </a:xfrm>
+          <a:prstGeom prst="rect">
+            <a:avLst/>
+          </a:prstGeom>
+          <a:noFill/>
+          <a:ln/>
+        </p:spPr>
+        <p:txBody>
+          <a:bodyPr wrap="square" lIns="0" tIns="0" rIns="0" bIns="0" rtlCol="0" anchor="ctr"/>
+          <a:lstStyle/>
           <a:p>
             <a:pPr indent="0" marL="0">
               <a:lnSpc>
-                <a:spcPts val="2000"/>
+                <a:spcPts val="1600"/>
               </a:lnSpc>
-              <a:spcAft>
-                <a:spcPts val="1400"/>
-              </a:spcAft>
-              <a:buNone/>
-            </a:pPr>
-            <a:r>
-              <a:rPr lang="en-US" sz="1400" dirty="0">
-                <a:solidFill>
-                  <a:srgbClr val="DCE6F5"/>
+              <a:buNone/>
+            </a:pPr>
+            <a:r>
+              <a:rPr lang="en-US" sz="1450" b="1" dirty="0">
+                <a:solidFill>
+                  <a:srgbClr val="0E1B3D"/>
+                </a:solidFill>
+                <a:latin typeface="Cambria" pitchFamily="34" charset="0"/>
+                <a:ea typeface="Cambria" pitchFamily="34" charset="-122"/>
+                <a:cs typeface="Cambria" pitchFamily="34" charset="-120"/>
+              </a:rPr>
+              <a:t>sa / db_owner の悪用</a:t>
+            </a:r>
+            <a:endParaRPr lang="en-US" sz="1450" dirty="0"/>
+          </a:p>
+        </p:txBody>
+      </p:sp>
+      <p:sp>
+        <p:nvSpPr>
+          <p:cNvPr id="28" name="Text 26"/>
+          <p:cNvSpPr/>
+          <p:nvPr/>
+        </p:nvSpPr>
+        <p:spPr>
+          <a:xfrm>
+            <a:off x="4864608" y="5148072"/>
+            <a:ext cx="6574536" cy="566928"/>
+          </a:xfrm>
+          <a:prstGeom prst="rect">
+            <a:avLst/>
+          </a:prstGeom>
+          <a:noFill/>
+          <a:ln/>
+        </p:spPr>
+        <p:txBody>
+          <a:bodyPr wrap="square" lIns="0" tIns="0" rIns="0" bIns="0" rtlCol="0" anchor="ctr"/>
+          <a:lstStyle/>
+          <a:p>
+            <a:pPr indent="0" marL="0">
+              <a:lnSpc>
+                <a:spcPts val="1500"/>
+              </a:lnSpc>
+              <a:buNone/>
+            </a:pPr>
+            <a:r>
+              <a:rPr lang="en-US" sz="1200" dirty="0">
+                <a:solidFill>
+                  <a:srgbClr val="1A2332"/>
                 </a:solidFill>
                 <a:latin typeface="Calibri" pitchFamily="34" charset="0"/>
                 <a:ea typeface="Calibri" pitchFamily="34" charset="-122"/>
                 <a:cs typeface="Calibri" pitchFamily="34" charset="-120"/>
               </a:rPr>
-              <a:t>層①（入口）が抜けたままでは、攻撃者は容易に侵入し、層②を無効化しにいく。</a:t>
-            </a:r>
-            <a:endParaRPr lang="en-US" sz="1800" dirty="0"/>
-          </a:p>
+              <a:t>特権SQLログイン奪取→xp_cmdshell等でOSコマンド実行(RCE)・横展開の踏み台に。</a:t>
+            </a:r>
+            <a:endParaRPr lang="en-US" sz="1200" dirty="0"/>
+          </a:p>
+        </p:txBody>
+      </p:sp>
+      <p:sp>
+        <p:nvSpPr>
+          <p:cNvPr id="29" name="Shape 27"/>
+          <p:cNvSpPr/>
+          <p:nvPr/>
+        </p:nvSpPr>
+        <p:spPr>
+          <a:xfrm>
+            <a:off x="566928" y="5870448"/>
+            <a:ext cx="11055096" cy="457200"/>
+          </a:xfrm>
+          <a:prstGeom prst="roundRect">
+            <a:avLst>
+              <a:gd name="adj" fmla="val 14000"/>
+            </a:avLst>
+          </a:prstGeom>
+          <a:solidFill>
+            <a:srgbClr val="0E1B3D"/>
+          </a:solidFill>
+          <a:ln/>
+        </p:spPr>
+      </p:sp>
+      <p:sp>
+        <p:nvSpPr>
+          <p:cNvPr id="30" name="Text 28"/>
+          <p:cNvSpPr/>
+          <p:nvPr/>
+        </p:nvSpPr>
+        <p:spPr>
+          <a:xfrm>
+            <a:off x="886968" y="5870448"/>
+            <a:ext cx="10415016" cy="457200"/>
+          </a:xfrm>
+          <a:prstGeom prst="rect">
+            <a:avLst/>
+          </a:prstGeom>
+          <a:noFill/>
+          <a:ln/>
+        </p:spPr>
+        <p:txBody>
+          <a:bodyPr wrap="square" lIns="0" tIns="0" rIns="0" bIns="0" rtlCol="0" anchor="ctr"/>
+          <a:lstStyle/>
           <a:p>
             <a:pPr indent="0" marL="0">
-              <a:lnSpc>
-                <a:spcPts val="2000"/>
-              </a:lnSpc>
-              <a:buNone/>
-            </a:pPr>
-            <a:r>
-              <a:rPr lang="en-US" sz="1400" b="1" dirty="0">
-                <a:solidFill>
-                  <a:srgbClr val="FFFFFF"/>
+              <a:buNone/>
+            </a:pPr>
+            <a:r>
+              <a:rPr lang="en-US" sz="1250" b="1" dirty="0">
+                <a:solidFill>
+                  <a:srgbClr val="FF6B81"/>
                 </a:solidFill>
                 <a:latin typeface="Calibri" pitchFamily="34" charset="0"/>
                 <a:ea typeface="Calibri" pitchFamily="34" charset="-122"/>
                 <a:cs typeface="Calibri" pitchFamily="34" charset="-120"/>
               </a:rPr>
-              <a:t>脆弱性検査は層②を置き換えるものではなく、層②が守る前提となる層①を成立させるもの。</a:t>
-            </a:r>
-            <a:endParaRPr lang="en-US" sz="1800" dirty="0"/>
-          </a:p>
-        </p:txBody>
-      </p:sp>
-      <p:sp>
-        <p:nvSpPr>
-          <p:cNvPr id="21" name="Text 19"/>
+              <a:t>対処：  </a:t>
+            </a:r>
+            <a:pPr indent="0" marL="0">
+              <a:buNone/>
+            </a:pPr>
+            <a:r>
+              <a:rPr lang="en-US" sz="1250" dirty="0">
+                <a:solidFill>
+                  <a:srgbClr val="DCE6F5"/>
+                </a:solidFill>
+                <a:latin typeface="Calibri" pitchFamily="34" charset="0"/>
+                <a:ea typeface="Calibri" pitchFamily="34" charset="-122"/>
+                <a:cs typeface="Calibri" pitchFamily="34" charset="-120"/>
+              </a:rPr>
+              <a:t>脆弱性検査(SQLi)・パスワード保存方式の監査・秘密情報の棚卸し・MFA。いずれもEDRの管轄外。</a:t>
+            </a:r>
+            <a:endParaRPr lang="en-US" sz="1250" dirty="0"/>
+          </a:p>
+        </p:txBody>
+      </p:sp>
+      <p:sp>
+        <p:nvSpPr>
+          <p:cNvPr id="31" name="Text 29"/>
           <p:cNvSpPr/>
           <p:nvPr/>
         </p:nvSpPr>
@@ -5293,7 +5670,7 @@
                 <a:ea typeface="Calibri" pitchFamily="34" charset="-122"/>
                 <a:cs typeface="Calibri" pitchFamily="34" charset="-120"/>
               </a:rPr>
-              <a:t>Aenaへの提言</a:t>
+              <a:t>あるべき考え方</a:t>
             </a:r>
             <a:endParaRPr lang="en-US" sz="1200" dirty="0"/>
           </a:p>
@@ -5332,7 +5709,7 @@
                 <a:ea typeface="Cambria" pitchFamily="34" charset="-122"/>
                 <a:cs typeface="Cambria" pitchFamily="34" charset="-120"/>
               </a:rPr>
-              <a:t>S-1に加えて今すぐ着手したい5項目</a:t>
+              <a:t>脆弱性検査とEDRは「補完関係」― 多層で守る</a:t>
             </a:r>
             <a:endParaRPr lang="en-US" sz="3200" dirty="0"/>
           </a:p>
@@ -5346,12 +5723,12 @@
         </p:nvSpPr>
         <p:spPr>
           <a:xfrm>
-            <a:off x="566928" y="1920240"/>
-            <a:ext cx="5344668" cy="1143000"/>
+            <a:off x="566928" y="2011680"/>
+            <a:ext cx="7498080" cy="1097280"/>
           </a:xfrm>
           <a:prstGeom prst="roundRect">
             <a:avLst>
-              <a:gd name="adj" fmla="val 6400"/>
+              <a:gd name="adj" fmla="val 6667"/>
             </a:avLst>
           </a:prstGeom>
           <a:solidFill>
@@ -5380,8 +5757,8 @@
         </p:nvSpPr>
         <p:spPr>
           <a:xfrm>
-            <a:off x="795528" y="2203704"/>
-            <a:ext cx="566928" cy="566928"/>
+            <a:off x="795528" y="2267712"/>
+            <a:ext cx="585216" cy="585216"/>
           </a:xfrm>
           <a:prstGeom prst="ellipse">
             <a:avLst/>
@@ -5400,8 +5777,8 @@
         </p:nvSpPr>
         <p:spPr>
           <a:xfrm>
-            <a:off x="795528" y="2203704"/>
-            <a:ext cx="566928" cy="566928"/>
+            <a:off x="795528" y="2267712"/>
+            <a:ext cx="585216" cy="585216"/>
           </a:xfrm>
           <a:prstGeom prst="rect">
             <a:avLst/>
@@ -5439,24 +5816,24 @@
         </p:nvSpPr>
         <p:spPr>
           <a:xfrm>
-            <a:off x="1527048" y="2066544"/>
-            <a:ext cx="4155948" cy="457200"/>
-          </a:xfrm>
-          <a:prstGeom prst="rect">
-            <a:avLst/>
-          </a:prstGeom>
-          <a:noFill/>
-          <a:ln/>
-        </p:spPr>
-        <p:txBody>
-          <a:bodyPr wrap="square" lIns="0" tIns="0" rIns="0" bIns="0" rtlCol="0" anchor="t"/>
+            <a:off x="1572768" y="2157984"/>
+            <a:ext cx="6400800" cy="457200"/>
+          </a:xfrm>
+          <a:prstGeom prst="rect">
+            <a:avLst/>
+          </a:prstGeom>
+          <a:noFill/>
+          <a:ln/>
+        </p:spPr>
+        <p:txBody>
+          <a:bodyPr wrap="square" lIns="0" tIns="0" rIns="0" bIns="0" rtlCol="0" anchor="ctr"/>
           <a:lstStyle/>
           <a:p>
             <a:pPr indent="0" marL="0">
               <a:buNone/>
             </a:pPr>
             <a:r>
-              <a:rPr lang="en-US" sz="1550" b="1" dirty="0">
+              <a:rPr lang="en-US" sz="1700" b="1" dirty="0">
                 <a:solidFill>
                   <a:srgbClr val="0E1B3D"/>
                 </a:solidFill>
@@ -5464,9 +5841,23 @@
                 <a:ea typeface="Cambria" pitchFamily="34" charset="-122"/>
                 <a:cs typeface="Cambria" pitchFamily="34" charset="-120"/>
               </a:rPr>
-              <a:t>外部公開資産の脆弱性検査を定期実施</a:t>
-            </a:r>
-            <a:endParaRPr lang="en-US" sz="1550" dirty="0"/>
+              <a:t>入口を塞ぐ   </a:t>
+            </a:r>
+            <a:pPr indent="0" marL="0">
+              <a:buNone/>
+            </a:pPr>
+            <a:r>
+              <a:rPr lang="en-US" sz="1300" b="1" dirty="0">
+                <a:solidFill>
+                  <a:srgbClr val="C8102E"/>
+                </a:solidFill>
+                <a:latin typeface="Cambria" pitchFamily="34" charset="0"/>
+                <a:ea typeface="Cambria" pitchFamily="34" charset="-122"/>
+                <a:cs typeface="Cambria" pitchFamily="34" charset="-120"/>
+              </a:rPr>
+              <a:t>脆弱性検査・パッチ・認証強化(MFA)</a:t>
+            </a:r>
+            <a:endParaRPr lang="en-US" sz="1700" dirty="0"/>
           </a:p>
         </p:txBody>
       </p:sp>
@@ -5478,8 +5869,8 @@
         </p:nvSpPr>
         <p:spPr>
           <a:xfrm>
-            <a:off x="1527048" y="2487168"/>
-            <a:ext cx="4155948" cy="502920"/>
+            <a:off x="1572768" y="2578608"/>
+            <a:ext cx="6400800" cy="457200"/>
           </a:xfrm>
           <a:prstGeom prst="rect">
             <a:avLst/>
@@ -5492,9 +5883,6 @@
           <a:lstStyle/>
           <a:p>
             <a:pPr indent="0" marL="0">
-              <a:lnSpc>
-                <a:spcPts val="1600"/>
-              </a:lnSpc>
               <a:buNone/>
             </a:pPr>
             <a:r>
@@ -5506,7 +5894,7 @@
                 <a:ea typeface="Calibri" pitchFamily="34" charset="-122"/>
                 <a:cs typeface="Calibri" pitchFamily="34" charset="-120"/>
               </a:rPr>
-              <a:t>VPN・公開サーバ・Webを対象に、悪用可能な入口を洗い出す</a:t>
+              <a:t>侵入・乗っ取りの起点を事前に潰す</a:t>
             </a:r>
             <a:endParaRPr lang="en-US" sz="1250" dirty="0"/>
           </a:p>
@@ -5520,12 +5908,12 @@
         </p:nvSpPr>
         <p:spPr>
           <a:xfrm>
-            <a:off x="6277356" y="1920240"/>
-            <a:ext cx="5344668" cy="1143000"/>
+            <a:off x="566928" y="3310128"/>
+            <a:ext cx="7498080" cy="1097280"/>
           </a:xfrm>
           <a:prstGeom prst="roundRect">
             <a:avLst>
-              <a:gd name="adj" fmla="val 6400"/>
+              <a:gd name="adj" fmla="val 6667"/>
             </a:avLst>
           </a:prstGeom>
           <a:solidFill>
@@ -5554,14 +5942,14 @@
         </p:nvSpPr>
         <p:spPr>
           <a:xfrm>
-            <a:off x="6505956" y="2203704"/>
-            <a:ext cx="566928" cy="566928"/>
+            <a:off x="795528" y="3566160"/>
+            <a:ext cx="585216" cy="585216"/>
           </a:xfrm>
           <a:prstGeom prst="ellipse">
             <a:avLst/>
           </a:prstGeom>
           <a:solidFill>
-            <a:srgbClr val="C8102E"/>
+            <a:srgbClr val="3E5C76"/>
           </a:solidFill>
           <a:ln/>
         </p:spPr>
@@ -5574,8 +5962,8 @@
         </p:nvSpPr>
         <p:spPr>
           <a:xfrm>
-            <a:off x="6505956" y="2203704"/>
-            <a:ext cx="566928" cy="566928"/>
+            <a:off x="795528" y="3566160"/>
+            <a:ext cx="585216" cy="585216"/>
           </a:xfrm>
           <a:prstGeom prst="rect">
             <a:avLst/>
@@ -5613,24 +6001,24 @@
         </p:nvSpPr>
         <p:spPr>
           <a:xfrm>
-            <a:off x="7237476" y="2066544"/>
-            <a:ext cx="4155948" cy="457200"/>
-          </a:xfrm>
-          <a:prstGeom prst="rect">
-            <a:avLst/>
-          </a:prstGeom>
-          <a:noFill/>
-          <a:ln/>
-        </p:spPr>
-        <p:txBody>
-          <a:bodyPr wrap="square" lIns="0" tIns="0" rIns="0" bIns="0" rtlCol="0" anchor="t"/>
+            <a:off x="1572768" y="3456432"/>
+            <a:ext cx="6400800" cy="457200"/>
+          </a:xfrm>
+          <a:prstGeom prst="rect">
+            <a:avLst/>
+          </a:prstGeom>
+          <a:noFill/>
+          <a:ln/>
+        </p:spPr>
+        <p:txBody>
+          <a:bodyPr wrap="square" lIns="0" tIns="0" rIns="0" bIns="0" rtlCol="0" anchor="ctr"/>
           <a:lstStyle/>
           <a:p>
             <a:pPr indent="0" marL="0">
               <a:buNone/>
             </a:pPr>
             <a:r>
-              <a:rPr lang="en-US" sz="1550" b="1" dirty="0">
+              <a:rPr lang="en-US" sz="1700" b="1" dirty="0">
                 <a:solidFill>
                   <a:srgbClr val="0E1B3D"/>
                 </a:solidFill>
@@ -5638,9 +6026,23 @@
                 <a:ea typeface="Cambria" pitchFamily="34" charset="-122"/>
                 <a:cs typeface="Cambria" pitchFamily="34" charset="-120"/>
               </a:rPr>
-              <a:t>パッチ運用の徹底と棚卸し</a:t>
-            </a:r>
-            <a:endParaRPr lang="en-US" sz="1550" dirty="0"/>
+              <a:t>内側で検知   </a:t>
+            </a:r>
+            <a:pPr indent="0" marL="0">
+              <a:buNone/>
+            </a:pPr>
+            <a:r>
+              <a:rPr lang="en-US" sz="1300" b="1" dirty="0">
+                <a:solidFill>
+                  <a:srgbClr val="3E5C76"/>
+                </a:solidFill>
+                <a:latin typeface="Cambria" pitchFamily="34" charset="0"/>
+                <a:ea typeface="Cambria" pitchFamily="34" charset="-122"/>
+                <a:cs typeface="Cambria" pitchFamily="34" charset="-120"/>
+              </a:rPr>
+              <a:t>EDR(SentinelOne)</a:t>
+            </a:r>
+            <a:endParaRPr lang="en-US" sz="1700" dirty="0"/>
           </a:p>
         </p:txBody>
       </p:sp>
@@ -5652,8 +6054,8 @@
         </p:nvSpPr>
         <p:spPr>
           <a:xfrm>
-            <a:off x="7237476" y="2487168"/>
-            <a:ext cx="4155948" cy="502920"/>
+            <a:off x="1572768" y="3877056"/>
+            <a:ext cx="6400800" cy="457200"/>
           </a:xfrm>
           <a:prstGeom prst="rect">
             <a:avLst/>
@@ -5666,9 +6068,6 @@
           <a:lstStyle/>
           <a:p>
             <a:pPr indent="0" marL="0">
-              <a:lnSpc>
-                <a:spcPts val="1600"/>
-              </a:lnSpc>
               <a:buNone/>
             </a:pPr>
             <a:r>
@@ -5680,7 +6079,7 @@
                 <a:ea typeface="Calibri" pitchFamily="34" charset="-122"/>
                 <a:cs typeface="Calibri" pitchFamily="34" charset="-120"/>
               </a:rPr>
-              <a:t>侵入元の約半数は未パッチ。適用状況を継続的に可視化</a:t>
+              <a:t>侵入されても被害拡大を検知・抑制</a:t>
             </a:r>
             <a:endParaRPr lang="en-US" sz="1250" dirty="0"/>
           </a:p>
@@ -5694,12 +6093,12 @@
         </p:nvSpPr>
         <p:spPr>
           <a:xfrm>
-            <a:off x="566928" y="3246120"/>
-            <a:ext cx="5344668" cy="1143000"/>
+            <a:off x="566928" y="4608576"/>
+            <a:ext cx="7498080" cy="1097280"/>
           </a:xfrm>
           <a:prstGeom prst="roundRect">
             <a:avLst>
-              <a:gd name="adj" fmla="val 6400"/>
+              <a:gd name="adj" fmla="val 6667"/>
             </a:avLst>
           </a:prstGeom>
           <a:solidFill>
@@ -5728,14 +6127,14 @@
         </p:nvSpPr>
         <p:spPr>
           <a:xfrm>
-            <a:off x="795528" y="3529584"/>
-            <a:ext cx="566928" cy="566928"/>
+            <a:off x="795528" y="4864608"/>
+            <a:ext cx="585216" cy="585216"/>
           </a:xfrm>
           <a:prstGeom prst="ellipse">
             <a:avLst/>
           </a:prstGeom>
           <a:solidFill>
-            <a:srgbClr val="C8102E"/>
+            <a:srgbClr val="1E7A46"/>
           </a:solidFill>
           <a:ln/>
         </p:spPr>
@@ -5748,8 +6147,8 @@
         </p:nvSpPr>
         <p:spPr>
           <a:xfrm>
-            <a:off x="795528" y="3529584"/>
-            <a:ext cx="566928" cy="566928"/>
+            <a:off x="795528" y="4864608"/>
+            <a:ext cx="585216" cy="585216"/>
           </a:xfrm>
           <a:prstGeom prst="rect">
             <a:avLst/>
@@ -5787,24 +6186,24 @@
         </p:nvSpPr>
         <p:spPr>
           <a:xfrm>
-            <a:off x="1527048" y="3392424"/>
-            <a:ext cx="4155948" cy="457200"/>
-          </a:xfrm>
-          <a:prstGeom prst="rect">
-            <a:avLst/>
-          </a:prstGeom>
-          <a:noFill/>
-          <a:ln/>
-        </p:spPr>
-        <p:txBody>
-          <a:bodyPr wrap="square" lIns="0" tIns="0" rIns="0" bIns="0" rtlCol="0" anchor="t"/>
+            <a:off x="1572768" y="4754880"/>
+            <a:ext cx="6400800" cy="457200"/>
+          </a:xfrm>
+          <a:prstGeom prst="rect">
+            <a:avLst/>
+          </a:prstGeom>
+          <a:noFill/>
+          <a:ln/>
+        </p:spPr>
+        <p:txBody>
+          <a:bodyPr wrap="square" lIns="0" tIns="0" rIns="0" bIns="0" rtlCol="0" anchor="ctr"/>
           <a:lstStyle/>
           <a:p>
             <a:pPr indent="0" marL="0">
               <a:buNone/>
             </a:pPr>
             <a:r>
-              <a:rPr lang="en-US" sz="1550" b="1" dirty="0">
+              <a:rPr lang="en-US" sz="1700" b="1" dirty="0">
                 <a:solidFill>
                   <a:srgbClr val="0E1B3D"/>
                 </a:solidFill>
@@ -5812,9 +6211,23 @@
                 <a:ea typeface="Cambria" pitchFamily="34" charset="-122"/>
                 <a:cs typeface="Cambria" pitchFamily="34" charset="-120"/>
               </a:rPr>
-              <a:t>認証の強化（MFA・特権管理）</a:t>
-            </a:r>
-            <a:endParaRPr lang="en-US" sz="1550" dirty="0"/>
+              <a:t>備えと復旧   </a:t>
+            </a:r>
+            <a:pPr indent="0" marL="0">
+              <a:buNone/>
+            </a:pPr>
+            <a:r>
+              <a:rPr lang="en-US" sz="1300" b="1" dirty="0">
+                <a:solidFill>
+                  <a:srgbClr val="1E7A46"/>
+                </a:solidFill>
+                <a:latin typeface="Cambria" pitchFamily="34" charset="0"/>
+                <a:ea typeface="Cambria" pitchFamily="34" charset="-122"/>
+                <a:cs typeface="Cambria" pitchFamily="34" charset="-120"/>
+              </a:rPr>
+              <a:t>バックアップ・監視・訓練</a:t>
+            </a:r>
+            <a:endParaRPr lang="en-US" sz="1700" dirty="0"/>
           </a:p>
         </p:txBody>
       </p:sp>
@@ -5826,8 +6239,8 @@
         </p:nvSpPr>
         <p:spPr>
           <a:xfrm>
-            <a:off x="1527048" y="3813048"/>
-            <a:ext cx="4155948" cy="502920"/>
+            <a:off x="1572768" y="5175504"/>
+            <a:ext cx="6400800" cy="457200"/>
           </a:xfrm>
           <a:prstGeom prst="rect">
             <a:avLst/>
@@ -5840,9 +6253,6 @@
           <a:lstStyle/>
           <a:p>
             <a:pPr indent="0" marL="0">
-              <a:lnSpc>
-                <a:spcPts val="1600"/>
-              </a:lnSpc>
               <a:buNone/>
             </a:pPr>
             <a:r>
@@ -5854,7 +6264,7 @@
                 <a:ea typeface="Calibri" pitchFamily="34" charset="-122"/>
                 <a:cs typeface="Calibri" pitchFamily="34" charset="-120"/>
               </a:rPr>
-              <a:t>盗まれた正規アカウントでの侵入を防ぐ。ADの保護を優先</a:t>
+              <a:t>最悪時に事業を止めない</a:t>
             </a:r>
             <a:endParaRPr lang="en-US" sz="1250" dirty="0"/>
           </a:p>
@@ -5868,7 +6278,273 @@
         </p:nvSpPr>
         <p:spPr>
           <a:xfrm>
-            <a:off x="6277356" y="3246120"/>
+            <a:off x="8366760" y="2011680"/>
+            <a:ext cx="3255264" cy="3712464"/>
+          </a:xfrm>
+          <a:prstGeom prst="roundRect">
+            <a:avLst>
+              <a:gd name="adj" fmla="val 2809"/>
+            </a:avLst>
+          </a:prstGeom>
+          <a:solidFill>
+            <a:srgbClr val="0E1B3D"/>
+          </a:solidFill>
+          <a:ln/>
+          <a:effectLst>
+            <a:outerShdw sx="100000" sy="100000" kx="0" ky="0" algn="bl" rotWithShape="0" blurRad="101600" dist="38100" dir="5400000">
+              <a:srgbClr val="8A93A6">
+                <a:alpha val="28000"/>
+              </a:srgbClr>
+            </a:outerShdw>
+          </a:effectLst>
+        </p:spPr>
+      </p:sp>
+      <p:sp>
+        <p:nvSpPr>
+          <p:cNvPr id="20" name="Text 18"/>
+          <p:cNvSpPr/>
+          <p:nvPr/>
+        </p:nvSpPr>
+        <p:spPr>
+          <a:xfrm>
+            <a:off x="8595360" y="2286000"/>
+            <a:ext cx="2779776" cy="3200400"/>
+          </a:xfrm>
+          <a:prstGeom prst="rect">
+            <a:avLst/>
+          </a:prstGeom>
+          <a:noFill/>
+          <a:ln/>
+        </p:spPr>
+        <p:txBody>
+          <a:bodyPr wrap="square" lIns="0" tIns="0" rIns="0" bIns="0" rtlCol="0" anchor="t"/>
+          <a:lstStyle/>
+          <a:p>
+            <a:pPr indent="0" marL="0">
+              <a:lnSpc>
+                <a:spcPts val="2000"/>
+              </a:lnSpc>
+              <a:spcAft>
+                <a:spcPts val="1000"/>
+              </a:spcAft>
+              <a:buNone/>
+            </a:pPr>
+            <a:r>
+              <a:rPr lang="en-US" sz="1800" b="1" dirty="0">
+                <a:solidFill>
+                  <a:srgbClr val="FF6B81"/>
+                </a:solidFill>
+                <a:latin typeface="Calibri" pitchFamily="34" charset="0"/>
+                <a:ea typeface="Calibri" pitchFamily="34" charset="-122"/>
+                <a:cs typeface="Calibri" pitchFamily="34" charset="-120"/>
+              </a:rPr>
+              <a:t>S-1は層②。</a:t>
+            </a:r>
+            <a:endParaRPr lang="en-US" sz="1800" dirty="0"/>
+          </a:p>
+          <a:p>
+            <a:pPr indent="0" marL="0">
+              <a:lnSpc>
+                <a:spcPts val="2000"/>
+              </a:lnSpc>
+              <a:spcAft>
+                <a:spcPts val="1400"/>
+              </a:spcAft>
+              <a:buNone/>
+            </a:pPr>
+            <a:r>
+              <a:rPr lang="en-US" sz="1400" dirty="0">
+                <a:solidFill>
+                  <a:srgbClr val="DCE6F5"/>
+                </a:solidFill>
+                <a:latin typeface="Calibri" pitchFamily="34" charset="0"/>
+                <a:ea typeface="Calibri" pitchFamily="34" charset="-122"/>
+                <a:cs typeface="Calibri" pitchFamily="34" charset="-120"/>
+              </a:rPr>
+              <a:t>層①（入口）が抜けたままでは、攻撃者は容易に侵入し、層②を無効化しにいく。</a:t>
+            </a:r>
+            <a:endParaRPr lang="en-US" sz="1800" dirty="0"/>
+          </a:p>
+          <a:p>
+            <a:pPr indent="0" marL="0">
+              <a:lnSpc>
+                <a:spcPts val="2000"/>
+              </a:lnSpc>
+              <a:buNone/>
+            </a:pPr>
+            <a:r>
+              <a:rPr lang="en-US" sz="1400" b="1" dirty="0">
+                <a:solidFill>
+                  <a:srgbClr val="FFFFFF"/>
+                </a:solidFill>
+                <a:latin typeface="Calibri" pitchFamily="34" charset="0"/>
+                <a:ea typeface="Calibri" pitchFamily="34" charset="-122"/>
+                <a:cs typeface="Calibri" pitchFamily="34" charset="-120"/>
+              </a:rPr>
+              <a:t>脆弱性検査は層②を置き換えるものではなく、層②が守る前提となる層①を成立させるもの。</a:t>
+            </a:r>
+            <a:endParaRPr lang="en-US" sz="1800" dirty="0"/>
+          </a:p>
+        </p:txBody>
+      </p:sp>
+      <p:sp>
+        <p:nvSpPr>
+          <p:cNvPr id="21" name="Text 19"/>
+          <p:cNvSpPr/>
+          <p:nvPr/>
+        </p:nvSpPr>
+        <p:spPr>
+          <a:xfrm>
+            <a:off x="11411712" y="6400800"/>
+            <a:ext cx="457200" cy="274320"/>
+          </a:xfrm>
+          <a:prstGeom prst="rect">
+            <a:avLst/>
+          </a:prstGeom>
+          <a:noFill/>
+          <a:ln/>
+        </p:spPr>
+        <p:txBody>
+          <a:bodyPr wrap="square" lIns="0" tIns="0" rIns="0" bIns="0" rtlCol="0" anchor="ctr"/>
+          <a:lstStyle/>
+          <a:p>
+            <a:pPr algn="r" indent="0" marL="0">
+              <a:buNone/>
+            </a:pPr>
+            <a:r>
+              <a:rPr lang="en-US" sz="1000" dirty="0">
+                <a:solidFill>
+                  <a:srgbClr val="68738A"/>
+                </a:solidFill>
+                <a:latin typeface="Calibri" pitchFamily="34" charset="0"/>
+                <a:ea typeface="Calibri" pitchFamily="34" charset="-122"/>
+                <a:cs typeface="Calibri" pitchFamily="34" charset="-120"/>
+              </a:rPr>
+              <a:t>12</a:t>
+            </a:r>
+            <a:endParaRPr lang="en-US" sz="1000" dirty="0"/>
+          </a:p>
+        </p:txBody>
+      </p:sp>
+    </p:spTree>
+  </p:cSld>
+  <p:clrMapOvr>
+    <a:masterClrMapping/>
+  </p:clrMapOvr>
+</p:sld>
+</file>
+
+<file path=ppt/slides/slide13.xml><?xml version="1.0" encoding="utf-8"?>
+<p:sld xmlns:a="http://schemas.openxmlformats.org/drawingml/2006/main" xmlns:r="http://schemas.openxmlformats.org/officeDocument/2006/relationships" xmlns:p="http://schemas.openxmlformats.org/presentationml/2006/main">
+  <p:cSld name="Slide 13">
+    <p:bg>
+      <p:bgPr>
+        <a:solidFill>
+          <a:srgbClr val="FFFFFF"/>
+        </a:solidFill>
+      </p:bgPr>
+    </p:bg>
+    <p:spTree>
+      <p:nvGrpSpPr>
+        <p:cNvPr id="1" name=""/>
+        <p:cNvGrpSpPr/>
+        <p:nvPr/>
+      </p:nvGrpSpPr>
+      <p:grpSpPr>
+        <a:xfrm>
+          <a:off x="0" y="0"/>
+          <a:ext cx="0" cy="0"/>
+          <a:chOff x="0" y="0"/>
+          <a:chExt cx="0" cy="0"/>
+        </a:xfrm>
+      </p:grpSpPr>
+      <p:sp>
+        <p:nvSpPr>
+          <p:cNvPr id="2" name="Text 0"/>
+          <p:cNvSpPr/>
+          <p:nvPr/>
+        </p:nvSpPr>
+        <p:spPr>
+          <a:xfrm>
+            <a:off x="566928" y="384048"/>
+            <a:ext cx="8229600" cy="274320"/>
+          </a:xfrm>
+          <a:prstGeom prst="rect">
+            <a:avLst/>
+          </a:prstGeom>
+          <a:noFill/>
+          <a:ln/>
+        </p:spPr>
+        <p:txBody>
+          <a:bodyPr wrap="square" lIns="0" tIns="0" rIns="0" bIns="0" rtlCol="0" anchor="ctr"/>
+          <a:lstStyle/>
+          <a:p>
+            <a:pPr algn="l" indent="0" marL="0">
+              <a:buNone/>
+            </a:pPr>
+            <a:r>
+              <a:rPr lang="en-US" sz="1200" b="1" spc="300" kern="0" dirty="0">
+                <a:solidFill>
+                  <a:srgbClr val="C8102E"/>
+                </a:solidFill>
+                <a:latin typeface="Calibri" pitchFamily="34" charset="0"/>
+                <a:ea typeface="Calibri" pitchFamily="34" charset="-122"/>
+                <a:cs typeface="Calibri" pitchFamily="34" charset="-120"/>
+              </a:rPr>
+              <a:t>Aenaへの提言</a:t>
+            </a:r>
+            <a:endParaRPr lang="en-US" sz="1200" dirty="0"/>
+          </a:p>
+        </p:txBody>
+      </p:sp>
+      <p:sp>
+        <p:nvSpPr>
+          <p:cNvPr id="3" name="Text 1"/>
+          <p:cNvSpPr/>
+          <p:nvPr/>
+        </p:nvSpPr>
+        <p:spPr>
+          <a:xfrm>
+            <a:off x="566928" y="658368"/>
+            <a:ext cx="11055096" cy="868680"/>
+          </a:xfrm>
+          <a:prstGeom prst="rect">
+            <a:avLst/>
+          </a:prstGeom>
+          <a:noFill/>
+          <a:ln/>
+        </p:spPr>
+        <p:txBody>
+          <a:bodyPr wrap="square" lIns="0" tIns="0" rIns="0" bIns="0" rtlCol="0" anchor="t"/>
+          <a:lstStyle/>
+          <a:p>
+            <a:pPr algn="l" indent="0" marL="0">
+              <a:buNone/>
+            </a:pPr>
+            <a:r>
+              <a:rPr lang="en-US" sz="3200" b="1" dirty="0">
+                <a:solidFill>
+                  <a:srgbClr val="0E1B3D"/>
+                </a:solidFill>
+                <a:latin typeface="Cambria" pitchFamily="34" charset="0"/>
+                <a:ea typeface="Cambria" pitchFamily="34" charset="-122"/>
+                <a:cs typeface="Cambria" pitchFamily="34" charset="-120"/>
+              </a:rPr>
+              <a:t>S-1に加えて今すぐ着手したい5項目</a:t>
+            </a:r>
+            <a:endParaRPr lang="en-US" sz="3200" dirty="0"/>
+          </a:p>
+        </p:txBody>
+      </p:sp>
+      <p:sp>
+        <p:nvSpPr>
+          <p:cNvPr id="4" name="Shape 2"/>
+          <p:cNvSpPr/>
+          <p:nvPr/>
+        </p:nvSpPr>
+        <p:spPr>
+          <a:xfrm>
+            <a:off x="566928" y="1920240"/>
             <a:ext cx="5344668" cy="1143000"/>
           </a:xfrm>
           <a:prstGeom prst="roundRect">
@@ -5896,13 +6572,13 @@
       </p:sp>
       <p:sp>
         <p:nvSpPr>
-          <p:cNvPr id="20" name="Shape 18"/>
-          <p:cNvSpPr/>
-          <p:nvPr/>
-        </p:nvSpPr>
-        <p:spPr>
-          <a:xfrm>
-            <a:off x="6505956" y="3529584"/>
+          <p:cNvPr id="5" name="Shape 3"/>
+          <p:cNvSpPr/>
+          <p:nvPr/>
+        </p:nvSpPr>
+        <p:spPr>
+          <a:xfrm>
+            <a:off x="795528" y="2203704"/>
             <a:ext cx="566928" cy="566928"/>
           </a:xfrm>
           <a:prstGeom prst="ellipse">
@@ -5916,13 +6592,13 @@
       </p:sp>
       <p:sp>
         <p:nvSpPr>
-          <p:cNvPr id="21" name="Text 19"/>
-          <p:cNvSpPr/>
-          <p:nvPr/>
-        </p:nvSpPr>
-        <p:spPr>
-          <a:xfrm>
-            <a:off x="6505956" y="3529584"/>
+          <p:cNvPr id="6" name="Text 4"/>
+          <p:cNvSpPr/>
+          <p:nvPr/>
+        </p:nvSpPr>
+        <p:spPr>
+          <a:xfrm>
+            <a:off x="795528" y="2203704"/>
             <a:ext cx="566928" cy="566928"/>
           </a:xfrm>
           <a:prstGeom prst="rect">
@@ -5947,7 +6623,7 @@
                 <a:ea typeface="Cambria" pitchFamily="34" charset="-122"/>
                 <a:cs typeface="Cambria" pitchFamily="34" charset="-120"/>
               </a:rPr>
-              <a:t>4</a:t>
+              <a:t>1</a:t>
             </a:r>
             <a:endParaRPr lang="en-US" sz="2200" dirty="0"/>
           </a:p>
@@ -5955,13 +6631,13 @@
       </p:sp>
       <p:sp>
         <p:nvSpPr>
-          <p:cNvPr id="22" name="Text 20"/>
-          <p:cNvSpPr/>
-          <p:nvPr/>
-        </p:nvSpPr>
-        <p:spPr>
-          <a:xfrm>
-            <a:off x="7237476" y="3392424"/>
+          <p:cNvPr id="7" name="Text 5"/>
+          <p:cNvSpPr/>
+          <p:nvPr/>
+        </p:nvSpPr>
+        <p:spPr>
+          <a:xfrm>
+            <a:off x="1527048" y="2066544"/>
             <a:ext cx="4155948" cy="457200"/>
           </a:xfrm>
           <a:prstGeom prst="rect">
@@ -5986,7 +6662,7 @@
                 <a:ea typeface="Cambria" pitchFamily="34" charset="-122"/>
                 <a:cs typeface="Cambria" pitchFamily="34" charset="-120"/>
               </a:rPr>
-              <a:t>SentinelOneの堅牢化設定</a:t>
+              <a:t>外部公開資産の脆弱性検査を定期実施</a:t>
             </a:r>
             <a:endParaRPr lang="en-US" sz="1550" dirty="0"/>
           </a:p>
@@ -5994,13 +6670,13 @@
       </p:sp>
       <p:sp>
         <p:nvSpPr>
-          <p:cNvPr id="23" name="Text 21"/>
-          <p:cNvSpPr/>
-          <p:nvPr/>
-        </p:nvSpPr>
-        <p:spPr>
-          <a:xfrm>
-            <a:off x="7237476" y="3813048"/>
+          <p:cNvPr id="8" name="Text 6"/>
+          <p:cNvSpPr/>
+          <p:nvPr/>
+        </p:nvSpPr>
+        <p:spPr>
+          <a:xfrm>
+            <a:off x="1527048" y="2487168"/>
             <a:ext cx="4155948" cy="502920"/>
           </a:xfrm>
           <a:prstGeom prst="rect">
@@ -6028,7 +6704,7 @@
                 <a:ea typeface="Calibri" pitchFamily="34" charset="-122"/>
                 <a:cs typeface="Calibri" pitchFamily="34" charset="-120"/>
               </a:rPr>
-              <a:t>Online Authorization等で無効化・改ざん回避を難しくする</a:t>
+              <a:t>VPN・公開サーバ・Webを対象に、悪用可能な入口を洗い出す</a:t>
             </a:r>
             <a:endParaRPr lang="en-US" sz="1250" dirty="0"/>
           </a:p>
@@ -6036,14 +6712,14 @@
       </p:sp>
       <p:sp>
         <p:nvSpPr>
-          <p:cNvPr id="24" name="Shape 22"/>
-          <p:cNvSpPr/>
-          <p:nvPr/>
-        </p:nvSpPr>
-        <p:spPr>
-          <a:xfrm>
-            <a:off x="566928" y="4572000"/>
-            <a:ext cx="11055096" cy="1143000"/>
+          <p:cNvPr id="9" name="Shape 7"/>
+          <p:cNvSpPr/>
+          <p:nvPr/>
+        </p:nvSpPr>
+        <p:spPr>
+          <a:xfrm>
+            <a:off x="6277356" y="1920240"/>
+            <a:ext cx="5344668" cy="1143000"/>
           </a:xfrm>
           <a:prstGeom prst="roundRect">
             <a:avLst>
@@ -6070,13 +6746,13 @@
       </p:sp>
       <p:sp>
         <p:nvSpPr>
-          <p:cNvPr id="25" name="Shape 23"/>
-          <p:cNvSpPr/>
-          <p:nvPr/>
-        </p:nvSpPr>
-        <p:spPr>
-          <a:xfrm>
-            <a:off x="795528" y="4855464"/>
+          <p:cNvPr id="10" name="Shape 8"/>
+          <p:cNvSpPr/>
+          <p:nvPr/>
+        </p:nvSpPr>
+        <p:spPr>
+          <a:xfrm>
+            <a:off x="6505956" y="2203704"/>
             <a:ext cx="566928" cy="566928"/>
           </a:xfrm>
           <a:prstGeom prst="ellipse">
@@ -6090,13 +6766,13 @@
       </p:sp>
       <p:sp>
         <p:nvSpPr>
-          <p:cNvPr id="26" name="Text 24"/>
-          <p:cNvSpPr/>
-          <p:nvPr/>
-        </p:nvSpPr>
-        <p:spPr>
-          <a:xfrm>
-            <a:off x="795528" y="4855464"/>
+          <p:cNvPr id="11" name="Text 9"/>
+          <p:cNvSpPr/>
+          <p:nvPr/>
+        </p:nvSpPr>
+        <p:spPr>
+          <a:xfrm>
+            <a:off x="6505956" y="2203704"/>
             <a:ext cx="566928" cy="566928"/>
           </a:xfrm>
           <a:prstGeom prst="rect">
@@ -6121,7 +6797,7 @@
                 <a:ea typeface="Cambria" pitchFamily="34" charset="-122"/>
                 <a:cs typeface="Cambria" pitchFamily="34" charset="-120"/>
               </a:rPr>
-              <a:t>5</a:t>
+              <a:t>2</a:t>
             </a:r>
             <a:endParaRPr lang="en-US" sz="2200" dirty="0"/>
           </a:p>
@@ -6129,14 +6805,14 @@
       </p:sp>
       <p:sp>
         <p:nvSpPr>
-          <p:cNvPr id="27" name="Text 25"/>
-          <p:cNvSpPr/>
-          <p:nvPr/>
-        </p:nvSpPr>
-        <p:spPr>
-          <a:xfrm>
-            <a:off x="1527048" y="4718304"/>
-            <a:ext cx="9866376" cy="457200"/>
+          <p:cNvPr id="12" name="Text 10"/>
+          <p:cNvSpPr/>
+          <p:nvPr/>
+        </p:nvSpPr>
+        <p:spPr>
+          <a:xfrm>
+            <a:off x="7237476" y="2066544"/>
+            <a:ext cx="4155948" cy="457200"/>
           </a:xfrm>
           <a:prstGeom prst="rect">
             <a:avLst/>
@@ -6160,7 +6836,7 @@
                 <a:ea typeface="Cambria" pitchFamily="34" charset="-122"/>
                 <a:cs typeface="Cambria" pitchFamily="34" charset="-120"/>
               </a:rPr>
-              <a:t>バックアップと復旧訓練</a:t>
+              <a:t>パッチ運用の徹底と棚卸し</a:t>
             </a:r>
             <a:endParaRPr lang="en-US" sz="1550" dirty="0"/>
           </a:p>
@@ -6168,14 +6844,14 @@
       </p:sp>
       <p:sp>
         <p:nvSpPr>
-          <p:cNvPr id="28" name="Text 26"/>
-          <p:cNvSpPr/>
-          <p:nvPr/>
-        </p:nvSpPr>
-        <p:spPr>
-          <a:xfrm>
-            <a:off x="1527048" y="5138928"/>
-            <a:ext cx="9866376" cy="502920"/>
+          <p:cNvPr id="13" name="Text 11"/>
+          <p:cNvSpPr/>
+          <p:nvPr/>
+        </p:nvSpPr>
+        <p:spPr>
+          <a:xfrm>
+            <a:off x="7237476" y="2487168"/>
+            <a:ext cx="4155948" cy="502920"/>
           </a:xfrm>
           <a:prstGeom prst="rect">
             <a:avLst/>
@@ -6202,7 +6878,7 @@
                 <a:ea typeface="Calibri" pitchFamily="34" charset="-122"/>
                 <a:cs typeface="Calibri" pitchFamily="34" charset="-120"/>
               </a:rPr>
-              <a:t>暗号化されても事業を止めない。オフライン保管と定期演習</a:t>
+              <a:t>侵入元の約半数は未パッチ。適用状況を継続的に可視化</a:t>
             </a:r>
             <a:endParaRPr lang="en-US" sz="1250" dirty="0"/>
           </a:p>
@@ -6210,14 +6886,68 @@
       </p:sp>
       <p:sp>
         <p:nvSpPr>
-          <p:cNvPr id="29" name="Text 27"/>
-          <p:cNvSpPr/>
-          <p:nvPr/>
-        </p:nvSpPr>
-        <p:spPr>
-          <a:xfrm>
-            <a:off x="11411712" y="6400800"/>
-            <a:ext cx="457200" cy="274320"/>
+          <p:cNvPr id="14" name="Shape 12"/>
+          <p:cNvSpPr/>
+          <p:nvPr/>
+        </p:nvSpPr>
+        <p:spPr>
+          <a:xfrm>
+            <a:off x="566928" y="3246120"/>
+            <a:ext cx="5344668" cy="1143000"/>
+          </a:xfrm>
+          <a:prstGeom prst="roundRect">
+            <a:avLst>
+              <a:gd name="adj" fmla="val 6400"/>
+            </a:avLst>
+          </a:prstGeom>
+          <a:solidFill>
+            <a:srgbClr val="F4F6FB"/>
+          </a:solidFill>
+          <a:ln w="12700">
+            <a:solidFill>
+              <a:srgbClr val="E2E8F4"/>
+            </a:solidFill>
+            <a:prstDash val="solid"/>
+          </a:ln>
+          <a:effectLst>
+            <a:outerShdw sx="100000" sy="100000" kx="0" ky="0" algn="bl" rotWithShape="0" blurRad="101600" dist="38100" dir="5400000">
+              <a:srgbClr val="8A93A6">
+                <a:alpha val="28000"/>
+              </a:srgbClr>
+            </a:outerShdw>
+          </a:effectLst>
+        </p:spPr>
+      </p:sp>
+      <p:sp>
+        <p:nvSpPr>
+          <p:cNvPr id="15" name="Shape 13"/>
+          <p:cNvSpPr/>
+          <p:nvPr/>
+        </p:nvSpPr>
+        <p:spPr>
+          <a:xfrm>
+            <a:off x="795528" y="3529584"/>
+            <a:ext cx="566928" cy="566928"/>
+          </a:xfrm>
+          <a:prstGeom prst="ellipse">
+            <a:avLst/>
+          </a:prstGeom>
+          <a:solidFill>
+            <a:srgbClr val="C8102E"/>
+          </a:solidFill>
+          <a:ln/>
+        </p:spPr>
+      </p:sp>
+      <p:sp>
+        <p:nvSpPr>
+          <p:cNvPr id="16" name="Text 14"/>
+          <p:cNvSpPr/>
+          <p:nvPr/>
+        </p:nvSpPr>
+        <p:spPr>
+          <a:xfrm>
+            <a:off x="795528" y="3529584"/>
+            <a:ext cx="566928" cy="566928"/>
           </a:xfrm>
           <a:prstGeom prst="rect">
             <a:avLst/>
@@ -6229,19 +6959,487 @@
           <a:bodyPr wrap="square" lIns="0" tIns="0" rIns="0" bIns="0" rtlCol="0" anchor="ctr"/>
           <a:lstStyle/>
           <a:p>
-            <a:pPr algn="r" indent="0" marL="0">
-              <a:buNone/>
-            </a:pPr>
-            <a:r>
-              <a:rPr lang="en-US" sz="1000" dirty="0">
-                <a:solidFill>
-                  <a:srgbClr val="68738A"/>
+            <a:pPr algn="ctr" indent="0" marL="0">
+              <a:buNone/>
+            </a:pPr>
+            <a:r>
+              <a:rPr lang="en-US" sz="2200" b="1" dirty="0">
+                <a:solidFill>
+                  <a:srgbClr val="FFFFFF"/>
+                </a:solidFill>
+                <a:latin typeface="Cambria" pitchFamily="34" charset="0"/>
+                <a:ea typeface="Cambria" pitchFamily="34" charset="-122"/>
+                <a:cs typeface="Cambria" pitchFamily="34" charset="-120"/>
+              </a:rPr>
+              <a:t>3</a:t>
+            </a:r>
+            <a:endParaRPr lang="en-US" sz="2200" dirty="0"/>
+          </a:p>
+        </p:txBody>
+      </p:sp>
+      <p:sp>
+        <p:nvSpPr>
+          <p:cNvPr id="17" name="Text 15"/>
+          <p:cNvSpPr/>
+          <p:nvPr/>
+        </p:nvSpPr>
+        <p:spPr>
+          <a:xfrm>
+            <a:off x="1527048" y="3392424"/>
+            <a:ext cx="4155948" cy="457200"/>
+          </a:xfrm>
+          <a:prstGeom prst="rect">
+            <a:avLst/>
+          </a:prstGeom>
+          <a:noFill/>
+          <a:ln/>
+        </p:spPr>
+        <p:txBody>
+          <a:bodyPr wrap="square" lIns="0" tIns="0" rIns="0" bIns="0" rtlCol="0" anchor="t"/>
+          <a:lstStyle/>
+          <a:p>
+            <a:pPr indent="0" marL="0">
+              <a:buNone/>
+            </a:pPr>
+            <a:r>
+              <a:rPr lang="en-US" sz="1550" b="1" dirty="0">
+                <a:solidFill>
+                  <a:srgbClr val="0E1B3D"/>
+                </a:solidFill>
+                <a:latin typeface="Cambria" pitchFamily="34" charset="0"/>
+                <a:ea typeface="Cambria" pitchFamily="34" charset="-122"/>
+                <a:cs typeface="Cambria" pitchFamily="34" charset="-120"/>
+              </a:rPr>
+              <a:t>認証の強化（MFA・特権管理）</a:t>
+            </a:r>
+            <a:endParaRPr lang="en-US" sz="1550" dirty="0"/>
+          </a:p>
+        </p:txBody>
+      </p:sp>
+      <p:sp>
+        <p:nvSpPr>
+          <p:cNvPr id="18" name="Text 16"/>
+          <p:cNvSpPr/>
+          <p:nvPr/>
+        </p:nvSpPr>
+        <p:spPr>
+          <a:xfrm>
+            <a:off x="1527048" y="3813048"/>
+            <a:ext cx="4155948" cy="502920"/>
+          </a:xfrm>
+          <a:prstGeom prst="rect">
+            <a:avLst/>
+          </a:prstGeom>
+          <a:noFill/>
+          <a:ln/>
+        </p:spPr>
+        <p:txBody>
+          <a:bodyPr wrap="square" lIns="0" tIns="0" rIns="0" bIns="0" rtlCol="0" anchor="t"/>
+          <a:lstStyle/>
+          <a:p>
+            <a:pPr indent="0" marL="0">
+              <a:lnSpc>
+                <a:spcPts val="1600"/>
+              </a:lnSpc>
+              <a:buNone/>
+            </a:pPr>
+            <a:r>
+              <a:rPr lang="en-US" sz="1250" dirty="0">
+                <a:solidFill>
+                  <a:srgbClr val="1A2332"/>
                 </a:solidFill>
                 <a:latin typeface="Calibri" pitchFamily="34" charset="0"/>
                 <a:ea typeface="Calibri" pitchFamily="34" charset="-122"/>
                 <a:cs typeface="Calibri" pitchFamily="34" charset="-120"/>
               </a:rPr>
-              <a:t>12</a:t>
+              <a:t>盗まれた正規アカウントでの侵入を防ぐ。ADの保護を優先</a:t>
+            </a:r>
+            <a:endParaRPr lang="en-US" sz="1250" dirty="0"/>
+          </a:p>
+        </p:txBody>
+      </p:sp>
+      <p:sp>
+        <p:nvSpPr>
+          <p:cNvPr id="19" name="Shape 17"/>
+          <p:cNvSpPr/>
+          <p:nvPr/>
+        </p:nvSpPr>
+        <p:spPr>
+          <a:xfrm>
+            <a:off x="6277356" y="3246120"/>
+            <a:ext cx="5344668" cy="1143000"/>
+          </a:xfrm>
+          <a:prstGeom prst="roundRect">
+            <a:avLst>
+              <a:gd name="adj" fmla="val 6400"/>
+            </a:avLst>
+          </a:prstGeom>
+          <a:solidFill>
+            <a:srgbClr val="F4F6FB"/>
+          </a:solidFill>
+          <a:ln w="12700">
+            <a:solidFill>
+              <a:srgbClr val="E2E8F4"/>
+            </a:solidFill>
+            <a:prstDash val="solid"/>
+          </a:ln>
+          <a:effectLst>
+            <a:outerShdw sx="100000" sy="100000" kx="0" ky="0" algn="bl" rotWithShape="0" blurRad="101600" dist="38100" dir="5400000">
+              <a:srgbClr val="8A93A6">
+                <a:alpha val="28000"/>
+              </a:srgbClr>
+            </a:outerShdw>
+          </a:effectLst>
+        </p:spPr>
+      </p:sp>
+      <p:sp>
+        <p:nvSpPr>
+          <p:cNvPr id="20" name="Shape 18"/>
+          <p:cNvSpPr/>
+          <p:nvPr/>
+        </p:nvSpPr>
+        <p:spPr>
+          <a:xfrm>
+            <a:off x="6505956" y="3529584"/>
+            <a:ext cx="566928" cy="566928"/>
+          </a:xfrm>
+          <a:prstGeom prst="ellipse">
+            <a:avLst/>
+          </a:prstGeom>
+          <a:solidFill>
+            <a:srgbClr val="C8102E"/>
+          </a:solidFill>
+          <a:ln/>
+        </p:spPr>
+      </p:sp>
+      <p:sp>
+        <p:nvSpPr>
+          <p:cNvPr id="21" name="Text 19"/>
+          <p:cNvSpPr/>
+          <p:nvPr/>
+        </p:nvSpPr>
+        <p:spPr>
+          <a:xfrm>
+            <a:off x="6505956" y="3529584"/>
+            <a:ext cx="566928" cy="566928"/>
+          </a:xfrm>
+          <a:prstGeom prst="rect">
+            <a:avLst/>
+          </a:prstGeom>
+          <a:noFill/>
+          <a:ln/>
+        </p:spPr>
+        <p:txBody>
+          <a:bodyPr wrap="square" lIns="0" tIns="0" rIns="0" bIns="0" rtlCol="0" anchor="ctr"/>
+          <a:lstStyle/>
+          <a:p>
+            <a:pPr algn="ctr" indent="0" marL="0">
+              <a:buNone/>
+            </a:pPr>
+            <a:r>
+              <a:rPr lang="en-US" sz="2200" b="1" dirty="0">
+                <a:solidFill>
+                  <a:srgbClr val="FFFFFF"/>
+                </a:solidFill>
+                <a:latin typeface="Cambria" pitchFamily="34" charset="0"/>
+                <a:ea typeface="Cambria" pitchFamily="34" charset="-122"/>
+                <a:cs typeface="Cambria" pitchFamily="34" charset="-120"/>
+              </a:rPr>
+              <a:t>4</a:t>
+            </a:r>
+            <a:endParaRPr lang="en-US" sz="2200" dirty="0"/>
+          </a:p>
+        </p:txBody>
+      </p:sp>
+      <p:sp>
+        <p:nvSpPr>
+          <p:cNvPr id="22" name="Text 20"/>
+          <p:cNvSpPr/>
+          <p:nvPr/>
+        </p:nvSpPr>
+        <p:spPr>
+          <a:xfrm>
+            <a:off x="7237476" y="3392424"/>
+            <a:ext cx="4155948" cy="457200"/>
+          </a:xfrm>
+          <a:prstGeom prst="rect">
+            <a:avLst/>
+          </a:prstGeom>
+          <a:noFill/>
+          <a:ln/>
+        </p:spPr>
+        <p:txBody>
+          <a:bodyPr wrap="square" lIns="0" tIns="0" rIns="0" bIns="0" rtlCol="0" anchor="t"/>
+          <a:lstStyle/>
+          <a:p>
+            <a:pPr indent="0" marL="0">
+              <a:buNone/>
+            </a:pPr>
+            <a:r>
+              <a:rPr lang="en-US" sz="1550" b="1" dirty="0">
+                <a:solidFill>
+                  <a:srgbClr val="0E1B3D"/>
+                </a:solidFill>
+                <a:latin typeface="Cambria" pitchFamily="34" charset="0"/>
+                <a:ea typeface="Cambria" pitchFamily="34" charset="-122"/>
+                <a:cs typeface="Cambria" pitchFamily="34" charset="-120"/>
+              </a:rPr>
+              <a:t>SentinelOneの堅牢化設定</a:t>
+            </a:r>
+            <a:endParaRPr lang="en-US" sz="1550" dirty="0"/>
+          </a:p>
+        </p:txBody>
+      </p:sp>
+      <p:sp>
+        <p:nvSpPr>
+          <p:cNvPr id="23" name="Text 21"/>
+          <p:cNvSpPr/>
+          <p:nvPr/>
+        </p:nvSpPr>
+        <p:spPr>
+          <a:xfrm>
+            <a:off x="7237476" y="3813048"/>
+            <a:ext cx="4155948" cy="502920"/>
+          </a:xfrm>
+          <a:prstGeom prst="rect">
+            <a:avLst/>
+          </a:prstGeom>
+          <a:noFill/>
+          <a:ln/>
+        </p:spPr>
+        <p:txBody>
+          <a:bodyPr wrap="square" lIns="0" tIns="0" rIns="0" bIns="0" rtlCol="0" anchor="t"/>
+          <a:lstStyle/>
+          <a:p>
+            <a:pPr indent="0" marL="0">
+              <a:lnSpc>
+                <a:spcPts val="1600"/>
+              </a:lnSpc>
+              <a:buNone/>
+            </a:pPr>
+            <a:r>
+              <a:rPr lang="en-US" sz="1250" dirty="0">
+                <a:solidFill>
+                  <a:srgbClr val="1A2332"/>
+                </a:solidFill>
+                <a:latin typeface="Calibri" pitchFamily="34" charset="0"/>
+                <a:ea typeface="Calibri" pitchFamily="34" charset="-122"/>
+                <a:cs typeface="Calibri" pitchFamily="34" charset="-120"/>
+              </a:rPr>
+              <a:t>Online Authorization等で無効化・改ざん回避を難しくする</a:t>
+            </a:r>
+            <a:endParaRPr lang="en-US" sz="1250" dirty="0"/>
+          </a:p>
+        </p:txBody>
+      </p:sp>
+      <p:sp>
+        <p:nvSpPr>
+          <p:cNvPr id="24" name="Shape 22"/>
+          <p:cNvSpPr/>
+          <p:nvPr/>
+        </p:nvSpPr>
+        <p:spPr>
+          <a:xfrm>
+            <a:off x="566928" y="4572000"/>
+            <a:ext cx="11055096" cy="1143000"/>
+          </a:xfrm>
+          <a:prstGeom prst="roundRect">
+            <a:avLst>
+              <a:gd name="adj" fmla="val 6400"/>
+            </a:avLst>
+          </a:prstGeom>
+          <a:solidFill>
+            <a:srgbClr val="F4F6FB"/>
+          </a:solidFill>
+          <a:ln w="12700">
+            <a:solidFill>
+              <a:srgbClr val="E2E8F4"/>
+            </a:solidFill>
+            <a:prstDash val="solid"/>
+          </a:ln>
+          <a:effectLst>
+            <a:outerShdw sx="100000" sy="100000" kx="0" ky="0" algn="bl" rotWithShape="0" blurRad="101600" dist="38100" dir="5400000">
+              <a:srgbClr val="8A93A6">
+                <a:alpha val="28000"/>
+              </a:srgbClr>
+            </a:outerShdw>
+          </a:effectLst>
+        </p:spPr>
+      </p:sp>
+      <p:sp>
+        <p:nvSpPr>
+          <p:cNvPr id="25" name="Shape 23"/>
+          <p:cNvSpPr/>
+          <p:nvPr/>
+        </p:nvSpPr>
+        <p:spPr>
+          <a:xfrm>
+            <a:off x="795528" y="4855464"/>
+            <a:ext cx="566928" cy="566928"/>
+          </a:xfrm>
+          <a:prstGeom prst="ellipse">
+            <a:avLst/>
+          </a:prstGeom>
+          <a:solidFill>
+            <a:srgbClr val="C8102E"/>
+          </a:solidFill>
+          <a:ln/>
+        </p:spPr>
+      </p:sp>
+      <p:sp>
+        <p:nvSpPr>
+          <p:cNvPr id="26" name="Text 24"/>
+          <p:cNvSpPr/>
+          <p:nvPr/>
+        </p:nvSpPr>
+        <p:spPr>
+          <a:xfrm>
+            <a:off x="795528" y="4855464"/>
+            <a:ext cx="566928" cy="566928"/>
+          </a:xfrm>
+          <a:prstGeom prst="rect">
+            <a:avLst/>
+          </a:prstGeom>
+          <a:noFill/>
+          <a:ln/>
+        </p:spPr>
+        <p:txBody>
+          <a:bodyPr wrap="square" lIns="0" tIns="0" rIns="0" bIns="0" rtlCol="0" anchor="ctr"/>
+          <a:lstStyle/>
+          <a:p>
+            <a:pPr algn="ctr" indent="0" marL="0">
+              <a:buNone/>
+            </a:pPr>
+            <a:r>
+              <a:rPr lang="en-US" sz="2200" b="1" dirty="0">
+                <a:solidFill>
+                  <a:srgbClr val="FFFFFF"/>
+                </a:solidFill>
+                <a:latin typeface="Cambria" pitchFamily="34" charset="0"/>
+                <a:ea typeface="Cambria" pitchFamily="34" charset="-122"/>
+                <a:cs typeface="Cambria" pitchFamily="34" charset="-120"/>
+              </a:rPr>
+              <a:t>5</a:t>
+            </a:r>
+            <a:endParaRPr lang="en-US" sz="2200" dirty="0"/>
+          </a:p>
+        </p:txBody>
+      </p:sp>
+      <p:sp>
+        <p:nvSpPr>
+          <p:cNvPr id="27" name="Text 25"/>
+          <p:cNvSpPr/>
+          <p:nvPr/>
+        </p:nvSpPr>
+        <p:spPr>
+          <a:xfrm>
+            <a:off x="1527048" y="4718304"/>
+            <a:ext cx="9866376" cy="457200"/>
+          </a:xfrm>
+          <a:prstGeom prst="rect">
+            <a:avLst/>
+          </a:prstGeom>
+          <a:noFill/>
+          <a:ln/>
+        </p:spPr>
+        <p:txBody>
+          <a:bodyPr wrap="square" lIns="0" tIns="0" rIns="0" bIns="0" rtlCol="0" anchor="t"/>
+          <a:lstStyle/>
+          <a:p>
+            <a:pPr indent="0" marL="0">
+              <a:buNone/>
+            </a:pPr>
+            <a:r>
+              <a:rPr lang="en-US" sz="1550" b="1" dirty="0">
+                <a:solidFill>
+                  <a:srgbClr val="0E1B3D"/>
+                </a:solidFill>
+                <a:latin typeface="Cambria" pitchFamily="34" charset="0"/>
+                <a:ea typeface="Cambria" pitchFamily="34" charset="-122"/>
+                <a:cs typeface="Cambria" pitchFamily="34" charset="-120"/>
+              </a:rPr>
+              <a:t>バックアップと復旧訓練</a:t>
+            </a:r>
+            <a:endParaRPr lang="en-US" sz="1550" dirty="0"/>
+          </a:p>
+        </p:txBody>
+      </p:sp>
+      <p:sp>
+        <p:nvSpPr>
+          <p:cNvPr id="28" name="Text 26"/>
+          <p:cNvSpPr/>
+          <p:nvPr/>
+        </p:nvSpPr>
+        <p:spPr>
+          <a:xfrm>
+            <a:off x="1527048" y="5138928"/>
+            <a:ext cx="9866376" cy="502920"/>
+          </a:xfrm>
+          <a:prstGeom prst="rect">
+            <a:avLst/>
+          </a:prstGeom>
+          <a:noFill/>
+          <a:ln/>
+        </p:spPr>
+        <p:txBody>
+          <a:bodyPr wrap="square" lIns="0" tIns="0" rIns="0" bIns="0" rtlCol="0" anchor="t"/>
+          <a:lstStyle/>
+          <a:p>
+            <a:pPr indent="0" marL="0">
+              <a:lnSpc>
+                <a:spcPts val="1600"/>
+              </a:lnSpc>
+              <a:buNone/>
+            </a:pPr>
+            <a:r>
+              <a:rPr lang="en-US" sz="1250" dirty="0">
+                <a:solidFill>
+                  <a:srgbClr val="1A2332"/>
+                </a:solidFill>
+                <a:latin typeface="Calibri" pitchFamily="34" charset="0"/>
+                <a:ea typeface="Calibri" pitchFamily="34" charset="-122"/>
+                <a:cs typeface="Calibri" pitchFamily="34" charset="-120"/>
+              </a:rPr>
+              <a:t>暗号化されても事業を止めない。オフライン保管と定期演習</a:t>
+            </a:r>
+            <a:endParaRPr lang="en-US" sz="1250" dirty="0"/>
+          </a:p>
+        </p:txBody>
+      </p:sp>
+      <p:sp>
+        <p:nvSpPr>
+          <p:cNvPr id="29" name="Text 27"/>
+          <p:cNvSpPr/>
+          <p:nvPr/>
+        </p:nvSpPr>
+        <p:spPr>
+          <a:xfrm>
+            <a:off x="11411712" y="6400800"/>
+            <a:ext cx="457200" cy="274320"/>
+          </a:xfrm>
+          <a:prstGeom prst="rect">
+            <a:avLst/>
+          </a:prstGeom>
+          <a:noFill/>
+          <a:ln/>
+        </p:spPr>
+        <p:txBody>
+          <a:bodyPr wrap="square" lIns="0" tIns="0" rIns="0" bIns="0" rtlCol="0" anchor="ctr"/>
+          <a:lstStyle/>
+          <a:p>
+            <a:pPr algn="r" indent="0" marL="0">
+              <a:buNone/>
+            </a:pPr>
+            <a:r>
+              <a:rPr lang="en-US" sz="1000" dirty="0">
+                <a:solidFill>
+                  <a:srgbClr val="68738A"/>
+                </a:solidFill>
+                <a:latin typeface="Calibri" pitchFamily="34" charset="0"/>
+                <a:ea typeface="Calibri" pitchFamily="34" charset="-122"/>
+                <a:cs typeface="Calibri" pitchFamily="34" charset="-120"/>
+              </a:rPr>
+              <a:t>13</a:t>
             </a:r>
             <a:endParaRPr lang="en-US" sz="1000" dirty="0"/>
           </a:p>
@@ -6255,9 +7453,9 @@
 </p:sld>
 </file>
 
-<file path=ppt/slides/slide13.xml><?xml version="1.0" encoding="utf-8"?>
+<file path=ppt/slides/slide14.xml><?xml version="1.0" encoding="utf-8"?>
 <p:sld xmlns:a="http://schemas.openxmlformats.org/drawingml/2006/main" xmlns:r="http://schemas.openxmlformats.org/officeDocument/2006/relationships" xmlns:p="http://schemas.openxmlformats.org/presentationml/2006/main">
-  <p:cSld name="Slide 13">
+  <p:cSld name="Slide 14">
     <p:bg>
       <p:bgPr>
         <a:solidFill>
@@ -6594,7 +7792,7 @@
                 <a:ea typeface="Calibri" pitchFamily="34" charset="-122"/>
                 <a:cs typeface="Calibri" pitchFamily="34" charset="-120"/>
               </a:rPr>
-              <a:t>13</a:t>
+              <a:t>14</a:t>
             </a:r>
             <a:endParaRPr lang="en-US" sz="1000" dirty="0"/>
           </a:p>
@@ -6608,9 +7806,9 @@
 </p:sld>
 </file>
 
-<file path=ppt/slides/slide14.xml><?xml version="1.0" encoding="utf-8"?>
+<file path=ppt/slides/slide15.xml><?xml version="1.0" encoding="utf-8"?>
 <p:sld xmlns:a="http://schemas.openxmlformats.org/drawingml/2006/main" xmlns:r="http://schemas.openxmlformats.org/officeDocument/2006/relationships" xmlns:p="http://schemas.openxmlformats.org/presentationml/2006/main">
-  <p:cSld name="Slide 14">
+  <p:cSld name="Slide 15">
     <p:bg>
       <p:bgPr>
         <a:solidFill>
@@ -6972,7 +8170,7 @@
                 <a:ea typeface="Calibri" pitchFamily="34" charset="-122"/>
                 <a:cs typeface="Calibri" pitchFamily="34" charset="-120"/>
               </a:rPr>
-              <a:t>14</a:t>
+              <a:t>15</a:t>
             </a:r>
             <a:endParaRPr lang="en-US" sz="1000" dirty="0"/>
           </a:p>
@@ -8741,7 +9939,7 @@
                 <a:ea typeface="Calibri" pitchFamily="34" charset="-122"/>
                 <a:cs typeface="Calibri" pitchFamily="34" charset="-120"/>
               </a:rPr>
-              <a:t>Active Directory を標的に管理者権限を奪い拡散</a:t>
+              <a:t>認証基盤（AD／SQL認証DB等）を標的に権限を奪い拡散</a:t>
             </a:r>
             <a:endParaRPr lang="en-US" sz="1150" dirty="0"/>
           </a:p>
@@ -10788,8 +11986,8 @@
         </p:nvSpPr>
         <p:spPr>
           <a:xfrm>
-            <a:off x="7315200" y="4590288"/>
-            <a:ext cx="4032504" cy="1097280"/>
+            <a:off x="7315200" y="4553712"/>
+            <a:ext cx="4032504" cy="1188720"/>
           </a:xfrm>
           <a:prstGeom prst="rect">
             <a:avLst/>
@@ -10803,15 +12001,15 @@
           <a:p>
             <a:pPr indent="0" marL="0">
               <a:lnSpc>
-                <a:spcPts val="1800"/>
+                <a:spcPts val="1500"/>
               </a:lnSpc>
               <a:spcAft>
-                <a:spcPts val="400"/>
+                <a:spcPts val="300"/>
               </a:spcAft>
               <a:buNone/>
             </a:pPr>
             <a:r>
-              <a:rPr lang="en-US" sz="1300" b="1" dirty="0">
+              <a:rPr lang="en-US" sz="1200" b="1" dirty="0">
                 <a:solidFill>
                   <a:srgbClr val="9FE0B5"/>
                 </a:solidFill>
@@ -10819,19 +12017,22 @@
                 <a:ea typeface="Calibri" pitchFamily="34" charset="-122"/>
                 <a:cs typeface="Calibri" pitchFamily="34" charset="-120"/>
               </a:rPr>
-              <a:t>緩和策（S-1側）：</a:t>
-            </a:r>
-            <a:endParaRPr lang="en-US" sz="1300" dirty="0"/>
+              <a:t>緩和策（S-1側・2025年1月提供）：</a:t>
+            </a:r>
+            <a:endParaRPr lang="en-US" sz="1200" dirty="0"/>
           </a:p>
           <a:p>
             <a:pPr indent="0" marL="0">
               <a:lnSpc>
-                <a:spcPts val="1800"/>
+                <a:spcPts val="1500"/>
               </a:lnSpc>
-              <a:buNone/>
-            </a:pPr>
-            <a:r>
-              <a:rPr lang="en-US" sz="1300" dirty="0">
+              <a:spcAft>
+                <a:spcPts val="300"/>
+              </a:spcAft>
+              <a:buNone/>
+            </a:pPr>
+            <a:r>
+              <a:rPr lang="en-US" sz="1200" dirty="0">
                 <a:solidFill>
                   <a:srgbClr val="DCE6F5"/>
                 </a:solidFill>
@@ -10839,9 +12040,29 @@
                 <a:ea typeface="Calibri" pitchFamily="34" charset="-122"/>
                 <a:cs typeface="Calibri" pitchFamily="34" charset="-120"/>
               </a:rPr>
-              <a:t>「Online Authorization」を有効化し、端末ローカルでのアップグレード/ダウングレードを禁止する。</a:t>
-            </a:r>
-            <a:endParaRPr lang="en-US" sz="1300" dirty="0"/>
+              <a:t>「Online Authorization」有効化＋検知ルール追加。</a:t>
+            </a:r>
+            <a:endParaRPr lang="en-US" sz="1200" dirty="0"/>
+          </a:p>
+          <a:p>
+            <a:pPr indent="0" marL="0">
+              <a:lnSpc>
+                <a:spcPts val="1500"/>
+              </a:lnSpc>
+              <a:buNone/>
+            </a:pPr>
+            <a:r>
+              <a:rPr lang="en-US" sz="1100" dirty="0">
+                <a:solidFill>
+                  <a:srgbClr val="FFD9A0"/>
+                </a:solidFill>
+                <a:latin typeface="Calibri" pitchFamily="34" charset="0"/>
+                <a:ea typeface="Calibri" pitchFamily="34" charset="-122"/>
+                <a:cs typeface="Calibri" pitchFamily="34" charset="-120"/>
+              </a:rPr>
+              <a:t>※既存導入は既定OFF＝手動で有効化を確認しない限り未対策。</a:t>
+            </a:r>
+            <a:endParaRPr lang="en-US" sz="1200" dirty="0"/>
           </a:p>
         </p:txBody>
       </p:sp>

</xml_diff>

<commit_message>
Update recommendations slide: verify S-1 Online Authorization, audit SQL credential storage
- スライド13を5→6項目に再構成(2×3): 「S-1のOnline Authorization有効化を確認」「認証情報のSQL保存方式を監査」を反映
- 項目1にSQLi対象を追記、項目3を委託先含め例外なしに一般化
- memory/context.md を更新

Co-Authored-By: Claude Opus 4.8 <noreply@anthropic.com>
Claude-Session: https://claude.ai/code/session_01EA4xD6dzVHyb75mdD2BWfh
</commit_message>
<xml_diff>
--- a/成果物/SentinelOne導入後も脆弱性検査が必要な理由.pptx
+++ b/成果物/SentinelOne導入後も脆弱性検査が必要な理由.pptx
@@ -6530,7 +6530,7 @@
                 <a:ea typeface="Cambria" pitchFamily="34" charset="-122"/>
                 <a:cs typeface="Cambria" pitchFamily="34" charset="-120"/>
               </a:rPr>
-              <a:t>S-1に加えて今すぐ着手したい5項目</a:t>
+              <a:t>S-1に加えて今すぐ着手したい6項目</a:t>
             </a:r>
             <a:endParaRPr lang="en-US" sz="3200" dirty="0"/>
           </a:p>
@@ -6544,12 +6544,12 @@
         </p:nvSpPr>
         <p:spPr>
           <a:xfrm>
-            <a:off x="566928" y="1920240"/>
-            <a:ext cx="5344668" cy="1143000"/>
+            <a:off x="566928" y="1874520"/>
+            <a:ext cx="5344668" cy="1188720"/>
           </a:xfrm>
           <a:prstGeom prst="roundRect">
             <a:avLst>
-              <a:gd name="adj" fmla="val 6400"/>
+              <a:gd name="adj" fmla="val 6154"/>
             </a:avLst>
           </a:prstGeom>
           <a:solidFill>
@@ -6578,7 +6578,7 @@
         </p:nvSpPr>
         <p:spPr>
           <a:xfrm>
-            <a:off x="795528" y="2203704"/>
+            <a:off x="795528" y="2185416"/>
             <a:ext cx="566928" cy="566928"/>
           </a:xfrm>
           <a:prstGeom prst="ellipse">
@@ -6598,7 +6598,7 @@
         </p:nvSpPr>
         <p:spPr>
           <a:xfrm>
-            <a:off x="795528" y="2203704"/>
+            <a:off x="795528" y="2185416"/>
             <a:ext cx="566928" cy="566928"/>
           </a:xfrm>
           <a:prstGeom prst="rect">
@@ -6637,7 +6637,7 @@
         </p:nvSpPr>
         <p:spPr>
           <a:xfrm>
-            <a:off x="1527048" y="2066544"/>
+            <a:off x="1527048" y="2011680"/>
             <a:ext cx="4155948" cy="457200"/>
           </a:xfrm>
           <a:prstGeom prst="rect">
@@ -6651,10 +6651,13 @@
           <a:lstStyle/>
           <a:p>
             <a:pPr indent="0" marL="0">
-              <a:buNone/>
-            </a:pPr>
-            <a:r>
-              <a:rPr lang="en-US" sz="1550" b="1" dirty="0">
+              <a:lnSpc>
+                <a:spcPts val="1700"/>
+              </a:lnSpc>
+              <a:buNone/>
+            </a:pPr>
+            <a:r>
+              <a:rPr lang="en-US" sz="1450" b="1" dirty="0">
                 <a:solidFill>
                   <a:srgbClr val="0E1B3D"/>
                 </a:solidFill>
@@ -6664,7 +6667,7 @@
               </a:rPr>
               <a:t>外部公開資産の脆弱性検査を定期実施</a:t>
             </a:r>
-            <a:endParaRPr lang="en-US" sz="1550" dirty="0"/>
+            <a:endParaRPr lang="en-US" sz="1450" dirty="0"/>
           </a:p>
         </p:txBody>
       </p:sp>
@@ -6676,8 +6679,8 @@
         </p:nvSpPr>
         <p:spPr>
           <a:xfrm>
-            <a:off x="1527048" y="2487168"/>
-            <a:ext cx="4155948" cy="502920"/>
+            <a:off x="1527048" y="2478024"/>
+            <a:ext cx="4155948" cy="512064"/>
           </a:xfrm>
           <a:prstGeom prst="rect">
             <a:avLst/>
@@ -6691,12 +6694,12 @@
           <a:p>
             <a:pPr indent="0" marL="0">
               <a:lnSpc>
-                <a:spcPts val="1600"/>
+                <a:spcPts val="1500"/>
               </a:lnSpc>
               <a:buNone/>
             </a:pPr>
             <a:r>
-              <a:rPr lang="en-US" sz="1250" dirty="0">
+              <a:rPr lang="en-US" sz="1200" dirty="0">
                 <a:solidFill>
                   <a:srgbClr val="1A2332"/>
                 </a:solidFill>
@@ -6704,9 +6707,9 @@
                 <a:ea typeface="Calibri" pitchFamily="34" charset="-122"/>
                 <a:cs typeface="Calibri" pitchFamily="34" charset="-120"/>
               </a:rPr>
-              <a:t>VPN・公開サーバ・Webを対象に、悪用可能な入口を洗い出す</a:t>
-            </a:r>
-            <a:endParaRPr lang="en-US" sz="1250" dirty="0"/>
+              <a:t>VPN・公開サーバ・Web/アプリ（SQLi含む）で悪用可能な入口を洗い出す</a:t>
+            </a:r>
+            <a:endParaRPr lang="en-US" sz="1200" dirty="0"/>
           </a:p>
         </p:txBody>
       </p:sp>
@@ -6718,12 +6721,12 @@
         </p:nvSpPr>
         <p:spPr>
           <a:xfrm>
-            <a:off x="6277356" y="1920240"/>
-            <a:ext cx="5344668" cy="1143000"/>
+            <a:off x="6277356" y="1874520"/>
+            <a:ext cx="5344668" cy="1188720"/>
           </a:xfrm>
           <a:prstGeom prst="roundRect">
             <a:avLst>
-              <a:gd name="adj" fmla="val 6400"/>
+              <a:gd name="adj" fmla="val 6154"/>
             </a:avLst>
           </a:prstGeom>
           <a:solidFill>
@@ -6752,7 +6755,7 @@
         </p:nvSpPr>
         <p:spPr>
           <a:xfrm>
-            <a:off x="6505956" y="2203704"/>
+            <a:off x="6505956" y="2185416"/>
             <a:ext cx="566928" cy="566928"/>
           </a:xfrm>
           <a:prstGeom prst="ellipse">
@@ -6772,7 +6775,7 @@
         </p:nvSpPr>
         <p:spPr>
           <a:xfrm>
-            <a:off x="6505956" y="2203704"/>
+            <a:off x="6505956" y="2185416"/>
             <a:ext cx="566928" cy="566928"/>
           </a:xfrm>
           <a:prstGeom prst="rect">
@@ -6811,7 +6814,7 @@
         </p:nvSpPr>
         <p:spPr>
           <a:xfrm>
-            <a:off x="7237476" y="2066544"/>
+            <a:off x="7237476" y="2011680"/>
             <a:ext cx="4155948" cy="457200"/>
           </a:xfrm>
           <a:prstGeom prst="rect">
@@ -6825,10 +6828,13 @@
           <a:lstStyle/>
           <a:p>
             <a:pPr indent="0" marL="0">
-              <a:buNone/>
-            </a:pPr>
-            <a:r>
-              <a:rPr lang="en-US" sz="1550" b="1" dirty="0">
+              <a:lnSpc>
+                <a:spcPts val="1700"/>
+              </a:lnSpc>
+              <a:buNone/>
+            </a:pPr>
+            <a:r>
+              <a:rPr lang="en-US" sz="1450" b="1" dirty="0">
                 <a:solidFill>
                   <a:srgbClr val="0E1B3D"/>
                 </a:solidFill>
@@ -6838,7 +6844,7 @@
               </a:rPr>
               <a:t>パッチ運用の徹底と棚卸し</a:t>
             </a:r>
-            <a:endParaRPr lang="en-US" sz="1550" dirty="0"/>
+            <a:endParaRPr lang="en-US" sz="1450" dirty="0"/>
           </a:p>
         </p:txBody>
       </p:sp>
@@ -6850,8 +6856,8 @@
         </p:nvSpPr>
         <p:spPr>
           <a:xfrm>
-            <a:off x="7237476" y="2487168"/>
-            <a:ext cx="4155948" cy="502920"/>
+            <a:off x="7237476" y="2478024"/>
+            <a:ext cx="4155948" cy="512064"/>
           </a:xfrm>
           <a:prstGeom prst="rect">
             <a:avLst/>
@@ -6865,12 +6871,12 @@
           <a:p>
             <a:pPr indent="0" marL="0">
               <a:lnSpc>
-                <a:spcPts val="1600"/>
+                <a:spcPts val="1500"/>
               </a:lnSpc>
               <a:buNone/>
             </a:pPr>
             <a:r>
-              <a:rPr lang="en-US" sz="1250" dirty="0">
+              <a:rPr lang="en-US" sz="1200" dirty="0">
                 <a:solidFill>
                   <a:srgbClr val="1A2332"/>
                 </a:solidFill>
@@ -6880,7 +6886,7 @@
               </a:rPr>
               <a:t>侵入元の約半数は未パッチ。適用状況を継続的に可視化</a:t>
             </a:r>
-            <a:endParaRPr lang="en-US" sz="1250" dirty="0"/>
+            <a:endParaRPr lang="en-US" sz="1200" dirty="0"/>
           </a:p>
         </p:txBody>
       </p:sp>
@@ -6893,11 +6899,11 @@
         <p:spPr>
           <a:xfrm>
             <a:off x="566928" y="3246120"/>
-            <a:ext cx="5344668" cy="1143000"/>
+            <a:ext cx="5344668" cy="1188720"/>
           </a:xfrm>
           <a:prstGeom prst="roundRect">
             <a:avLst>
-              <a:gd name="adj" fmla="val 6400"/>
+              <a:gd name="adj" fmla="val 6154"/>
             </a:avLst>
           </a:prstGeom>
           <a:solidFill>
@@ -6926,7 +6932,7 @@
         </p:nvSpPr>
         <p:spPr>
           <a:xfrm>
-            <a:off x="795528" y="3529584"/>
+            <a:off x="795528" y="3557016"/>
             <a:ext cx="566928" cy="566928"/>
           </a:xfrm>
           <a:prstGeom prst="ellipse">
@@ -6946,7 +6952,7 @@
         </p:nvSpPr>
         <p:spPr>
           <a:xfrm>
-            <a:off x="795528" y="3529584"/>
+            <a:off x="795528" y="3557016"/>
             <a:ext cx="566928" cy="566928"/>
           </a:xfrm>
           <a:prstGeom prst="rect">
@@ -6985,7 +6991,7 @@
         </p:nvSpPr>
         <p:spPr>
           <a:xfrm>
-            <a:off x="1527048" y="3392424"/>
+            <a:off x="1527048" y="3383280"/>
             <a:ext cx="4155948" cy="457200"/>
           </a:xfrm>
           <a:prstGeom prst="rect">
@@ -6999,10 +7005,13 @@
           <a:lstStyle/>
           <a:p>
             <a:pPr indent="0" marL="0">
-              <a:buNone/>
-            </a:pPr>
-            <a:r>
-              <a:rPr lang="en-US" sz="1550" b="1" dirty="0">
+              <a:lnSpc>
+                <a:spcPts val="1700"/>
+              </a:lnSpc>
+              <a:buNone/>
+            </a:pPr>
+            <a:r>
+              <a:rPr lang="en-US" sz="1450" b="1" dirty="0">
                 <a:solidFill>
                   <a:srgbClr val="0E1B3D"/>
                 </a:solidFill>
@@ -7012,7 +7021,7 @@
               </a:rPr>
               <a:t>認証の強化（MFA・特権管理）</a:t>
             </a:r>
-            <a:endParaRPr lang="en-US" sz="1550" dirty="0"/>
+            <a:endParaRPr lang="en-US" sz="1450" dirty="0"/>
           </a:p>
         </p:txBody>
       </p:sp>
@@ -7024,8 +7033,8 @@
         </p:nvSpPr>
         <p:spPr>
           <a:xfrm>
-            <a:off x="1527048" y="3813048"/>
-            <a:ext cx="4155948" cy="502920"/>
+            <a:off x="1527048" y="3849624"/>
+            <a:ext cx="4155948" cy="512064"/>
           </a:xfrm>
           <a:prstGeom prst="rect">
             <a:avLst/>
@@ -7039,12 +7048,12 @@
           <a:p>
             <a:pPr indent="0" marL="0">
               <a:lnSpc>
-                <a:spcPts val="1600"/>
+                <a:spcPts val="1500"/>
               </a:lnSpc>
               <a:buNone/>
             </a:pPr>
             <a:r>
-              <a:rPr lang="en-US" sz="1250" dirty="0">
+              <a:rPr lang="en-US" sz="1200" dirty="0">
                 <a:solidFill>
                   <a:srgbClr val="1A2332"/>
                 </a:solidFill>
@@ -7052,9 +7061,9 @@
                 <a:ea typeface="Calibri" pitchFamily="34" charset="-122"/>
                 <a:cs typeface="Calibri" pitchFamily="34" charset="-120"/>
               </a:rPr>
-              <a:t>盗まれた正規アカウントでの侵入を防ぐ。ADの保護を優先</a:t>
-            </a:r>
-            <a:endParaRPr lang="en-US" sz="1250" dirty="0"/>
+              <a:t>盗まれた正規アカウントでの侵入を防ぐ。委託先含め例外を作らない</a:t>
+            </a:r>
+            <a:endParaRPr lang="en-US" sz="1200" dirty="0"/>
           </a:p>
         </p:txBody>
       </p:sp>
@@ -7067,11 +7076,11 @@
         <p:spPr>
           <a:xfrm>
             <a:off x="6277356" y="3246120"/>
-            <a:ext cx="5344668" cy="1143000"/>
+            <a:ext cx="5344668" cy="1188720"/>
           </a:xfrm>
           <a:prstGeom prst="roundRect">
             <a:avLst>
-              <a:gd name="adj" fmla="val 6400"/>
+              <a:gd name="adj" fmla="val 6154"/>
             </a:avLst>
           </a:prstGeom>
           <a:solidFill>
@@ -7100,7 +7109,7 @@
         </p:nvSpPr>
         <p:spPr>
           <a:xfrm>
-            <a:off x="6505956" y="3529584"/>
+            <a:off x="6505956" y="3557016"/>
             <a:ext cx="566928" cy="566928"/>
           </a:xfrm>
           <a:prstGeom prst="ellipse">
@@ -7120,7 +7129,7 @@
         </p:nvSpPr>
         <p:spPr>
           <a:xfrm>
-            <a:off x="6505956" y="3529584"/>
+            <a:off x="6505956" y="3557016"/>
             <a:ext cx="566928" cy="566928"/>
           </a:xfrm>
           <a:prstGeom prst="rect">
@@ -7159,7 +7168,7 @@
         </p:nvSpPr>
         <p:spPr>
           <a:xfrm>
-            <a:off x="7237476" y="3392424"/>
+            <a:off x="7237476" y="3383280"/>
             <a:ext cx="4155948" cy="457200"/>
           </a:xfrm>
           <a:prstGeom prst="rect">
@@ -7173,10 +7182,13 @@
           <a:lstStyle/>
           <a:p>
             <a:pPr indent="0" marL="0">
-              <a:buNone/>
-            </a:pPr>
-            <a:r>
-              <a:rPr lang="en-US" sz="1550" b="1" dirty="0">
+              <a:lnSpc>
+                <a:spcPts val="1700"/>
+              </a:lnSpc>
+              <a:buNone/>
+            </a:pPr>
+            <a:r>
+              <a:rPr lang="en-US" sz="1450" b="1" dirty="0">
                 <a:solidFill>
                   <a:srgbClr val="0E1B3D"/>
                 </a:solidFill>
@@ -7184,9 +7196,9 @@
                 <a:ea typeface="Cambria" pitchFamily="34" charset="-122"/>
                 <a:cs typeface="Cambria" pitchFamily="34" charset="-120"/>
               </a:rPr>
-              <a:t>SentinelOneの堅牢化設定</a:t>
-            </a:r>
-            <a:endParaRPr lang="en-US" sz="1550" dirty="0"/>
+              <a:t>S-1のOnline Authorization有効化を確認</a:t>
+            </a:r>
+            <a:endParaRPr lang="en-US" sz="1450" dirty="0"/>
           </a:p>
         </p:txBody>
       </p:sp>
@@ -7198,8 +7210,8 @@
         </p:nvSpPr>
         <p:spPr>
           <a:xfrm>
-            <a:off x="7237476" y="3813048"/>
-            <a:ext cx="4155948" cy="502920"/>
+            <a:off x="7237476" y="3849624"/>
+            <a:ext cx="4155948" cy="512064"/>
           </a:xfrm>
           <a:prstGeom prst="rect">
             <a:avLst/>
@@ -7213,12 +7225,12 @@
           <a:p>
             <a:pPr indent="0" marL="0">
               <a:lnSpc>
-                <a:spcPts val="1600"/>
+                <a:spcPts val="1500"/>
               </a:lnSpc>
               <a:buNone/>
             </a:pPr>
             <a:r>
-              <a:rPr lang="en-US" sz="1250" dirty="0">
+              <a:rPr lang="en-US" sz="1200" dirty="0">
                 <a:solidFill>
                   <a:srgbClr val="1A2332"/>
                 </a:solidFill>
@@ -7226,9 +7238,9 @@
                 <a:ea typeface="Calibri" pitchFamily="34" charset="-122"/>
                 <a:cs typeface="Calibri" pitchFamily="34" charset="-120"/>
               </a:rPr>
-              <a:t>Online Authorization等で無効化・改ざん回避を難しくする</a:t>
-            </a:r>
-            <a:endParaRPr lang="en-US" sz="1250" dirty="0"/>
+              <a:t>既存導入は既定OFF。無効化・改ざん回避（BYOI等）を難しくする</a:t>
+            </a:r>
+            <a:endParaRPr lang="en-US" sz="1200" dirty="0"/>
           </a:p>
         </p:txBody>
       </p:sp>
@@ -7240,12 +7252,12 @@
         </p:nvSpPr>
         <p:spPr>
           <a:xfrm>
-            <a:off x="566928" y="4572000"/>
-            <a:ext cx="11055096" cy="1143000"/>
+            <a:off x="566928" y="4617720"/>
+            <a:ext cx="5344668" cy="1188720"/>
           </a:xfrm>
           <a:prstGeom prst="roundRect">
             <a:avLst>
-              <a:gd name="adj" fmla="val 6400"/>
+              <a:gd name="adj" fmla="val 6154"/>
             </a:avLst>
           </a:prstGeom>
           <a:solidFill>
@@ -7274,7 +7286,7 @@
         </p:nvSpPr>
         <p:spPr>
           <a:xfrm>
-            <a:off x="795528" y="4855464"/>
+            <a:off x="795528" y="4928616"/>
             <a:ext cx="566928" cy="566928"/>
           </a:xfrm>
           <a:prstGeom prst="ellipse">
@@ -7294,7 +7306,7 @@
         </p:nvSpPr>
         <p:spPr>
           <a:xfrm>
-            <a:off x="795528" y="4855464"/>
+            <a:off x="795528" y="4928616"/>
             <a:ext cx="566928" cy="566928"/>
           </a:xfrm>
           <a:prstGeom prst="rect">
@@ -7333,8 +7345,8 @@
         </p:nvSpPr>
         <p:spPr>
           <a:xfrm>
-            <a:off x="1527048" y="4718304"/>
-            <a:ext cx="9866376" cy="457200"/>
+            <a:off x="1527048" y="4754880"/>
+            <a:ext cx="4155948" cy="457200"/>
           </a:xfrm>
           <a:prstGeom prst="rect">
             <a:avLst/>
@@ -7347,10 +7359,13 @@
           <a:lstStyle/>
           <a:p>
             <a:pPr indent="0" marL="0">
-              <a:buNone/>
-            </a:pPr>
-            <a:r>
-              <a:rPr lang="en-US" sz="1550" b="1" dirty="0">
+              <a:lnSpc>
+                <a:spcPts val="1700"/>
+              </a:lnSpc>
+              <a:buNone/>
+            </a:pPr>
+            <a:r>
+              <a:rPr lang="en-US" sz="1450" b="1" dirty="0">
                 <a:solidFill>
                   <a:srgbClr val="0E1B3D"/>
                 </a:solidFill>
@@ -7358,9 +7373,9 @@
                 <a:ea typeface="Cambria" pitchFamily="34" charset="-122"/>
                 <a:cs typeface="Cambria" pitchFamily="34" charset="-120"/>
               </a:rPr>
-              <a:t>バックアップと復旧訓練</a:t>
-            </a:r>
-            <a:endParaRPr lang="en-US" sz="1550" dirty="0"/>
+              <a:t>認証情報のSQL保存方式を監査</a:t>
+            </a:r>
+            <a:endParaRPr lang="en-US" sz="1450" dirty="0"/>
           </a:p>
         </p:txBody>
       </p:sp>
@@ -7372,8 +7387,8 @@
         </p:nvSpPr>
         <p:spPr>
           <a:xfrm>
-            <a:off x="1527048" y="5138928"/>
-            <a:ext cx="9866376" cy="502920"/>
+            <a:off x="1527048" y="5221224"/>
+            <a:ext cx="4155948" cy="512064"/>
           </a:xfrm>
           <a:prstGeom prst="rect">
             <a:avLst/>
@@ -7387,12 +7402,12 @@
           <a:p>
             <a:pPr indent="0" marL="0">
               <a:lnSpc>
-                <a:spcPts val="1600"/>
+                <a:spcPts val="1500"/>
               </a:lnSpc>
               <a:buNone/>
             </a:pPr>
             <a:r>
-              <a:rPr lang="en-US" sz="1250" dirty="0">
+              <a:rPr lang="en-US" sz="1200" dirty="0">
                 <a:solidFill>
                   <a:srgbClr val="1A2332"/>
                 </a:solidFill>
@@ -7400,15 +7415,192 @@
                 <a:ea typeface="Calibri" pitchFamily="34" charset="-122"/>
                 <a:cs typeface="Calibri" pitchFamily="34" charset="-120"/>
               </a:rPr>
+              <a:t>ハッシュ/ソルトの有無、接続文字列・秘密情報の管理を点検</a:t>
+            </a:r>
+            <a:endParaRPr lang="en-US" sz="1200" dirty="0"/>
+          </a:p>
+        </p:txBody>
+      </p:sp>
+      <p:sp>
+        <p:nvSpPr>
+          <p:cNvPr id="29" name="Shape 27"/>
+          <p:cNvSpPr/>
+          <p:nvPr/>
+        </p:nvSpPr>
+        <p:spPr>
+          <a:xfrm>
+            <a:off x="6277356" y="4617720"/>
+            <a:ext cx="5344668" cy="1188720"/>
+          </a:xfrm>
+          <a:prstGeom prst="roundRect">
+            <a:avLst>
+              <a:gd name="adj" fmla="val 6154"/>
+            </a:avLst>
+          </a:prstGeom>
+          <a:solidFill>
+            <a:srgbClr val="F4F6FB"/>
+          </a:solidFill>
+          <a:ln w="12700">
+            <a:solidFill>
+              <a:srgbClr val="E2E8F4"/>
+            </a:solidFill>
+            <a:prstDash val="solid"/>
+          </a:ln>
+          <a:effectLst>
+            <a:outerShdw sx="100000" sy="100000" kx="0" ky="0" algn="bl" rotWithShape="0" blurRad="101600" dist="38100" dir="5400000">
+              <a:srgbClr val="8A93A6">
+                <a:alpha val="28000"/>
+              </a:srgbClr>
+            </a:outerShdw>
+          </a:effectLst>
+        </p:spPr>
+      </p:sp>
+      <p:sp>
+        <p:nvSpPr>
+          <p:cNvPr id="30" name="Shape 28"/>
+          <p:cNvSpPr/>
+          <p:nvPr/>
+        </p:nvSpPr>
+        <p:spPr>
+          <a:xfrm>
+            <a:off x="6505956" y="4928616"/>
+            <a:ext cx="566928" cy="566928"/>
+          </a:xfrm>
+          <a:prstGeom prst="ellipse">
+            <a:avLst/>
+          </a:prstGeom>
+          <a:solidFill>
+            <a:srgbClr val="C8102E"/>
+          </a:solidFill>
+          <a:ln/>
+        </p:spPr>
+      </p:sp>
+      <p:sp>
+        <p:nvSpPr>
+          <p:cNvPr id="31" name="Text 29"/>
+          <p:cNvSpPr/>
+          <p:nvPr/>
+        </p:nvSpPr>
+        <p:spPr>
+          <a:xfrm>
+            <a:off x="6505956" y="4928616"/>
+            <a:ext cx="566928" cy="566928"/>
+          </a:xfrm>
+          <a:prstGeom prst="rect">
+            <a:avLst/>
+          </a:prstGeom>
+          <a:noFill/>
+          <a:ln/>
+        </p:spPr>
+        <p:txBody>
+          <a:bodyPr wrap="square" lIns="0" tIns="0" rIns="0" bIns="0" rtlCol="0" anchor="ctr"/>
+          <a:lstStyle/>
+          <a:p>
+            <a:pPr algn="ctr" indent="0" marL="0">
+              <a:buNone/>
+            </a:pPr>
+            <a:r>
+              <a:rPr lang="en-US" sz="2200" b="1" dirty="0">
+                <a:solidFill>
+                  <a:srgbClr val="FFFFFF"/>
+                </a:solidFill>
+                <a:latin typeface="Cambria" pitchFamily="34" charset="0"/>
+                <a:ea typeface="Cambria" pitchFamily="34" charset="-122"/>
+                <a:cs typeface="Cambria" pitchFamily="34" charset="-120"/>
+              </a:rPr>
+              <a:t>6</a:t>
+            </a:r>
+            <a:endParaRPr lang="en-US" sz="2200" dirty="0"/>
+          </a:p>
+        </p:txBody>
+      </p:sp>
+      <p:sp>
+        <p:nvSpPr>
+          <p:cNvPr id="32" name="Text 30"/>
+          <p:cNvSpPr/>
+          <p:nvPr/>
+        </p:nvSpPr>
+        <p:spPr>
+          <a:xfrm>
+            <a:off x="7237476" y="4754880"/>
+            <a:ext cx="4155948" cy="457200"/>
+          </a:xfrm>
+          <a:prstGeom prst="rect">
+            <a:avLst/>
+          </a:prstGeom>
+          <a:noFill/>
+          <a:ln/>
+        </p:spPr>
+        <p:txBody>
+          <a:bodyPr wrap="square" lIns="0" tIns="0" rIns="0" bIns="0" rtlCol="0" anchor="t"/>
+          <a:lstStyle/>
+          <a:p>
+            <a:pPr indent="0" marL="0">
+              <a:lnSpc>
+                <a:spcPts val="1700"/>
+              </a:lnSpc>
+              <a:buNone/>
+            </a:pPr>
+            <a:r>
+              <a:rPr lang="en-US" sz="1450" b="1" dirty="0">
+                <a:solidFill>
+                  <a:srgbClr val="0E1B3D"/>
+                </a:solidFill>
+                <a:latin typeface="Cambria" pitchFamily="34" charset="0"/>
+                <a:ea typeface="Cambria" pitchFamily="34" charset="-122"/>
+                <a:cs typeface="Cambria" pitchFamily="34" charset="-120"/>
+              </a:rPr>
+              <a:t>バックアップと復旧訓練</a:t>
+            </a:r>
+            <a:endParaRPr lang="en-US" sz="1450" dirty="0"/>
+          </a:p>
+        </p:txBody>
+      </p:sp>
+      <p:sp>
+        <p:nvSpPr>
+          <p:cNvPr id="33" name="Text 31"/>
+          <p:cNvSpPr/>
+          <p:nvPr/>
+        </p:nvSpPr>
+        <p:spPr>
+          <a:xfrm>
+            <a:off x="7237476" y="5221224"/>
+            <a:ext cx="4155948" cy="512064"/>
+          </a:xfrm>
+          <a:prstGeom prst="rect">
+            <a:avLst/>
+          </a:prstGeom>
+          <a:noFill/>
+          <a:ln/>
+        </p:spPr>
+        <p:txBody>
+          <a:bodyPr wrap="square" lIns="0" tIns="0" rIns="0" bIns="0" rtlCol="0" anchor="t"/>
+          <a:lstStyle/>
+          <a:p>
+            <a:pPr indent="0" marL="0">
+              <a:lnSpc>
+                <a:spcPts val="1500"/>
+              </a:lnSpc>
+              <a:buNone/>
+            </a:pPr>
+            <a:r>
+              <a:rPr lang="en-US" sz="1200" dirty="0">
+                <a:solidFill>
+                  <a:srgbClr val="1A2332"/>
+                </a:solidFill>
+                <a:latin typeface="Calibri" pitchFamily="34" charset="0"/>
+                <a:ea typeface="Calibri" pitchFamily="34" charset="-122"/>
+                <a:cs typeface="Calibri" pitchFamily="34" charset="-120"/>
+              </a:rPr>
               <a:t>暗号化されても事業を止めない。オフライン保管と定期演習</a:t>
             </a:r>
-            <a:endParaRPr lang="en-US" sz="1250" dirty="0"/>
-          </a:p>
-        </p:txBody>
-      </p:sp>
-      <p:sp>
-        <p:nvSpPr>
-          <p:cNvPr id="29" name="Text 27"/>
+            <a:endParaRPr lang="en-US" sz="1200" dirty="0"/>
+          </a:p>
+        </p:txBody>
+      </p:sp>
+      <p:sp>
+        <p:nvSpPr>
+          <p:cNvPr id="34" name="Text 32"/>
           <p:cNvSpPr/>
           <p:nvPr/>
         </p:nvSpPr>

</xml_diff>

<commit_message>
Soften watermark to non-intrusive, background-aware light gray
- 透かしをコンテンツを阻害しない低コントラスト色に変更（白背景=淡グレー/濃紺背景=僅かに明るい紺）
- 背景色に応じて自動で色を選択するようbg()を調整
- memory/context.md を更新

Co-Authored-By: Claude Opus 4.8 <noreply@anthropic.com>
Claude-Session: https://claude.ai/code/session_01EA4xD6dzVHyb75mdD2BWfh
</commit_message>
<xml_diff>
--- a/成果物/SentinelOne導入後も脆弱性検査が必要な理由.pptx
+++ b/成果物/SentinelOne導入後も脆弱性検査が必要な理由.pptx
@@ -2393,8 +2393,8 @@
         </p:nvSpPr>
         <p:spPr>
           <a:xfrm rot="19800000">
-            <a:off x="822960" y="2331720"/>
-            <a:ext cx="10515600" cy="1920240"/>
+            <a:off x="822960" y="2377440"/>
+            <a:ext cx="10515600" cy="1828800"/>
           </a:xfrm>
           <a:prstGeom prst="rect">
             <a:avLst/>
@@ -2410,9 +2410,9 @@
               <a:buNone/>
             </a:pPr>
             <a:r>
-              <a:rPr lang="en-US" sz="5200" b="1" dirty="0">
-                <a:solidFill>
-                  <a:srgbClr val="D3D9E3"/>
+              <a:rPr lang="en-US" sz="5000" b="1" dirty="0">
+                <a:solidFill>
+                  <a:srgbClr val="223257"/>
                 </a:solidFill>
                 <a:latin typeface="Cambria" pitchFamily="34" charset="0"/>
                 <a:ea typeface="Cambria" pitchFamily="34" charset="-122"/>
@@ -2420,7 +2420,7 @@
               </a:rPr>
               <a:t>CONFIDENTIAL ｜ 社外秘</a:t>
             </a:r>
-            <a:endParaRPr lang="en-US" sz="5200" dirty="0"/>
+            <a:endParaRPr lang="en-US" sz="5000" dirty="0"/>
           </a:p>
         </p:txBody>
       </p:sp>
@@ -2749,8 +2749,8 @@
         </p:nvSpPr>
         <p:spPr>
           <a:xfrm rot="19800000">
-            <a:off x="822960" y="2331720"/>
-            <a:ext cx="10515600" cy="1920240"/>
+            <a:off x="822960" y="2377440"/>
+            <a:ext cx="10515600" cy="1828800"/>
           </a:xfrm>
           <a:prstGeom prst="rect">
             <a:avLst/>
@@ -2766,9 +2766,9 @@
               <a:buNone/>
             </a:pPr>
             <a:r>
-              <a:rPr lang="en-US" sz="5200" b="1" dirty="0">
-                <a:solidFill>
-                  <a:srgbClr val="D3D9E3"/>
+              <a:rPr lang="en-US" sz="5000" b="1" dirty="0">
+                <a:solidFill>
+                  <a:srgbClr val="EBEEF3"/>
                 </a:solidFill>
                 <a:latin typeface="Cambria" pitchFamily="34" charset="0"/>
                 <a:ea typeface="Cambria" pitchFamily="34" charset="-122"/>
@@ -2776,7 +2776,7 @@
               </a:rPr>
               <a:t>CONFIDENTIAL ｜ 社外秘</a:t>
             </a:r>
-            <a:endParaRPr lang="en-US" sz="5200" dirty="0"/>
+            <a:endParaRPr lang="en-US" sz="5000" dirty="0"/>
           </a:p>
         </p:txBody>
       </p:sp>
@@ -4692,8 +4692,8 @@
         </p:nvSpPr>
         <p:spPr>
           <a:xfrm rot="19800000">
-            <a:off x="822960" y="2331720"/>
-            <a:ext cx="10515600" cy="1920240"/>
+            <a:off x="822960" y="2377440"/>
+            <a:ext cx="10515600" cy="1828800"/>
           </a:xfrm>
           <a:prstGeom prst="rect">
             <a:avLst/>
@@ -4709,9 +4709,9 @@
               <a:buNone/>
             </a:pPr>
             <a:r>
-              <a:rPr lang="en-US" sz="5200" b="1" dirty="0">
-                <a:solidFill>
-                  <a:srgbClr val="D3D9E3"/>
+              <a:rPr lang="en-US" sz="5000" b="1" dirty="0">
+                <a:solidFill>
+                  <a:srgbClr val="EBEEF3"/>
                 </a:solidFill>
                 <a:latin typeface="Cambria" pitchFamily="34" charset="0"/>
                 <a:ea typeface="Cambria" pitchFamily="34" charset="-122"/>
@@ -4719,7 +4719,7 @@
               </a:rPr>
               <a:t>CONFIDENTIAL ｜ 社外秘</a:t>
             </a:r>
-            <a:endParaRPr lang="en-US" sz="5200" dirty="0"/>
+            <a:endParaRPr lang="en-US" sz="5000" dirty="0"/>
           </a:p>
         </p:txBody>
       </p:sp>
@@ -5879,8 +5879,8 @@
         </p:nvSpPr>
         <p:spPr>
           <a:xfrm rot="19800000">
-            <a:off x="822960" y="2331720"/>
-            <a:ext cx="10515600" cy="1920240"/>
+            <a:off x="822960" y="2377440"/>
+            <a:ext cx="10515600" cy="1828800"/>
           </a:xfrm>
           <a:prstGeom prst="rect">
             <a:avLst/>
@@ -5896,9 +5896,9 @@
               <a:buNone/>
             </a:pPr>
             <a:r>
-              <a:rPr lang="en-US" sz="5200" b="1" dirty="0">
-                <a:solidFill>
-                  <a:srgbClr val="D3D9E3"/>
+              <a:rPr lang="en-US" sz="5000" b="1" dirty="0">
+                <a:solidFill>
+                  <a:srgbClr val="EBEEF3"/>
                 </a:solidFill>
                 <a:latin typeface="Cambria" pitchFamily="34" charset="0"/>
                 <a:ea typeface="Cambria" pitchFamily="34" charset="-122"/>
@@ -5906,7 +5906,7 @@
               </a:rPr>
               <a:t>CONFIDENTIAL ｜ 社外秘</a:t>
             </a:r>
-            <a:endParaRPr lang="en-US" sz="5200" dirty="0"/>
+            <a:endParaRPr lang="en-US" sz="5000" dirty="0"/>
           </a:p>
         </p:txBody>
       </p:sp>
@@ -6778,8 +6778,8 @@
         </p:nvSpPr>
         <p:spPr>
           <a:xfrm rot="19800000">
-            <a:off x="822960" y="2331720"/>
-            <a:ext cx="10515600" cy="1920240"/>
+            <a:off x="822960" y="2377440"/>
+            <a:ext cx="10515600" cy="1828800"/>
           </a:xfrm>
           <a:prstGeom prst="rect">
             <a:avLst/>
@@ -6795,9 +6795,9 @@
               <a:buNone/>
             </a:pPr>
             <a:r>
-              <a:rPr lang="en-US" sz="5200" b="1" dirty="0">
-                <a:solidFill>
-                  <a:srgbClr val="D3D9E3"/>
+              <a:rPr lang="en-US" sz="5000" b="1" dirty="0">
+                <a:solidFill>
+                  <a:srgbClr val="EBEEF3"/>
                 </a:solidFill>
                 <a:latin typeface="Cambria" pitchFamily="34" charset="0"/>
                 <a:ea typeface="Cambria" pitchFamily="34" charset="-122"/>
@@ -6805,7 +6805,7 @@
               </a:rPr>
               <a:t>CONFIDENTIAL ｜ 社外秘</a:t>
             </a:r>
-            <a:endParaRPr lang="en-US" sz="5200" dirty="0"/>
+            <a:endParaRPr lang="en-US" sz="5000" dirty="0"/>
           </a:p>
         </p:txBody>
       </p:sp>
@@ -8067,8 +8067,8 @@
         </p:nvSpPr>
         <p:spPr>
           <a:xfrm rot="19800000">
-            <a:off x="822960" y="2331720"/>
-            <a:ext cx="10515600" cy="1920240"/>
+            <a:off x="822960" y="2377440"/>
+            <a:ext cx="10515600" cy="1828800"/>
           </a:xfrm>
           <a:prstGeom prst="rect">
             <a:avLst/>
@@ -8084,9 +8084,9 @@
               <a:buNone/>
             </a:pPr>
             <a:r>
-              <a:rPr lang="en-US" sz="5200" b="1" dirty="0">
-                <a:solidFill>
-                  <a:srgbClr val="D3D9E3"/>
+              <a:rPr lang="en-US" sz="5000" b="1" dirty="0">
+                <a:solidFill>
+                  <a:srgbClr val="223257"/>
                 </a:solidFill>
                 <a:latin typeface="Cambria" pitchFamily="34" charset="0"/>
                 <a:ea typeface="Cambria" pitchFamily="34" charset="-122"/>
@@ -8094,7 +8094,7 @@
               </a:rPr>
               <a:t>CONFIDENTIAL ｜ 社外秘</a:t>
             </a:r>
-            <a:endParaRPr lang="en-US" sz="5200" dirty="0"/>
+            <a:endParaRPr lang="en-US" sz="5000" dirty="0"/>
           </a:p>
         </p:txBody>
       </p:sp>
@@ -8498,8 +8498,8 @@
         </p:nvSpPr>
         <p:spPr>
           <a:xfrm rot="19800000">
-            <a:off x="822960" y="2331720"/>
-            <a:ext cx="10515600" cy="1920240"/>
+            <a:off x="822960" y="2377440"/>
+            <a:ext cx="10515600" cy="1828800"/>
           </a:xfrm>
           <a:prstGeom prst="rect">
             <a:avLst/>
@@ -8515,9 +8515,9 @@
               <a:buNone/>
             </a:pPr>
             <a:r>
-              <a:rPr lang="en-US" sz="5200" b="1" dirty="0">
-                <a:solidFill>
-                  <a:srgbClr val="D3D9E3"/>
+              <a:rPr lang="en-US" sz="5000" b="1" dirty="0">
+                <a:solidFill>
+                  <a:srgbClr val="EBEEF3"/>
                 </a:solidFill>
                 <a:latin typeface="Cambria" pitchFamily="34" charset="0"/>
                 <a:ea typeface="Cambria" pitchFamily="34" charset="-122"/>
@@ -8525,7 +8525,7 @@
               </a:rPr>
               <a:t>CONFIDENTIAL ｜ 社外秘</a:t>
             </a:r>
-            <a:endParaRPr lang="en-US" sz="5200" dirty="0"/>
+            <a:endParaRPr lang="en-US" sz="5000" dirty="0"/>
           </a:p>
         </p:txBody>
       </p:sp>
@@ -8954,8 +8954,8 @@
         </p:nvSpPr>
         <p:spPr>
           <a:xfrm rot="19800000">
-            <a:off x="822960" y="2331720"/>
-            <a:ext cx="10515600" cy="1920240"/>
+            <a:off x="822960" y="2377440"/>
+            <a:ext cx="10515600" cy="1828800"/>
           </a:xfrm>
           <a:prstGeom prst="rect">
             <a:avLst/>
@@ -8971,9 +8971,9 @@
               <a:buNone/>
             </a:pPr>
             <a:r>
-              <a:rPr lang="en-US" sz="5200" b="1" dirty="0">
-                <a:solidFill>
-                  <a:srgbClr val="D3D9E3"/>
+              <a:rPr lang="en-US" sz="5000" b="1" dirty="0">
+                <a:solidFill>
+                  <a:srgbClr val="EBEEF3"/>
                 </a:solidFill>
                 <a:latin typeface="Cambria" pitchFamily="34" charset="0"/>
                 <a:ea typeface="Cambria" pitchFamily="34" charset="-122"/>
@@ -8981,7 +8981,7 @@
               </a:rPr>
               <a:t>CONFIDENTIAL ｜ 社外秘</a:t>
             </a:r>
-            <a:endParaRPr lang="en-US" sz="5200" dirty="0"/>
+            <a:endParaRPr lang="en-US" sz="5000" dirty="0"/>
           </a:p>
         </p:txBody>
       </p:sp>
@@ -9643,8 +9643,8 @@
         </p:nvSpPr>
         <p:spPr>
           <a:xfrm rot="19800000">
-            <a:off x="822960" y="2331720"/>
-            <a:ext cx="10515600" cy="1920240"/>
+            <a:off x="822960" y="2377440"/>
+            <a:ext cx="10515600" cy="1828800"/>
           </a:xfrm>
           <a:prstGeom prst="rect">
             <a:avLst/>
@@ -9660,9 +9660,9 @@
               <a:buNone/>
             </a:pPr>
             <a:r>
-              <a:rPr lang="en-US" sz="5200" b="1" dirty="0">
-                <a:solidFill>
-                  <a:srgbClr val="D3D9E3"/>
+              <a:rPr lang="en-US" sz="5000" b="1" dirty="0">
+                <a:solidFill>
+                  <a:srgbClr val="EBEEF3"/>
                 </a:solidFill>
                 <a:latin typeface="Cambria" pitchFamily="34" charset="0"/>
                 <a:ea typeface="Cambria" pitchFamily="34" charset="-122"/>
@@ -9670,7 +9670,7 @@
               </a:rPr>
               <a:t>CONFIDENTIAL ｜ 社外秘</a:t>
             </a:r>
-            <a:endParaRPr lang="en-US" sz="5200" dirty="0"/>
+            <a:endParaRPr lang="en-US" sz="5000" dirty="0"/>
           </a:p>
         </p:txBody>
       </p:sp>
@@ -10238,8 +10238,8 @@
         </p:nvSpPr>
         <p:spPr>
           <a:xfrm rot="19800000">
-            <a:off x="822960" y="2331720"/>
-            <a:ext cx="10515600" cy="1920240"/>
+            <a:off x="822960" y="2377440"/>
+            <a:ext cx="10515600" cy="1828800"/>
           </a:xfrm>
           <a:prstGeom prst="rect">
             <a:avLst/>
@@ -10255,9 +10255,9 @@
               <a:buNone/>
             </a:pPr>
             <a:r>
-              <a:rPr lang="en-US" sz="5200" b="1" dirty="0">
-                <a:solidFill>
-                  <a:srgbClr val="D3D9E3"/>
+              <a:rPr lang="en-US" sz="5000" b="1" dirty="0">
+                <a:solidFill>
+                  <a:srgbClr val="EBEEF3"/>
                 </a:solidFill>
                 <a:latin typeface="Cambria" pitchFamily="34" charset="0"/>
                 <a:ea typeface="Cambria" pitchFamily="34" charset="-122"/>
@@ -10265,7 +10265,7 @@
               </a:rPr>
               <a:t>CONFIDENTIAL ｜ 社外秘</a:t>
             </a:r>
-            <a:endParaRPr lang="en-US" sz="5200" dirty="0"/>
+            <a:endParaRPr lang="en-US" sz="5000" dirty="0"/>
           </a:p>
         </p:txBody>
       </p:sp>
@@ -11438,8 +11438,8 @@
         </p:nvSpPr>
         <p:spPr>
           <a:xfrm rot="19800000">
-            <a:off x="822960" y="2331720"/>
-            <a:ext cx="10515600" cy="1920240"/>
+            <a:off x="822960" y="2377440"/>
+            <a:ext cx="10515600" cy="1828800"/>
           </a:xfrm>
           <a:prstGeom prst="rect">
             <a:avLst/>
@@ -11455,9 +11455,9 @@
               <a:buNone/>
             </a:pPr>
             <a:r>
-              <a:rPr lang="en-US" sz="5200" b="1" dirty="0">
-                <a:solidFill>
-                  <a:srgbClr val="D3D9E3"/>
+              <a:rPr lang="en-US" sz="5000" b="1" dirty="0">
+                <a:solidFill>
+                  <a:srgbClr val="EBEEF3"/>
                 </a:solidFill>
                 <a:latin typeface="Cambria" pitchFamily="34" charset="0"/>
                 <a:ea typeface="Cambria" pitchFamily="34" charset="-122"/>
@@ -11465,7 +11465,7 @@
               </a:rPr>
               <a:t>CONFIDENTIAL ｜ 社外秘</a:t>
             </a:r>
-            <a:endParaRPr lang="en-US" sz="5200" dirty="0"/>
+            <a:endParaRPr lang="en-US" sz="5000" dirty="0"/>
           </a:p>
         </p:txBody>
       </p:sp>
@@ -12109,8 +12109,8 @@
         </p:nvSpPr>
         <p:spPr>
           <a:xfrm rot="19800000">
-            <a:off x="822960" y="2331720"/>
-            <a:ext cx="10515600" cy="1920240"/>
+            <a:off x="822960" y="2377440"/>
+            <a:ext cx="10515600" cy="1828800"/>
           </a:xfrm>
           <a:prstGeom prst="rect">
             <a:avLst/>
@@ -12126,9 +12126,9 @@
               <a:buNone/>
             </a:pPr>
             <a:r>
-              <a:rPr lang="en-US" sz="5200" b="1" dirty="0">
-                <a:solidFill>
-                  <a:srgbClr val="D3D9E3"/>
+              <a:rPr lang="en-US" sz="5000" b="1" dirty="0">
+                <a:solidFill>
+                  <a:srgbClr val="EBEEF3"/>
                 </a:solidFill>
                 <a:latin typeface="Cambria" pitchFamily="34" charset="0"/>
                 <a:ea typeface="Cambria" pitchFamily="34" charset="-122"/>
@@ -12136,7 +12136,7 @@
               </a:rPr>
               <a:t>CONFIDENTIAL ｜ 社外秘</a:t>
             </a:r>
-            <a:endParaRPr lang="en-US" sz="5200" dirty="0"/>
+            <a:endParaRPr lang="en-US" sz="5000" dirty="0"/>
           </a:p>
         </p:txBody>
       </p:sp>
@@ -12704,8 +12704,8 @@
         </p:nvSpPr>
         <p:spPr>
           <a:xfrm rot="19800000">
-            <a:off x="822960" y="2331720"/>
-            <a:ext cx="10515600" cy="1920240"/>
+            <a:off x="822960" y="2377440"/>
+            <a:ext cx="10515600" cy="1828800"/>
           </a:xfrm>
           <a:prstGeom prst="rect">
             <a:avLst/>
@@ -12721,9 +12721,9 @@
               <a:buNone/>
             </a:pPr>
             <a:r>
-              <a:rPr lang="en-US" sz="5200" b="1" dirty="0">
-                <a:solidFill>
-                  <a:srgbClr val="D3D9E3"/>
+              <a:rPr lang="en-US" sz="5000" b="1" dirty="0">
+                <a:solidFill>
+                  <a:srgbClr val="223257"/>
                 </a:solidFill>
                 <a:latin typeface="Cambria" pitchFamily="34" charset="0"/>
                 <a:ea typeface="Cambria" pitchFamily="34" charset="-122"/>
@@ -12731,7 +12731,7 @@
               </a:rPr>
               <a:t>CONFIDENTIAL ｜ 社外秘</a:t>
             </a:r>
-            <a:endParaRPr lang="en-US" sz="5200" dirty="0"/>
+            <a:endParaRPr lang="en-US" sz="5000" dirty="0"/>
           </a:p>
         </p:txBody>
       </p:sp>
@@ -13390,8 +13390,8 @@
         </p:nvSpPr>
         <p:spPr>
           <a:xfrm rot="19800000">
-            <a:off x="822960" y="2331720"/>
-            <a:ext cx="10515600" cy="1920240"/>
+            <a:off x="822960" y="2377440"/>
+            <a:ext cx="10515600" cy="1828800"/>
           </a:xfrm>
           <a:prstGeom prst="rect">
             <a:avLst/>
@@ -13407,9 +13407,9 @@
               <a:buNone/>
             </a:pPr>
             <a:r>
-              <a:rPr lang="en-US" sz="5200" b="1" dirty="0">
-                <a:solidFill>
-                  <a:srgbClr val="D3D9E3"/>
+              <a:rPr lang="en-US" sz="5000" b="1" dirty="0">
+                <a:solidFill>
+                  <a:srgbClr val="EBEEF3"/>
                 </a:solidFill>
                 <a:latin typeface="Cambria" pitchFamily="34" charset="0"/>
                 <a:ea typeface="Cambria" pitchFamily="34" charset="-122"/>
@@ -13417,7 +13417,7 @@
               </a:rPr>
               <a:t>CONFIDENTIAL ｜ 社外秘</a:t>
             </a:r>
-            <a:endParaRPr lang="en-US" sz="5200" dirty="0"/>
+            <a:endParaRPr lang="en-US" sz="5000" dirty="0"/>
           </a:p>
         </p:txBody>
       </p:sp>
@@ -14495,8 +14495,8 @@
         </p:nvSpPr>
         <p:spPr>
           <a:xfrm rot="19800000">
-            <a:off x="822960" y="2331720"/>
-            <a:ext cx="10515600" cy="1920240"/>
+            <a:off x="822960" y="2377440"/>
+            <a:ext cx="10515600" cy="1828800"/>
           </a:xfrm>
           <a:prstGeom prst="rect">
             <a:avLst/>
@@ -14512,9 +14512,9 @@
               <a:buNone/>
             </a:pPr>
             <a:r>
-              <a:rPr lang="en-US" sz="5200" b="1" dirty="0">
-                <a:solidFill>
-                  <a:srgbClr val="D3D9E3"/>
+              <a:rPr lang="en-US" sz="5000" b="1" dirty="0">
+                <a:solidFill>
+                  <a:srgbClr val="EBEEF3"/>
                 </a:solidFill>
                 <a:latin typeface="Cambria" pitchFamily="34" charset="0"/>
                 <a:ea typeface="Cambria" pitchFamily="34" charset="-122"/>
@@ -14522,7 +14522,7 @@
               </a:rPr>
               <a:t>CONFIDENTIAL ｜ 社外秘</a:t>
             </a:r>
-            <a:endParaRPr lang="en-US" sz="5200" dirty="0"/>
+            <a:endParaRPr lang="en-US" sz="5000" dirty="0"/>
           </a:p>
         </p:txBody>
       </p:sp>

</xml_diff>